<commit_message>
More work on the poster
</commit_message>
<xml_diff>
--- a/RCOS Poster Fall 24.pptx
+++ b/RCOS Poster Fall 24.pptx
@@ -5750,7 +5750,7 @@
             <a:tbl>
               <a:tblPr bandRow="1" firstRow="1">
                 <a:noFill/>
-                <a:tableStyleId>{221DDE7E-DA77-4664-8EEF-9E0650C0446A}</a:tableStyleId>
+                <a:tableStyleId>{8598BC43-226E-47E2-BF5D-7E1E38377976}</a:tableStyleId>
               </a:tblPr>
               <a:tblGrid>
                 <a:gridCol w="4192250"/>
@@ -7279,7 +7279,7 @@
             <a:tbl>
               <a:tblPr bandRow="1" firstRow="1">
                 <a:noFill/>
-                <a:tableStyleId>{221DDE7E-DA77-4664-8EEF-9E0650C0446A}</a:tableStyleId>
+                <a:tableStyleId>{8598BC43-226E-47E2-BF5D-7E1E38377976}</a:tableStyleId>
               </a:tblPr>
               <a:tblGrid>
                 <a:gridCol w="3343825"/>
@@ -9697,7 +9697,7 @@
         <p:spPr>
           <a:xfrm>
             <a:off x="11808086" y="6530881"/>
-            <a:ext cx="10048800" cy="5079300"/>
+            <a:ext cx="10048800" cy="8665800"/>
           </a:xfrm>
           <a:prstGeom prst="rect">
             <a:avLst/>
@@ -9713,7 +9713,7 @@
           </a:bodyPr>
           <a:lstStyle/>
           <a:p>
-            <a:pPr indent="-419100" lvl="0" marL="457200" rtl="0" algn="l">
+            <a:pPr indent="-488950" lvl="0" marL="457200" rtl="0" algn="l">
               <a:lnSpc>
                 <a:spcPct val="150000"/>
               </a:lnSpc>
@@ -9726,12 +9726,12 @@
               <a:buClr>
                 <a:schemeClr val="lt1"/>
               </a:buClr>
-              <a:buSzPts val="3000"/>
+              <a:buSzPts val="4100"/>
               <a:buFont typeface="Helvetica Neue"/>
               <a:buChar char="●"/>
             </a:pPr>
             <a:r>
-              <a:rPr lang="en-US" sz="3000">
+              <a:rPr lang="en-US" sz="4100">
                 <a:solidFill>
                   <a:schemeClr val="lt1"/>
                 </a:solidFill>
@@ -9742,7 +9742,7 @@
               </a:rPr>
               <a:t>Provide students with a resource to quickly and easily test code anywhere, anytime</a:t>
             </a:r>
-            <a:endParaRPr sz="3000">
+            <a:endParaRPr sz="4100">
               <a:solidFill>
                 <a:schemeClr val="lt1"/>
               </a:solidFill>
@@ -9753,7 +9753,7 @@
             </a:endParaRPr>
           </a:p>
           <a:p>
-            <a:pPr indent="-419100" lvl="0" marL="457200" rtl="0" algn="l">
+            <a:pPr indent="-488950" lvl="0" marL="457200" rtl="0" algn="l">
               <a:lnSpc>
                 <a:spcPct val="150000"/>
               </a:lnSpc>
@@ -9766,12 +9766,12 @@
               <a:buClr>
                 <a:schemeClr val="lt1"/>
               </a:buClr>
-              <a:buSzPts val="3000"/>
+              <a:buSzPts val="4100"/>
               <a:buFont typeface="Helvetica Neue"/>
               <a:buChar char="●"/>
             </a:pPr>
             <a:r>
-              <a:rPr lang="en-US" sz="3000">
+              <a:rPr lang="en-US" sz="4100">
                 <a:solidFill>
                   <a:schemeClr val="lt1"/>
                 </a:solidFill>
@@ -9782,7 +9782,7 @@
               </a:rPr>
               <a:t>Create a user friendly and functional UI</a:t>
             </a:r>
-            <a:endParaRPr sz="3000">
+            <a:endParaRPr sz="4100">
               <a:solidFill>
                 <a:schemeClr val="lt1"/>
               </a:solidFill>
@@ -9793,7 +9793,7 @@
             </a:endParaRPr>
           </a:p>
           <a:p>
-            <a:pPr indent="-419100" lvl="0" marL="457200" rtl="0" algn="l">
+            <a:pPr indent="-488950" lvl="0" marL="457200" rtl="0" algn="l">
               <a:lnSpc>
                 <a:spcPct val="150000"/>
               </a:lnSpc>
@@ -9806,12 +9806,12 @@
               <a:buClr>
                 <a:schemeClr val="lt1"/>
               </a:buClr>
-              <a:buSzPts val="3000"/>
+              <a:buSzPts val="4100"/>
               <a:buFont typeface="Helvetica Neue"/>
               <a:buChar char="●"/>
             </a:pPr>
             <a:r>
-              <a:rPr lang="en-US" sz="3000">
+              <a:rPr lang="en-US" sz="4100">
                 <a:solidFill>
                   <a:schemeClr val="lt1"/>
                 </a:solidFill>
@@ -9822,7 +9822,7 @@
               </a:rPr>
               <a:t>Encourage students to develop better testing habits</a:t>
             </a:r>
-            <a:endParaRPr sz="3000">
+            <a:endParaRPr sz="4100">
               <a:solidFill>
                 <a:schemeClr val="lt1"/>
               </a:solidFill>
@@ -9833,7 +9833,7 @@
             </a:endParaRPr>
           </a:p>
           <a:p>
-            <a:pPr indent="-419100" lvl="0" marL="457200" rtl="0" algn="l">
+            <a:pPr indent="-488950" lvl="0" marL="457200" rtl="0" algn="l">
               <a:lnSpc>
                 <a:spcPct val="150000"/>
               </a:lnSpc>
@@ -9846,12 +9846,12 @@
               <a:buClr>
                 <a:schemeClr val="lt1"/>
               </a:buClr>
-              <a:buSzPts val="3000"/>
+              <a:buSzPts val="4100"/>
               <a:buFont typeface="Helvetica Neue"/>
               <a:buChar char="●"/>
             </a:pPr>
             <a:r>
-              <a:rPr lang="en-US" sz="3000">
+              <a:rPr lang="en-US" sz="4100">
                 <a:solidFill>
                   <a:schemeClr val="lt1"/>
                 </a:solidFill>
@@ -9862,7 +9862,7 @@
               </a:rPr>
               <a:t>Relieve stress off Submitty servers</a:t>
             </a:r>
-            <a:endParaRPr sz="3000">
+            <a:endParaRPr sz="4100">
               <a:solidFill>
                 <a:schemeClr val="lt1"/>
               </a:solidFill>
@@ -9873,7 +9873,7 @@
             </a:endParaRPr>
           </a:p>
           <a:p>
-            <a:pPr indent="-419100" lvl="0" marL="457200" rtl="0" algn="l">
+            <a:pPr indent="-488950" lvl="0" marL="457200" rtl="0" algn="l">
               <a:lnSpc>
                 <a:spcPct val="150000"/>
               </a:lnSpc>
@@ -9886,12 +9886,12 @@
               <a:buClr>
                 <a:schemeClr val="lt1"/>
               </a:buClr>
-              <a:buSzPts val="3000"/>
+              <a:buSzPts val="4100"/>
               <a:buFont typeface="Helvetica Neue"/>
               <a:buChar char="●"/>
             </a:pPr>
             <a:r>
-              <a:rPr lang="en-US" sz="3000">
+              <a:rPr lang="en-US" sz="4100">
                 <a:solidFill>
                   <a:schemeClr val="lt1"/>
                 </a:solidFill>
@@ -9900,9 +9900,9 @@
                 <a:cs typeface="Helvetica Neue"/>
                 <a:sym typeface="Helvetica Neue"/>
               </a:rPr>
-              <a:t>Apply the skills we’ve learned to create a useful product</a:t>
+              <a:t>Apply the skills we’ve learned in classes to create a useful product!</a:t>
             </a:r>
-            <a:endParaRPr sz="3000">
+            <a:endParaRPr sz="4100">
               <a:solidFill>
                 <a:schemeClr val="lt1"/>
               </a:solidFill>
@@ -9925,7 +9925,7 @@
         <p:spPr>
           <a:xfrm>
             <a:off x="459675" y="6378476"/>
-            <a:ext cx="10056900" cy="12075300"/>
+            <a:ext cx="10056900" cy="13154400"/>
           </a:xfrm>
           <a:prstGeom prst="rect">
             <a:avLst/>
@@ -9941,7 +9941,7 @@
           </a:bodyPr>
           <a:lstStyle/>
           <a:p>
-            <a:pPr indent="-419100" lvl="0" marL="457200" rtl="0" algn="l">
+            <a:pPr indent="-469900" lvl="0" marL="457200" rtl="0" algn="l">
               <a:lnSpc>
                 <a:spcPct val="115000"/>
               </a:lnSpc>
@@ -9954,12 +9954,12 @@
               <a:buClr>
                 <a:schemeClr val="lt1"/>
               </a:buClr>
-              <a:buSzPts val="3000"/>
+              <a:buSzPts val="3800"/>
               <a:buFont typeface="Helvetica Neue"/>
               <a:buChar char="●"/>
             </a:pPr>
             <a:r>
-              <a:rPr lang="en-US" sz="3000">
+              <a:rPr lang="en-US" sz="3800">
                 <a:solidFill>
                   <a:schemeClr val="lt1"/>
                 </a:solidFill>
@@ -9968,9 +9968,9 @@
                 <a:cs typeface="Helvetica Neue"/>
                 <a:sym typeface="Helvetica Neue"/>
               </a:rPr>
-              <a:t>SIFT or Submitty Instant Feedback and Testing is a standalone app that enables students to autograde their Submitty coding homework assignments without having to rely on Submitty</a:t>
+              <a:t>Standalone app</a:t>
             </a:r>
-            <a:endParaRPr sz="3000">
+            <a:endParaRPr sz="3800">
               <a:solidFill>
                 <a:schemeClr val="lt1"/>
               </a:solidFill>
@@ -9981,7 +9981,7 @@
             </a:endParaRPr>
           </a:p>
           <a:p>
-            <a:pPr indent="-419100" lvl="0" marL="457200" rtl="0" algn="l">
+            <a:pPr indent="-469900" lvl="1" marL="914400" rtl="0" algn="l">
               <a:lnSpc>
                 <a:spcPct val="115000"/>
               </a:lnSpc>
@@ -9994,12 +9994,12 @@
               <a:buClr>
                 <a:schemeClr val="lt1"/>
               </a:buClr>
-              <a:buSzPts val="3000"/>
+              <a:buSzPts val="3800"/>
               <a:buFont typeface="Helvetica Neue"/>
-              <a:buChar char="●"/>
+              <a:buChar char="○"/>
             </a:pPr>
             <a:r>
-              <a:rPr lang="en-US" sz="3000">
+              <a:rPr lang="en-US" sz="3800">
                 <a:solidFill>
                   <a:schemeClr val="lt1"/>
                 </a:solidFill>
@@ -10008,9 +10008,9 @@
                 <a:cs typeface="Helvetica Neue"/>
                 <a:sym typeface="Helvetica Neue"/>
               </a:rPr>
-              <a:t>Oftentimes, working with the Submitty autograder to test and find problems in code can be cumbersome, requiring the user to upload all their files, wait for the servers to process and run them, and then getting your output, all while using up a precious submission</a:t>
+              <a:t>Students can get feedback on homework without having to rely on Submitty</a:t>
             </a:r>
-            <a:endParaRPr sz="3000">
+            <a:endParaRPr sz="3800">
               <a:solidFill>
                 <a:schemeClr val="lt1"/>
               </a:solidFill>
@@ -10021,7 +10021,7 @@
             </a:endParaRPr>
           </a:p>
           <a:p>
-            <a:pPr indent="-419100" lvl="0" marL="457200" rtl="0" algn="l">
+            <a:pPr indent="-469900" lvl="0" marL="457200" rtl="0" algn="l">
               <a:lnSpc>
                 <a:spcPct val="115000"/>
               </a:lnSpc>
@@ -10034,12 +10034,12 @@
               <a:buClr>
                 <a:schemeClr val="lt1"/>
               </a:buClr>
-              <a:buSzPts val="3000"/>
+              <a:buSzPts val="3800"/>
               <a:buFont typeface="Helvetica Neue"/>
               <a:buChar char="●"/>
             </a:pPr>
             <a:r>
-              <a:rPr lang="en-US" sz="3000">
+              <a:rPr lang="en-US" sz="3800">
                 <a:solidFill>
                   <a:schemeClr val="lt1"/>
                 </a:solidFill>
@@ -10048,9 +10048,9 @@
                 <a:cs typeface="Helvetica Neue"/>
                 <a:sym typeface="Helvetica Neue"/>
               </a:rPr>
-              <a:t>SIFT aims to fix this by giving students the tools to get their homeworks graded on their own computers.</a:t>
+              <a:t>Using the Submitty autograder to test and find problems in code can be cumbersome</a:t>
             </a:r>
-            <a:endParaRPr sz="3000">
+            <a:endParaRPr sz="3800">
               <a:solidFill>
                 <a:schemeClr val="lt1"/>
               </a:solidFill>
@@ -10061,7 +10061,7 @@
             </a:endParaRPr>
           </a:p>
           <a:p>
-            <a:pPr indent="-419100" lvl="1" marL="914400" rtl="0" algn="l">
+            <a:pPr indent="-469900" lvl="1" marL="914400" rtl="0" algn="l">
               <a:lnSpc>
                 <a:spcPct val="115000"/>
               </a:lnSpc>
@@ -10074,12 +10074,12 @@
               <a:buClr>
                 <a:schemeClr val="lt1"/>
               </a:buClr>
-              <a:buSzPts val="3000"/>
+              <a:buSzPts val="3800"/>
               <a:buFont typeface="Helvetica Neue"/>
               <a:buChar char="○"/>
             </a:pPr>
             <a:r>
-              <a:rPr lang="en-US" sz="3000">
+              <a:rPr lang="en-US" sz="3800">
                 <a:solidFill>
                   <a:schemeClr val="lt1"/>
                 </a:solidFill>
@@ -10088,9 +10088,9 @@
                 <a:cs typeface="Helvetica Neue"/>
                 <a:sym typeface="Helvetica Neue"/>
               </a:rPr>
-              <a:t>Users begin by selecting the language they are using, upload their own source code files, and the expected output files</a:t>
+              <a:t>SIFT gives students the tools to get their homeworks graded instantly on their own computers</a:t>
             </a:r>
-            <a:endParaRPr sz="3000">
+            <a:endParaRPr sz="3800">
               <a:solidFill>
                 <a:schemeClr val="lt1"/>
               </a:solidFill>
@@ -10101,7 +10101,7 @@
             </a:endParaRPr>
           </a:p>
           <a:p>
-            <a:pPr indent="-419100" lvl="1" marL="914400" rtl="0" algn="l">
+            <a:pPr indent="-469900" lvl="0" marL="457200" rtl="0" algn="l">
               <a:lnSpc>
                 <a:spcPct val="115000"/>
               </a:lnSpc>
@@ -10114,12 +10114,12 @@
               <a:buClr>
                 <a:schemeClr val="lt1"/>
               </a:buClr>
-              <a:buSzPts val="3000"/>
+              <a:buSzPts val="3800"/>
               <a:buFont typeface="Helvetica Neue"/>
-              <a:buChar char="○"/>
+              <a:buChar char="●"/>
             </a:pPr>
             <a:r>
-              <a:rPr lang="en-US" sz="3000">
+              <a:rPr lang="en-US" sz="3800">
                 <a:solidFill>
                   <a:schemeClr val="lt1"/>
                 </a:solidFill>
@@ -10128,9 +10128,9 @@
                 <a:cs typeface="Helvetica Neue"/>
                 <a:sym typeface="Helvetica Neue"/>
               </a:rPr>
-              <a:t>SIFT then runs the source code and shows the user the comparison between their output and the expected output that was provided in a similar way to Submitty</a:t>
+              <a:t>SIFT runs the user’s source code and shows a comparison between the actual and expected output</a:t>
             </a:r>
-            <a:endParaRPr sz="3000">
+            <a:endParaRPr sz="3800">
               <a:solidFill>
                 <a:schemeClr val="lt1"/>
               </a:solidFill>
@@ -10141,7 +10141,7 @@
             </a:endParaRPr>
           </a:p>
           <a:p>
-            <a:pPr indent="-419100" lvl="0" marL="457200" rtl="0" algn="l">
+            <a:pPr indent="-469900" lvl="0" marL="457200" rtl="0" algn="l">
               <a:lnSpc>
                 <a:spcPct val="115000"/>
               </a:lnSpc>
@@ -10154,12 +10154,12 @@
               <a:buClr>
                 <a:schemeClr val="lt1"/>
               </a:buClr>
-              <a:buSzPts val="3000"/>
+              <a:buSzPts val="3800"/>
               <a:buFont typeface="Helvetica Neue"/>
               <a:buChar char="●"/>
             </a:pPr>
             <a:r>
-              <a:rPr lang="en-US" sz="3000">
+              <a:rPr lang="en-US" sz="3800">
                 <a:solidFill>
                   <a:schemeClr val="lt1"/>
                 </a:solidFill>
@@ -10168,9 +10168,49 @@
                 <a:cs typeface="Helvetica Neue"/>
                 <a:sym typeface="Helvetica Neue"/>
               </a:rPr>
-              <a:t>The goal of SIFT is to streamline the process of creating and testing code so that students spend less time waiting for Submitty, wasting submissions, and can instead get quick results and keep working</a:t>
+              <a:t>Streamlines the process of creating and testing code</a:t>
             </a:r>
-            <a:endParaRPr sz="3000">
+            <a:endParaRPr sz="3800">
+              <a:solidFill>
+                <a:schemeClr val="lt1"/>
+              </a:solidFill>
+              <a:latin typeface="Helvetica Neue"/>
+              <a:ea typeface="Helvetica Neue"/>
+              <a:cs typeface="Helvetica Neue"/>
+              <a:sym typeface="Helvetica Neue"/>
+            </a:endParaRPr>
+          </a:p>
+          <a:p>
+            <a:pPr indent="-469900" lvl="1" marL="914400" rtl="0" algn="l">
+              <a:lnSpc>
+                <a:spcPct val="115000"/>
+              </a:lnSpc>
+              <a:spcBef>
+                <a:spcPts val="0"/>
+              </a:spcBef>
+              <a:spcAft>
+                <a:spcPts val="0"/>
+              </a:spcAft>
+              <a:buClr>
+                <a:schemeClr val="lt1"/>
+              </a:buClr>
+              <a:buSzPts val="3800"/>
+              <a:buFont typeface="Helvetica Neue"/>
+              <a:buChar char="○"/>
+            </a:pPr>
+            <a:r>
+              <a:rPr lang="en-US" sz="3800">
+                <a:solidFill>
+                  <a:schemeClr val="lt1"/>
+                </a:solidFill>
+                <a:latin typeface="Helvetica Neue"/>
+                <a:ea typeface="Helvetica Neue"/>
+                <a:cs typeface="Helvetica Neue"/>
+                <a:sym typeface="Helvetica Neue"/>
+              </a:rPr>
+              <a:t>Students can spend less time waiting for Submitty, wasting submissions, and instead get quick results and keep working</a:t>
+            </a:r>
+            <a:endParaRPr sz="3800">
               <a:solidFill>
                 <a:schemeClr val="lt1"/>
               </a:solidFill>
@@ -11292,7 +11332,7 @@
         </p:spPr>
         <p:txBody>
           <a:bodyPr anchorCtr="1" anchor="t" bIns="45700" lIns="91425" spcFirstLastPara="1" rIns="91425" wrap="square" tIns="45700">
-            <a:normAutofit lnSpcReduction="20000"/>
+            <a:normAutofit fontScale="85000"/>
           </a:bodyPr>
           <a:lstStyle/>
           <a:p>
@@ -11306,7 +11346,7 @@
               <a:buClr>
                 <a:srgbClr val="1F3864"/>
               </a:buClr>
-              <a:buSzPts val="8800"/>
+              <a:buSzPct val="100000"/>
               <a:buFont typeface="Calibri"/>
               <a:buNone/>
             </a:pPr>
@@ -11320,7 +11360,7 @@
                 <a:cs typeface="Helvetica Neue"/>
                 <a:sym typeface="Helvetica Neue"/>
               </a:rPr>
-              <a:t>Abedalah Safi, Abrar Zaki, Ayaan Ahmad, Joshua Javillo</a:t>
+              <a:t>Abedalah Safi, Abrar Zaki, Aleks Bekker, Ayaan Ahmad, Joshua Javillo</a:t>
             </a:r>
             <a:endParaRPr i="1">
               <a:solidFill>
@@ -11410,7 +11450,7 @@
         <p:spPr>
           <a:xfrm>
             <a:off x="22244906" y="6328831"/>
-            <a:ext cx="10048800" cy="5100900"/>
+            <a:ext cx="10048800" cy="10392900"/>
           </a:xfrm>
           <a:prstGeom prst="rect">
             <a:avLst/>
@@ -11445,7 +11485,7 @@
             <a:r>
               <a:t/>
             </a:r>
-            <a:endParaRPr sz="2800">
+            <a:endParaRPr sz="3600">
               <a:solidFill>
                 <a:schemeClr val="lt1"/>
               </a:solidFill>
@@ -11475,7 +11515,7 @@
             <a:r>
               <a:t/>
             </a:r>
-            <a:endParaRPr sz="2800">
+            <a:endParaRPr sz="3600">
               <a:solidFill>
                 <a:schemeClr val="lt1"/>
               </a:solidFill>
@@ -11505,7 +11545,7 @@
             <a:r>
               <a:t/>
             </a:r>
-            <a:endParaRPr sz="3000">
+            <a:endParaRPr sz="3800">
               <a:solidFill>
                 <a:schemeClr val="lt1"/>
               </a:solidFill>
@@ -11534,7 +11574,7 @@
               <a:buNone/>
             </a:pPr>
             <a:r>
-              <a:rPr lang="en-US" sz="3000">
+              <a:rPr lang="en-US" sz="3800">
                 <a:solidFill>
                   <a:schemeClr val="lt1"/>
                 </a:solidFill>
@@ -11543,9 +11583,9 @@
                 <a:cs typeface="Helvetica Neue"/>
                 <a:sym typeface="Helvetica Neue"/>
               </a:rPr>
-              <a:t>One of our main goals with S.I.F.T was to make an easy-to-run, smooth application. As such:</a:t>
+              <a:t>SIFT is meant to be an easy-to-run, smooth application. As such:</a:t>
             </a:r>
-            <a:endParaRPr sz="3000">
+            <a:endParaRPr sz="3800">
               <a:solidFill>
                 <a:schemeClr val="lt1"/>
               </a:solidFill>
@@ -11556,7 +11596,7 @@
             </a:endParaRPr>
           </a:p>
           <a:p>
-            <a:pPr indent="-419100" lvl="0" marL="457200" rtl="0" algn="l">
+            <a:pPr indent="-469900" lvl="0" marL="457200" rtl="0" algn="l">
               <a:lnSpc>
                 <a:spcPct val="115000"/>
               </a:lnSpc>
@@ -11569,12 +11609,12 @@
               <a:buClr>
                 <a:schemeClr val="lt1"/>
               </a:buClr>
-              <a:buSzPts val="3000"/>
+              <a:buSzPts val="3800"/>
               <a:buFont typeface="Helvetica Neue"/>
               <a:buChar char="●"/>
             </a:pPr>
             <a:r>
-              <a:rPr lang="en-US" sz="3000">
+              <a:rPr lang="en-US" sz="3800">
                 <a:solidFill>
                   <a:schemeClr val="lt1"/>
                 </a:solidFill>
@@ -11583,9 +11623,9 @@
                 <a:cs typeface="Helvetica Neue"/>
                 <a:sym typeface="Helvetica Neue"/>
               </a:rPr>
-              <a:t> We decided to </a:t>
+              <a:t>We switched from Python to Javascript for its robust application support and distributability</a:t>
             </a:r>
-            <a:endParaRPr sz="3000">
+            <a:endParaRPr sz="3800">
               <a:solidFill>
                 <a:schemeClr val="lt1"/>
               </a:solidFill>
@@ -11596,7 +11636,7 @@
             </a:endParaRPr>
           </a:p>
           <a:p>
-            <a:pPr indent="-419100" lvl="0" marL="457200" rtl="0" algn="l">
+            <a:pPr indent="-469900" lvl="0" marL="457200" rtl="0" algn="l">
               <a:lnSpc>
                 <a:spcPct val="115000"/>
               </a:lnSpc>
@@ -11609,12 +11649,12 @@
               <a:buClr>
                 <a:schemeClr val="lt1"/>
               </a:buClr>
-              <a:buSzPts val="3000"/>
+              <a:buSzPts val="3800"/>
               <a:buFont typeface="Helvetica Neue"/>
               <a:buChar char="●"/>
             </a:pPr>
             <a:r>
-              <a:rPr lang="en-US" sz="3000">
+              <a:rPr lang="en-US" sz="3800">
                 <a:solidFill>
                   <a:schemeClr val="lt1"/>
                 </a:solidFill>
@@ -11623,10 +11663,10 @@
                 <a:cs typeface="Helvetica Neue"/>
                 <a:sym typeface="Helvetica Neue"/>
               </a:rPr>
-              <a:t>Our front-end team, composed of </a:t>
+              <a:t>Our front-end team, </a:t>
             </a:r>
             <a:r>
-              <a:rPr i="1" lang="en-US" sz="3000">
+              <a:rPr i="1" lang="en-US" sz="3800">
                 <a:solidFill>
                   <a:schemeClr val="lt1"/>
                 </a:solidFill>
@@ -11638,7 +11678,7 @@
               <a:t>Abrar Zaki </a:t>
             </a:r>
             <a:r>
-              <a:rPr lang="en-US" sz="3000">
+              <a:rPr lang="en-US" sz="3800">
                 <a:solidFill>
                   <a:schemeClr val="lt1"/>
                 </a:solidFill>
@@ -11650,7 +11690,7 @@
               <a:t>and </a:t>
             </a:r>
             <a:r>
-              <a:rPr i="1" lang="en-US" sz="3000">
+              <a:rPr i="1" lang="en-US" sz="3800">
                 <a:solidFill>
                   <a:schemeClr val="lt1"/>
                 </a:solidFill>
@@ -11659,10 +11699,10 @@
                 <a:cs typeface="Helvetica Neue"/>
                 <a:sym typeface="Helvetica Neue"/>
               </a:rPr>
-              <a:t>Joshua Javillo</a:t>
+              <a:t>Joshua Javillo,</a:t>
             </a:r>
             <a:r>
-              <a:rPr lang="en-US" sz="3000">
+              <a:rPr i="1" lang="en-US" sz="3800">
                 <a:solidFill>
                   <a:schemeClr val="lt1"/>
                 </a:solidFill>
@@ -11671,9 +11711,21 @@
                 <a:cs typeface="Helvetica Neue"/>
                 <a:sym typeface="Helvetica Neue"/>
               </a:rPr>
-              <a:t>, researched for ways to create a simple, easy-to-use UI. </a:t>
+              <a:t> </a:t>
             </a:r>
-            <a:endParaRPr sz="3000">
+            <a:r>
+              <a:rPr lang="en-US" sz="3800">
+                <a:solidFill>
+                  <a:schemeClr val="lt1"/>
+                </a:solidFill>
+                <a:latin typeface="Helvetica Neue"/>
+                <a:ea typeface="Helvetica Neue"/>
+                <a:cs typeface="Helvetica Neue"/>
+                <a:sym typeface="Helvetica Neue"/>
+              </a:rPr>
+              <a:t>worked to create the UI in Javascript</a:t>
+            </a:r>
+            <a:endParaRPr sz="3800">
               <a:solidFill>
                 <a:schemeClr val="lt1"/>
               </a:solidFill>
@@ -11682,6 +11734,110 @@
               <a:cs typeface="Helvetica Neue"/>
               <a:sym typeface="Helvetica Neue"/>
             </a:endParaRPr>
+          </a:p>
+          <a:p>
+            <a:pPr indent="-469900" lvl="0" marL="457200" rtl="0" algn="l">
+              <a:lnSpc>
+                <a:spcPct val="115000"/>
+              </a:lnSpc>
+              <a:spcBef>
+                <a:spcPts val="0"/>
+              </a:spcBef>
+              <a:spcAft>
+                <a:spcPts val="0"/>
+              </a:spcAft>
+              <a:buClr>
+                <a:schemeClr val="lt1"/>
+              </a:buClr>
+              <a:buSzPts val="3800"/>
+              <a:buFont typeface="Helvetica Neue"/>
+              <a:buChar char="●"/>
+            </a:pPr>
+            <a:r>
+              <a:rPr lang="en-US" sz="3800">
+                <a:solidFill>
+                  <a:schemeClr val="lt1"/>
+                </a:solidFill>
+                <a:latin typeface="Helvetica Neue"/>
+                <a:ea typeface="Helvetica Neue"/>
+                <a:cs typeface="Helvetica Neue"/>
+                <a:sym typeface="Helvetica Neue"/>
+              </a:rPr>
+              <a:t>Our back-end team, </a:t>
+            </a:r>
+            <a:r>
+              <a:rPr i="1" lang="en-US" sz="3800">
+                <a:solidFill>
+                  <a:schemeClr val="lt1"/>
+                </a:solidFill>
+                <a:latin typeface="Helvetica Neue"/>
+                <a:ea typeface="Helvetica Neue"/>
+                <a:cs typeface="Helvetica Neue"/>
+                <a:sym typeface="Helvetica Neue"/>
+              </a:rPr>
+              <a:t>Abedalah Safi</a:t>
+            </a:r>
+            <a:r>
+              <a:rPr lang="en-US" sz="3800">
+                <a:solidFill>
+                  <a:schemeClr val="lt1"/>
+                </a:solidFill>
+                <a:latin typeface="Helvetica Neue"/>
+                <a:ea typeface="Helvetica Neue"/>
+                <a:cs typeface="Helvetica Neue"/>
+                <a:sym typeface="Helvetica Neue"/>
+              </a:rPr>
+              <a:t>, </a:t>
+            </a:r>
+            <a:r>
+              <a:rPr i="1" lang="en-US" sz="3800">
+                <a:solidFill>
+                  <a:schemeClr val="lt1"/>
+                </a:solidFill>
+                <a:latin typeface="Helvetica Neue"/>
+                <a:ea typeface="Helvetica Neue"/>
+                <a:cs typeface="Helvetica Neue"/>
+                <a:sym typeface="Helvetica Neue"/>
+              </a:rPr>
+              <a:t>Aleks Bekker, Ayaan Ahmad,</a:t>
+            </a:r>
+            <a:r>
+              <a:rPr lang="en-US" sz="3800">
+                <a:solidFill>
+                  <a:schemeClr val="lt1"/>
+                </a:solidFill>
+                <a:latin typeface="Helvetica Neue"/>
+                <a:ea typeface="Helvetica Neue"/>
+                <a:cs typeface="Helvetica Neue"/>
+                <a:sym typeface="Helvetica Neue"/>
+              </a:rPr>
+              <a:t> and </a:t>
+            </a:r>
+            <a:r>
+              <a:rPr i="1" lang="en-US" sz="3800">
+                <a:solidFill>
+                  <a:schemeClr val="lt1"/>
+                </a:solidFill>
+                <a:latin typeface="Helvetica Neue"/>
+                <a:ea typeface="Helvetica Neue"/>
+                <a:cs typeface="Helvetica Neue"/>
+                <a:sym typeface="Helvetica Neue"/>
+              </a:rPr>
+              <a:t>Steven Huynh</a:t>
+            </a:r>
+            <a:r>
+              <a:rPr lang="en-US" sz="3800">
+                <a:solidFill>
+                  <a:schemeClr val="lt1"/>
+                </a:solidFill>
+                <a:latin typeface="Helvetica Neue"/>
+                <a:ea typeface="Helvetica Neue"/>
+                <a:cs typeface="Helvetica Neue"/>
+                <a:sym typeface="Helvetica Neue"/>
+              </a:rPr>
+              <a:t> worked on documentation, writing code, and developing the API</a:t>
+            </a:r>
+            <a:endParaRPr/>
           </a:p>
         </p:txBody>
       </p:sp>
@@ -11723,7 +11879,7 @@
         </p:nvSpPr>
         <p:spPr>
           <a:xfrm>
-            <a:off x="472638" y="18572338"/>
+            <a:off x="472638" y="19410538"/>
             <a:ext cx="10050600" cy="877200"/>
           </a:xfrm>
           <a:prstGeom prst="rect">
@@ -11763,7 +11919,7 @@
                 <a:cs typeface="Helvetica Neue"/>
                 <a:sym typeface="Helvetica Neue"/>
               </a:rPr>
-              <a:t>Accomplishments</a:t>
+              <a:t>Changes from last semester</a:t>
             </a:r>
             <a:endParaRPr sz="4500">
               <a:solidFill>
@@ -11785,7 +11941,7 @@
         </p:nvSpPr>
         <p:spPr>
           <a:xfrm>
-            <a:off x="428325" y="19651975"/>
+            <a:off x="428325" y="20490175"/>
             <a:ext cx="10464600" cy="12525000"/>
           </a:xfrm>
           <a:prstGeom prst="rect">
@@ -11802,7 +11958,7 @@
           </a:bodyPr>
           <a:lstStyle/>
           <a:p>
-            <a:pPr indent="-419100" lvl="0" marL="914400" rtl="0" algn="l">
+            <a:pPr indent="-469900" lvl="0" marL="914400" rtl="0" algn="l">
               <a:lnSpc>
                 <a:spcPct val="115000"/>
               </a:lnSpc>
@@ -11815,12 +11971,12 @@
               <a:buClr>
                 <a:schemeClr val="lt1"/>
               </a:buClr>
-              <a:buSzPts val="3000"/>
+              <a:buSzPts val="3800"/>
               <a:buFont typeface="Helvetica Neue"/>
               <a:buChar char="●"/>
             </a:pPr>
             <a:r>
-              <a:rPr lang="en-US" sz="3000">
+              <a:rPr lang="en-US" sz="3800">
                 <a:solidFill>
                   <a:schemeClr val="lt1"/>
                 </a:solidFill>
@@ -11829,9 +11985,9 @@
                 <a:cs typeface="Helvetica Neue"/>
                 <a:sym typeface="Helvetica Neue"/>
               </a:rPr>
-              <a:t>We started S.I.F.T from scratch, making our UI over the semester</a:t>
+              <a:t>Moving away from Python</a:t>
             </a:r>
-            <a:endParaRPr sz="3000">
+            <a:endParaRPr sz="3800">
               <a:solidFill>
                 <a:schemeClr val="lt1"/>
               </a:solidFill>
@@ -11842,7 +11998,7 @@
             </a:endParaRPr>
           </a:p>
           <a:p>
-            <a:pPr indent="-419100" lvl="0" marL="914400" rtl="0" algn="l">
+            <a:pPr indent="-469900" lvl="1" marL="1371600" rtl="0" algn="l">
               <a:lnSpc>
                 <a:spcPct val="115000"/>
               </a:lnSpc>
@@ -11855,12 +12011,12 @@
               <a:buClr>
                 <a:schemeClr val="lt1"/>
               </a:buClr>
-              <a:buSzPts val="3000"/>
+              <a:buSzPts val="3800"/>
               <a:buFont typeface="Helvetica Neue"/>
-              <a:buChar char="●"/>
+              <a:buChar char="○"/>
             </a:pPr>
             <a:r>
-              <a:rPr lang="en-US" sz="3000">
+              <a:rPr lang="en-US" sz="3800">
                 <a:solidFill>
                   <a:schemeClr val="lt1"/>
                 </a:solidFill>
@@ -11869,9 +12025,9 @@
                 <a:cs typeface="Helvetica Neue"/>
                 <a:sym typeface="Helvetica Neue"/>
               </a:rPr>
-              <a:t>We created a new logo</a:t>
+              <a:t>Javascript was more customizable and robust for front-end</a:t>
             </a:r>
-            <a:endParaRPr sz="3000">
+            <a:endParaRPr sz="3800">
               <a:solidFill>
                 <a:schemeClr val="lt1"/>
               </a:solidFill>
@@ -11882,7 +12038,7 @@
             </a:endParaRPr>
           </a:p>
           <a:p>
-            <a:pPr indent="-419100" lvl="1" marL="1371600" rtl="0" algn="l">
+            <a:pPr indent="-469900" lvl="1" marL="1371600" rtl="0" algn="l">
               <a:lnSpc>
                 <a:spcPct val="115000"/>
               </a:lnSpc>
@@ -11895,12 +12051,132 @@
               <a:buClr>
                 <a:schemeClr val="lt1"/>
               </a:buClr>
-              <a:buSzPts val="3000"/>
+              <a:buSzPts val="3800"/>
               <a:buFont typeface="Helvetica Neue"/>
               <a:buChar char="○"/>
             </a:pPr>
             <a:r>
-              <a:rPr lang="en-US" sz="3000">
+              <a:rPr lang="en-US" sz="3800">
+                <a:solidFill>
+                  <a:schemeClr val="lt1"/>
+                </a:solidFill>
+                <a:latin typeface="Helvetica Neue"/>
+                <a:ea typeface="Helvetica Neue"/>
+                <a:cs typeface="Helvetica Neue"/>
+                <a:sym typeface="Helvetica Neue"/>
+              </a:rPr>
+              <a:t>Golang is more performant for back-end tasks</a:t>
+            </a:r>
+            <a:endParaRPr sz="3800">
+              <a:solidFill>
+                <a:schemeClr val="lt1"/>
+              </a:solidFill>
+              <a:latin typeface="Helvetica Neue"/>
+              <a:ea typeface="Helvetica Neue"/>
+              <a:cs typeface="Helvetica Neue"/>
+              <a:sym typeface="Helvetica Neue"/>
+            </a:endParaRPr>
+          </a:p>
+          <a:p>
+            <a:pPr indent="-469900" lvl="0" marL="914400" rtl="0" algn="l">
+              <a:lnSpc>
+                <a:spcPct val="115000"/>
+              </a:lnSpc>
+              <a:spcBef>
+                <a:spcPts val="0"/>
+              </a:spcBef>
+              <a:spcAft>
+                <a:spcPts val="0"/>
+              </a:spcAft>
+              <a:buClr>
+                <a:schemeClr val="lt1"/>
+              </a:buClr>
+              <a:buSzPts val="3800"/>
+              <a:buFont typeface="Helvetica Neue"/>
+              <a:buChar char="●"/>
+            </a:pPr>
+            <a:r>
+              <a:rPr lang="en-US" sz="3800">
+                <a:solidFill>
+                  <a:schemeClr val="lt1"/>
+                </a:solidFill>
+                <a:latin typeface="Helvetica Neue"/>
+                <a:ea typeface="Helvetica Neue"/>
+                <a:cs typeface="Helvetica Neue"/>
+                <a:sym typeface="Helvetica Neue"/>
+              </a:rPr>
+              <a:t>Decided to </a:t>
+            </a:r>
+            <a:endParaRPr sz="3800">
+              <a:solidFill>
+                <a:schemeClr val="lt1"/>
+              </a:solidFill>
+              <a:latin typeface="Helvetica Neue"/>
+              <a:ea typeface="Helvetica Neue"/>
+              <a:cs typeface="Helvetica Neue"/>
+              <a:sym typeface="Helvetica Neue"/>
+            </a:endParaRPr>
+          </a:p>
+          <a:p>
+            <a:pPr indent="-469900" lvl="0" marL="914400" rtl="0" algn="l">
+              <a:lnSpc>
+                <a:spcPct val="115000"/>
+              </a:lnSpc>
+              <a:spcBef>
+                <a:spcPts val="0"/>
+              </a:spcBef>
+              <a:spcAft>
+                <a:spcPts val="0"/>
+              </a:spcAft>
+              <a:buClr>
+                <a:schemeClr val="lt1"/>
+              </a:buClr>
+              <a:buSzPts val="3800"/>
+              <a:buFont typeface="Helvetica Neue"/>
+              <a:buChar char="●"/>
+            </a:pPr>
+            <a:r>
+              <a:rPr lang="en-US" sz="3800">
+                <a:solidFill>
+                  <a:schemeClr val="lt1"/>
+                </a:solidFill>
+                <a:latin typeface="Helvetica Neue"/>
+                <a:ea typeface="Helvetica Neue"/>
+                <a:cs typeface="Helvetica Neue"/>
+                <a:sym typeface="Helvetica Neue"/>
+              </a:rPr>
+              <a:t>New logo</a:t>
+            </a:r>
+            <a:endParaRPr sz="3800">
+              <a:solidFill>
+                <a:schemeClr val="lt1"/>
+              </a:solidFill>
+              <a:latin typeface="Helvetica Neue"/>
+              <a:ea typeface="Helvetica Neue"/>
+              <a:cs typeface="Helvetica Neue"/>
+              <a:sym typeface="Helvetica Neue"/>
+            </a:endParaRPr>
+          </a:p>
+          <a:p>
+            <a:pPr indent="-469900" lvl="1" marL="1371600" rtl="0" algn="l">
+              <a:lnSpc>
+                <a:spcPct val="115000"/>
+              </a:lnSpc>
+              <a:spcBef>
+                <a:spcPts val="0"/>
+              </a:spcBef>
+              <a:spcAft>
+                <a:spcPts val="0"/>
+              </a:spcAft>
+              <a:buClr>
+                <a:schemeClr val="lt1"/>
+              </a:buClr>
+              <a:buSzPts val="3800"/>
+              <a:buFont typeface="Helvetica Neue"/>
+              <a:buChar char="○"/>
+            </a:pPr>
+            <a:r>
+              <a:rPr lang="en-US" sz="3800">
                 <a:solidFill>
                   <a:schemeClr val="lt1"/>
                 </a:solidFill>
@@ -11911,7 +12187,7 @@
               </a:rPr>
               <a:t>A modified version of the Submitty logo with the duck made up of green binary</a:t>
             </a:r>
-            <a:endParaRPr sz="3000">
+            <a:endParaRPr sz="3800">
               <a:solidFill>
                 <a:schemeClr val="lt1"/>
               </a:solidFill>
@@ -11940,7 +12216,7 @@
               <a:buNone/>
             </a:pPr>
             <a:r>
-              <a:rPr lang="en-US" sz="3000">
+              <a:rPr lang="en-US" sz="3800">
                 <a:solidFill>
                   <a:schemeClr val="lt1"/>
                 </a:solidFill>
@@ -11951,7 +12227,7 @@
               </a:rPr>
               <a:t> </a:t>
             </a:r>
-            <a:endParaRPr sz="3000">
+            <a:endParaRPr sz="3800">
               <a:solidFill>
                 <a:schemeClr val="lt1"/>
               </a:solidFill>
@@ -11979,8 +12255,8 @@
         </p:blipFill>
         <p:spPr>
           <a:xfrm>
-            <a:off x="37752909" y="458534"/>
-            <a:ext cx="3024175" cy="3024175"/>
+            <a:off x="38112199" y="1322074"/>
+            <a:ext cx="2543175" cy="2543175"/>
           </a:xfrm>
           <a:prstGeom prst="rect">
             <a:avLst/>
@@ -12007,8 +12283,8 @@
         </p:blipFill>
         <p:spPr>
           <a:xfrm>
-            <a:off x="41258626" y="458538"/>
-            <a:ext cx="3024175" cy="3024175"/>
+            <a:off x="40975425" y="1322073"/>
+            <a:ext cx="2543175" cy="2543175"/>
           </a:xfrm>
           <a:prstGeom prst="rect">
             <a:avLst/>

</xml_diff>

<commit_message>
Final poster for rcos expo
</commit_message>
<xml_diff>
--- a/RCOS Poster Fall 24.pptx
+++ b/RCOS Poster Fall 24.pptx
@@ -304,7 +304,7 @@
       </p15:notesGuideLst>
     </p:ext>
     <p:ext uri="GoogleSlidesCustomDataVersion2">
-      <go:slidesCustomData xmlns:go="http://customooxmlschemas.google.com/" r:id="rId13" roundtripDataSignature="AMtx7mh4FMsl5tdLKdFNHf0sWWaLJUPJKw=="/>
+      <go:slidesCustomData xmlns:go="http://customooxmlschemas.google.com/" r:id="rId13" roundtripDataSignature="AMtx7mhNeuLw/K6cNyyvhq1FdII+tn5JNg=="/>
     </p:ext>
   </p:extLst>
 </p:presentation>
@@ -5750,7 +5750,7 @@
             <a:tbl>
               <a:tblPr bandRow="1" firstRow="1">
                 <a:noFill/>
-                <a:tableStyleId>{8598BC43-226E-47E2-BF5D-7E1E38377976}</a:tableStyleId>
+                <a:tableStyleId>{36B4EF38-2129-4F2A-A8C0-1B8BAF3392DA}</a:tableStyleId>
               </a:tblPr>
               <a:tblGrid>
                 <a:gridCol w="4192250"/>
@@ -7279,7 +7279,7 @@
             <a:tbl>
               <a:tblPr bandRow="1" firstRow="1">
                 <a:noFill/>
-                <a:tableStyleId>{8598BC43-226E-47E2-BF5D-7E1E38377976}</a:tableStyleId>
+                <a:tableStyleId>{36B4EF38-2129-4F2A-A8C0-1B8BAF3392DA}</a:tableStyleId>
               </a:tblPr>
               <a:tblGrid>
                 <a:gridCol w="3343825"/>
@@ -9531,7 +9531,7 @@
         </p:nvPicPr>
         <p:blipFill>
           <a:blip r:embed="rId3">
-            <a:alphaModFix/>
+            <a:alphaModFix amt="50000"/>
           </a:blip>
           <a:stretch>
             <a:fillRect/>
@@ -9559,7 +9559,7 @@
         </p:nvSpPr>
         <p:spPr>
           <a:xfrm>
-            <a:off x="11711350" y="5548750"/>
+            <a:off x="11711350" y="5548725"/>
             <a:ext cx="10058400" cy="10972500"/>
           </a:xfrm>
           <a:prstGeom prst="rect">
@@ -9604,8 +9604,8 @@
         </p:nvSpPr>
         <p:spPr>
           <a:xfrm>
-            <a:off x="33182425" y="5491325"/>
-            <a:ext cx="10464600" cy="25799700"/>
+            <a:off x="33182425" y="5548725"/>
+            <a:ext cx="10464600" cy="25798200"/>
           </a:xfrm>
           <a:prstGeom prst="rect">
             <a:avLst/>
@@ -9650,7 +9650,7 @@
         <p:spPr>
           <a:xfrm>
             <a:off x="428325" y="5548750"/>
-            <a:ext cx="10464600" cy="25742400"/>
+            <a:ext cx="10464600" cy="25798200"/>
           </a:xfrm>
           <a:prstGeom prst="rect">
             <a:avLst/>
@@ -9690,14 +9690,12 @@
         <p:nvSpPr>
           <p:cNvPr id="39" name="Google Shape;39;p1"/>
           <p:cNvSpPr txBox="1"/>
-          <p:nvPr>
-            <p:ph idx="4" type="body"/>
-          </p:nvPr>
+          <p:nvPr/>
         </p:nvSpPr>
         <p:spPr>
           <a:xfrm>
-            <a:off x="11808086" y="6530881"/>
-            <a:ext cx="10048800" cy="8665800"/>
+            <a:off x="428325" y="22822300"/>
+            <a:ext cx="10464600" cy="10162800"/>
           </a:xfrm>
           <a:prstGeom prst="rect">
             <a:avLst/>
@@ -9708,14 +9706,14 @@
           </a:ln>
         </p:spPr>
         <p:txBody>
-          <a:bodyPr anchorCtr="0" anchor="t" bIns="228575" lIns="228575" spcFirstLastPara="1" rIns="228575" wrap="square" tIns="228575">
-            <a:spAutoFit/>
+          <a:bodyPr anchorCtr="0" anchor="t" bIns="91425" lIns="91425" spcFirstLastPara="1" rIns="91425" wrap="square" tIns="91425">
+            <a:noAutofit/>
           </a:bodyPr>
           <a:lstStyle/>
           <a:p>
-            <a:pPr indent="-488950" lvl="0" marL="457200" rtl="0" algn="l">
+            <a:pPr indent="-488950" lvl="0" marL="914400" rtl="0" algn="l">
               <a:lnSpc>
-                <a:spcPct val="150000"/>
+                <a:spcPct val="115000"/>
               </a:lnSpc>
               <a:spcBef>
                 <a:spcPts val="0"/>
@@ -9740,7 +9738,7 @@
                 <a:cs typeface="Helvetica Neue"/>
                 <a:sym typeface="Helvetica Neue"/>
               </a:rPr>
-              <a:t>Provide students with a resource to quickly and easily test code anywhere, anytime</a:t>
+              <a:t>Moving away from Python</a:t>
             </a:r>
             <a:endParaRPr sz="4100">
               <a:solidFill>
@@ -9753,9 +9751,9 @@
             </a:endParaRPr>
           </a:p>
           <a:p>
-            <a:pPr indent="-488950" lvl="0" marL="457200" rtl="0" algn="l">
+            <a:pPr indent="-488950" lvl="1" marL="1371600" rtl="0" algn="l">
               <a:lnSpc>
-                <a:spcPct val="150000"/>
+                <a:spcPct val="115000"/>
               </a:lnSpc>
               <a:spcBef>
                 <a:spcPts val="0"/>
@@ -9768,7 +9766,7 @@
               </a:buClr>
               <a:buSzPts val="4100"/>
               <a:buFont typeface="Helvetica Neue"/>
-              <a:buChar char="●"/>
+              <a:buChar char="○"/>
             </a:pPr>
             <a:r>
               <a:rPr lang="en-US" sz="4100">
@@ -9780,7 +9778,7 @@
                 <a:cs typeface="Helvetica Neue"/>
                 <a:sym typeface="Helvetica Neue"/>
               </a:rPr>
-              <a:t>Create a user friendly and functional UI</a:t>
+              <a:t>Javascript was more customizable and robust for front-end</a:t>
             </a:r>
             <a:endParaRPr sz="4100">
               <a:solidFill>
@@ -9793,9 +9791,9 @@
             </a:endParaRPr>
           </a:p>
           <a:p>
-            <a:pPr indent="-488950" lvl="0" marL="457200" rtl="0" algn="l">
+            <a:pPr indent="-488950" lvl="1" marL="1371600" rtl="0" algn="l">
               <a:lnSpc>
-                <a:spcPct val="150000"/>
+                <a:spcPct val="115000"/>
               </a:lnSpc>
               <a:spcBef>
                 <a:spcPts val="0"/>
@@ -9808,7 +9806,7 @@
               </a:buClr>
               <a:buSzPts val="4100"/>
               <a:buFont typeface="Helvetica Neue"/>
-              <a:buChar char="●"/>
+              <a:buChar char="○"/>
             </a:pPr>
             <a:r>
               <a:rPr lang="en-US" sz="4100">
@@ -9820,7 +9818,7 @@
                 <a:cs typeface="Helvetica Neue"/>
                 <a:sym typeface="Helvetica Neue"/>
               </a:rPr>
-              <a:t>Encourage students to develop better testing habits</a:t>
+              <a:t>Golang is more performant for back-end tasks</a:t>
             </a:r>
             <a:endParaRPr sz="4100">
               <a:solidFill>
@@ -9833,9 +9831,9 @@
             </a:endParaRPr>
           </a:p>
           <a:p>
-            <a:pPr indent="-488950" lvl="0" marL="457200" rtl="0" algn="l">
+            <a:pPr indent="-488950" lvl="0" marL="914400" rtl="0" algn="l">
               <a:lnSpc>
-                <a:spcPct val="150000"/>
+                <a:spcPct val="115000"/>
               </a:lnSpc>
               <a:spcBef>
                 <a:spcPts val="0"/>
@@ -9860,7 +9858,7 @@
                 <a:cs typeface="Helvetica Neue"/>
                 <a:sym typeface="Helvetica Neue"/>
               </a:rPr>
-              <a:t>Relieve stress off Submitty servers</a:t>
+              <a:t>Decided to </a:t>
             </a:r>
             <a:endParaRPr sz="4100">
               <a:solidFill>
@@ -9873,9 +9871,9 @@
             </a:endParaRPr>
           </a:p>
           <a:p>
-            <a:pPr indent="-488950" lvl="0" marL="457200" rtl="0" algn="l">
+            <a:pPr indent="-488950" lvl="0" marL="914400" rtl="0" algn="l">
               <a:lnSpc>
-                <a:spcPct val="150000"/>
+                <a:spcPct val="115000"/>
               </a:lnSpc>
               <a:spcBef>
                 <a:spcPts val="0"/>
@@ -9900,7 +9898,87 @@
                 <a:cs typeface="Helvetica Neue"/>
                 <a:sym typeface="Helvetica Neue"/>
               </a:rPr>
-              <a:t>Apply the skills we’ve learned in classes to create a useful product!</a:t>
+              <a:t>New logo</a:t>
+            </a:r>
+            <a:endParaRPr sz="4100">
+              <a:solidFill>
+                <a:schemeClr val="lt1"/>
+              </a:solidFill>
+              <a:latin typeface="Helvetica Neue"/>
+              <a:ea typeface="Helvetica Neue"/>
+              <a:cs typeface="Helvetica Neue"/>
+              <a:sym typeface="Helvetica Neue"/>
+            </a:endParaRPr>
+          </a:p>
+          <a:p>
+            <a:pPr indent="-488950" lvl="1" marL="1371600" rtl="0" algn="l">
+              <a:lnSpc>
+                <a:spcPct val="115000"/>
+              </a:lnSpc>
+              <a:spcBef>
+                <a:spcPts val="0"/>
+              </a:spcBef>
+              <a:spcAft>
+                <a:spcPts val="0"/>
+              </a:spcAft>
+              <a:buClr>
+                <a:schemeClr val="lt1"/>
+              </a:buClr>
+              <a:buSzPts val="4100"/>
+              <a:buFont typeface="Helvetica Neue"/>
+              <a:buChar char="○"/>
+            </a:pPr>
+            <a:r>
+              <a:rPr lang="en-US" sz="4100">
+                <a:solidFill>
+                  <a:schemeClr val="lt1"/>
+                </a:solidFill>
+                <a:latin typeface="Helvetica Neue"/>
+                <a:ea typeface="Helvetica Neue"/>
+                <a:cs typeface="Helvetica Neue"/>
+                <a:sym typeface="Helvetica Neue"/>
+              </a:rPr>
+              <a:t>A modified version of the Submitty logo with the duck made up of green binary</a:t>
+            </a:r>
+            <a:endParaRPr sz="4100">
+              <a:solidFill>
+                <a:schemeClr val="lt1"/>
+              </a:solidFill>
+              <a:latin typeface="Helvetica Neue"/>
+              <a:ea typeface="Helvetica Neue"/>
+              <a:cs typeface="Helvetica Neue"/>
+              <a:sym typeface="Helvetica Neue"/>
+            </a:endParaRPr>
+          </a:p>
+          <a:p>
+            <a:pPr indent="0" lvl="0" marL="914400" rtl="0" algn="l">
+              <a:lnSpc>
+                <a:spcPct val="115000"/>
+              </a:lnSpc>
+              <a:spcBef>
+                <a:spcPts val="0"/>
+              </a:spcBef>
+              <a:spcAft>
+                <a:spcPts val="0"/>
+              </a:spcAft>
+              <a:buClr>
+                <a:schemeClr val="dk1"/>
+              </a:buClr>
+              <a:buSzPts val="1100"/>
+              <a:buFont typeface="Arial"/>
+              <a:buNone/>
+            </a:pPr>
+            <a:r>
+              <a:rPr lang="en-US" sz="4100">
+                <a:solidFill>
+                  <a:schemeClr val="lt1"/>
+                </a:solidFill>
+                <a:latin typeface="Helvetica Neue"/>
+                <a:ea typeface="Helvetica Neue"/>
+                <a:cs typeface="Helvetica Neue"/>
+                <a:sym typeface="Helvetica Neue"/>
+              </a:rPr>
+              <a:t> </a:t>
             </a:r>
             <a:endParaRPr sz="4100">
               <a:solidFill>
@@ -9919,13 +9997,13 @@
           <p:cNvPr id="40" name="Google Shape;40;p1"/>
           <p:cNvSpPr txBox="1"/>
           <p:nvPr>
-            <p:ph idx="1" type="body"/>
+            <p:ph idx="4" type="body"/>
           </p:nvPr>
         </p:nvSpPr>
         <p:spPr>
           <a:xfrm>
-            <a:off x="459675" y="6378476"/>
-            <a:ext cx="10056900" cy="13154400"/>
+            <a:off x="11808086" y="6530881"/>
+            <a:ext cx="10048800" cy="9835800"/>
           </a:xfrm>
           <a:prstGeom prst="rect">
             <a:avLst/>
@@ -9941,9 +10019,9 @@
           </a:bodyPr>
           <a:lstStyle/>
           <a:p>
-            <a:pPr indent="-469900" lvl="0" marL="457200" rtl="0" algn="l">
+            <a:pPr indent="-495300" lvl="0" marL="457200" rtl="0" algn="l">
               <a:lnSpc>
-                <a:spcPct val="115000"/>
+                <a:spcPct val="150000"/>
               </a:lnSpc>
               <a:spcBef>
                 <a:spcPts val="0"/>
@@ -9954,12 +10032,12 @@
               <a:buClr>
                 <a:schemeClr val="lt1"/>
               </a:buClr>
-              <a:buSzPts val="3800"/>
+              <a:buSzPts val="4200"/>
               <a:buFont typeface="Helvetica Neue"/>
               <a:buChar char="●"/>
             </a:pPr>
             <a:r>
-              <a:rPr lang="en-US" sz="3800">
+              <a:rPr lang="en-US" sz="4200">
                 <a:solidFill>
                   <a:schemeClr val="lt1"/>
                 </a:solidFill>
@@ -9968,9 +10046,9 @@
                 <a:cs typeface="Helvetica Neue"/>
                 <a:sym typeface="Helvetica Neue"/>
               </a:rPr>
-              <a:t>Standalone app</a:t>
+              <a:t>Provide students with a resource to quickly and easily test code anywhere, anytime</a:t>
             </a:r>
-            <a:endParaRPr sz="3800">
+            <a:endParaRPr sz="4200">
               <a:solidFill>
                 <a:schemeClr val="lt1"/>
               </a:solidFill>
@@ -9981,9 +10059,9 @@
             </a:endParaRPr>
           </a:p>
           <a:p>
-            <a:pPr indent="-469900" lvl="1" marL="914400" rtl="0" algn="l">
+            <a:pPr indent="-495300" lvl="0" marL="457200" rtl="0" algn="l">
               <a:lnSpc>
-                <a:spcPct val="115000"/>
+                <a:spcPct val="150000"/>
               </a:lnSpc>
               <a:spcBef>
                 <a:spcPts val="0"/>
@@ -9994,12 +10072,12 @@
               <a:buClr>
                 <a:schemeClr val="lt1"/>
               </a:buClr>
-              <a:buSzPts val="3800"/>
+              <a:buSzPts val="4200"/>
               <a:buFont typeface="Helvetica Neue"/>
-              <a:buChar char="○"/>
+              <a:buChar char="●"/>
             </a:pPr>
             <a:r>
-              <a:rPr lang="en-US" sz="3800">
+              <a:rPr lang="en-US" sz="4200">
                 <a:solidFill>
                   <a:schemeClr val="lt1"/>
                 </a:solidFill>
@@ -10008,9 +10086,9 @@
                 <a:cs typeface="Helvetica Neue"/>
                 <a:sym typeface="Helvetica Neue"/>
               </a:rPr>
-              <a:t>Students can get feedback on homework without having to rely on Submitty</a:t>
+              <a:t>Create a user friendly and functional UI</a:t>
             </a:r>
-            <a:endParaRPr sz="3800">
+            <a:endParaRPr sz="4200">
               <a:solidFill>
                 <a:schemeClr val="lt1"/>
               </a:solidFill>
@@ -10021,9 +10099,9 @@
             </a:endParaRPr>
           </a:p>
           <a:p>
-            <a:pPr indent="-469900" lvl="0" marL="457200" rtl="0" algn="l">
+            <a:pPr indent="-495300" lvl="0" marL="457200" rtl="0" algn="l">
               <a:lnSpc>
-                <a:spcPct val="115000"/>
+                <a:spcPct val="150000"/>
               </a:lnSpc>
               <a:spcBef>
                 <a:spcPts val="0"/>
@@ -10034,12 +10112,12 @@
               <a:buClr>
                 <a:schemeClr val="lt1"/>
               </a:buClr>
-              <a:buSzPts val="3800"/>
+              <a:buSzPts val="4200"/>
               <a:buFont typeface="Helvetica Neue"/>
               <a:buChar char="●"/>
             </a:pPr>
             <a:r>
-              <a:rPr lang="en-US" sz="3800">
+              <a:rPr lang="en-US" sz="4200">
                 <a:solidFill>
                   <a:schemeClr val="lt1"/>
                 </a:solidFill>
@@ -10048,9 +10126,9 @@
                 <a:cs typeface="Helvetica Neue"/>
                 <a:sym typeface="Helvetica Neue"/>
               </a:rPr>
-              <a:t>Using the Submitty autograder to test and find problems in code can be cumbersome</a:t>
+              <a:t>Encourage students to develop better testing habits</a:t>
             </a:r>
-            <a:endParaRPr sz="3800">
+            <a:endParaRPr sz="4200">
               <a:solidFill>
                 <a:schemeClr val="lt1"/>
               </a:solidFill>
@@ -10061,9 +10139,9 @@
             </a:endParaRPr>
           </a:p>
           <a:p>
-            <a:pPr indent="-469900" lvl="1" marL="914400" rtl="0" algn="l">
+            <a:pPr indent="-495300" lvl="0" marL="457200" rtl="0" algn="l">
               <a:lnSpc>
-                <a:spcPct val="115000"/>
+                <a:spcPct val="150000"/>
               </a:lnSpc>
               <a:spcBef>
                 <a:spcPts val="0"/>
@@ -10074,12 +10152,12 @@
               <a:buClr>
                 <a:schemeClr val="lt1"/>
               </a:buClr>
-              <a:buSzPts val="3800"/>
+              <a:buSzPts val="4200"/>
               <a:buFont typeface="Helvetica Neue"/>
-              <a:buChar char="○"/>
+              <a:buChar char="●"/>
             </a:pPr>
             <a:r>
-              <a:rPr lang="en-US" sz="3800">
+              <a:rPr lang="en-US" sz="4200">
                 <a:solidFill>
                   <a:schemeClr val="lt1"/>
                 </a:solidFill>
@@ -10088,9 +10166,9 @@
                 <a:cs typeface="Helvetica Neue"/>
                 <a:sym typeface="Helvetica Neue"/>
               </a:rPr>
-              <a:t>SIFT gives students the tools to get their homeworks graded instantly on their own computers</a:t>
+              <a:t>Relieve stress off Submitty servers</a:t>
             </a:r>
-            <a:endParaRPr sz="3800">
+            <a:endParaRPr sz="4200">
               <a:solidFill>
                 <a:schemeClr val="lt1"/>
               </a:solidFill>
@@ -10101,9 +10179,9 @@
             </a:endParaRPr>
           </a:p>
           <a:p>
-            <a:pPr indent="-469900" lvl="0" marL="457200" rtl="0" algn="l">
+            <a:pPr indent="-495300" lvl="0" marL="457200" rtl="0" algn="l">
               <a:lnSpc>
-                <a:spcPct val="115000"/>
+                <a:spcPct val="150000"/>
               </a:lnSpc>
               <a:spcBef>
                 <a:spcPts val="0"/>
@@ -10114,12 +10192,12 @@
               <a:buClr>
                 <a:schemeClr val="lt1"/>
               </a:buClr>
-              <a:buSzPts val="3800"/>
+              <a:buSzPts val="4200"/>
               <a:buFont typeface="Helvetica Neue"/>
               <a:buChar char="●"/>
             </a:pPr>
             <a:r>
-              <a:rPr lang="en-US" sz="3800">
+              <a:rPr lang="en-US" sz="4200">
                 <a:solidFill>
                   <a:schemeClr val="lt1"/>
                 </a:solidFill>
@@ -10128,89 +10206,9 @@
                 <a:cs typeface="Helvetica Neue"/>
                 <a:sym typeface="Helvetica Neue"/>
               </a:rPr>
-              <a:t>SIFT runs the user’s source code and shows a comparison between the actual and expected output</a:t>
+              <a:t>Apply the skills we’ve learned in classes to create a useful product!</a:t>
             </a:r>
-            <a:endParaRPr sz="3800">
-              <a:solidFill>
-                <a:schemeClr val="lt1"/>
-              </a:solidFill>
-              <a:latin typeface="Helvetica Neue"/>
-              <a:ea typeface="Helvetica Neue"/>
-              <a:cs typeface="Helvetica Neue"/>
-              <a:sym typeface="Helvetica Neue"/>
-            </a:endParaRPr>
-          </a:p>
-          <a:p>
-            <a:pPr indent="-469900" lvl="0" marL="457200" rtl="0" algn="l">
-              <a:lnSpc>
-                <a:spcPct val="115000"/>
-              </a:lnSpc>
-              <a:spcBef>
-                <a:spcPts val="0"/>
-              </a:spcBef>
-              <a:spcAft>
-                <a:spcPts val="0"/>
-              </a:spcAft>
-              <a:buClr>
-                <a:schemeClr val="lt1"/>
-              </a:buClr>
-              <a:buSzPts val="3800"/>
-              <a:buFont typeface="Helvetica Neue"/>
-              <a:buChar char="●"/>
-            </a:pPr>
-            <a:r>
-              <a:rPr lang="en-US" sz="3800">
-                <a:solidFill>
-                  <a:schemeClr val="lt1"/>
-                </a:solidFill>
-                <a:latin typeface="Helvetica Neue"/>
-                <a:ea typeface="Helvetica Neue"/>
-                <a:cs typeface="Helvetica Neue"/>
-                <a:sym typeface="Helvetica Neue"/>
-              </a:rPr>
-              <a:t>Streamlines the process of creating and testing code</a:t>
-            </a:r>
-            <a:endParaRPr sz="3800">
-              <a:solidFill>
-                <a:schemeClr val="lt1"/>
-              </a:solidFill>
-              <a:latin typeface="Helvetica Neue"/>
-              <a:ea typeface="Helvetica Neue"/>
-              <a:cs typeface="Helvetica Neue"/>
-              <a:sym typeface="Helvetica Neue"/>
-            </a:endParaRPr>
-          </a:p>
-          <a:p>
-            <a:pPr indent="-469900" lvl="1" marL="914400" rtl="0" algn="l">
-              <a:lnSpc>
-                <a:spcPct val="115000"/>
-              </a:lnSpc>
-              <a:spcBef>
-                <a:spcPts val="0"/>
-              </a:spcBef>
-              <a:spcAft>
-                <a:spcPts val="0"/>
-              </a:spcAft>
-              <a:buClr>
-                <a:schemeClr val="lt1"/>
-              </a:buClr>
-              <a:buSzPts val="3800"/>
-              <a:buFont typeface="Helvetica Neue"/>
-              <a:buChar char="○"/>
-            </a:pPr>
-            <a:r>
-              <a:rPr lang="en-US" sz="3800">
-                <a:solidFill>
-                  <a:schemeClr val="lt1"/>
-                </a:solidFill>
-                <a:latin typeface="Helvetica Neue"/>
-                <a:ea typeface="Helvetica Neue"/>
-                <a:cs typeface="Helvetica Neue"/>
-                <a:sym typeface="Helvetica Neue"/>
-              </a:rPr>
-              <a:t>Students can spend less time waiting for Submitty, wasting submissions, and instead get quick results and keep working</a:t>
-            </a:r>
-            <a:endParaRPr sz="3800">
+            <a:endParaRPr sz="4200">
               <a:solidFill>
                 <a:schemeClr val="lt1"/>
               </a:solidFill>
@@ -10227,13 +10225,13 @@
           <p:cNvPr id="41" name="Google Shape;41;p1"/>
           <p:cNvSpPr txBox="1"/>
           <p:nvPr>
-            <p:ph idx="9" type="body"/>
+            <p:ph idx="1" type="body"/>
           </p:nvPr>
         </p:nvSpPr>
         <p:spPr>
           <a:xfrm>
-            <a:off x="33405900" y="6352650"/>
-            <a:ext cx="10047000" cy="11154000"/>
+            <a:off x="459675" y="6378476"/>
+            <a:ext cx="10056900" cy="14156400"/>
           </a:xfrm>
           <a:prstGeom prst="rect">
             <a:avLst/>
@@ -10245,11 +10243,11 @@
         </p:spPr>
         <p:txBody>
           <a:bodyPr anchorCtr="0" anchor="t" bIns="228575" lIns="228575" spcFirstLastPara="1" rIns="228575" wrap="square" tIns="228575">
-            <a:noAutofit/>
+            <a:spAutoFit/>
           </a:bodyPr>
           <a:lstStyle/>
           <a:p>
-            <a:pPr indent="-419100" lvl="0" marL="457200" rtl="0" algn="l">
+            <a:pPr indent="-488950" lvl="0" marL="457200" rtl="0" algn="l">
               <a:lnSpc>
                 <a:spcPct val="115000"/>
               </a:lnSpc>
@@ -10262,12 +10260,12 @@
               <a:buClr>
                 <a:schemeClr val="lt1"/>
               </a:buClr>
-              <a:buSzPts val="3000"/>
+              <a:buSzPts val="4100"/>
               <a:buFont typeface="Helvetica Neue"/>
               <a:buChar char="●"/>
             </a:pPr>
             <a:r>
-              <a:rPr lang="en-US" sz="3000">
+              <a:rPr lang="en-US" sz="4100">
                 <a:solidFill>
                   <a:schemeClr val="lt1"/>
                 </a:solidFill>
@@ -10276,9 +10274,9 @@
                 <a:cs typeface="Helvetica Neue"/>
                 <a:sym typeface="Helvetica Neue"/>
               </a:rPr>
-              <a:t>We made our mock ups in figma</a:t>
+              <a:t>Standalone app</a:t>
             </a:r>
-            <a:endParaRPr sz="3000">
+            <a:endParaRPr sz="4100">
               <a:solidFill>
                 <a:schemeClr val="lt1"/>
               </a:solidFill>
@@ -10289,7 +10287,7 @@
             </a:endParaRPr>
           </a:p>
           <a:p>
-            <a:pPr indent="-419100" lvl="1" marL="914400" rtl="0" algn="l">
+            <a:pPr indent="-488950" lvl="1" marL="914400" rtl="0" algn="l">
               <a:lnSpc>
                 <a:spcPct val="115000"/>
               </a:lnSpc>
@@ -10302,12 +10300,12 @@
               <a:buClr>
                 <a:schemeClr val="lt1"/>
               </a:buClr>
-              <a:buSzPts val="3000"/>
+              <a:buSzPts val="4100"/>
               <a:buFont typeface="Helvetica Neue"/>
               <a:buChar char="○"/>
             </a:pPr>
             <a:r>
-              <a:rPr lang="en-US" sz="3000">
+              <a:rPr lang="en-US" sz="4100">
                 <a:solidFill>
                   <a:schemeClr val="lt1"/>
                 </a:solidFill>
@@ -10316,9 +10314,9 @@
                 <a:cs typeface="Helvetica Neue"/>
                 <a:sym typeface="Helvetica Neue"/>
               </a:rPr>
-              <a:t>it was easy to use and it allowed us to easily collaborate with each other. </a:t>
+              <a:t>Students can get feedback on homework without having to rely on Submitty</a:t>
             </a:r>
-            <a:endParaRPr sz="3000">
+            <a:endParaRPr sz="4100">
               <a:solidFill>
                 <a:schemeClr val="lt1"/>
               </a:solidFill>
@@ -10329,7 +10327,7 @@
             </a:endParaRPr>
           </a:p>
           <a:p>
-            <a:pPr indent="-419100" lvl="0" marL="457200" rtl="0" algn="l">
+            <a:pPr indent="-488950" lvl="0" marL="457200" rtl="0" algn="l">
               <a:lnSpc>
                 <a:spcPct val="115000"/>
               </a:lnSpc>
@@ -10342,12 +10340,12 @@
               <a:buClr>
                 <a:schemeClr val="lt1"/>
               </a:buClr>
-              <a:buSzPts val="3000"/>
+              <a:buSzPts val="4100"/>
               <a:buFont typeface="Helvetica Neue"/>
               <a:buChar char="●"/>
             </a:pPr>
             <a:r>
-              <a:rPr lang="en-US" sz="3000">
+              <a:rPr lang="en-US" sz="4100">
                 <a:solidFill>
                   <a:schemeClr val="lt1"/>
                 </a:solidFill>
@@ -10356,9 +10354,169 @@
                 <a:cs typeface="Helvetica Neue"/>
                 <a:sym typeface="Helvetica Neue"/>
               </a:rPr>
-              <a:t>Our design philosophy when making our frontend was that we wanted to emphasize the discoverability of our application. </a:t>
+              <a:t>Using the Submitty autograder to test and find problems in code can be cumbersome</a:t>
             </a:r>
-            <a:endParaRPr sz="3000">
+            <a:endParaRPr sz="4100">
+              <a:solidFill>
+                <a:schemeClr val="lt1"/>
+              </a:solidFill>
+              <a:latin typeface="Helvetica Neue"/>
+              <a:ea typeface="Helvetica Neue"/>
+              <a:cs typeface="Helvetica Neue"/>
+              <a:sym typeface="Helvetica Neue"/>
+            </a:endParaRPr>
+          </a:p>
+          <a:p>
+            <a:pPr indent="-488950" lvl="1" marL="914400" rtl="0" algn="l">
+              <a:lnSpc>
+                <a:spcPct val="115000"/>
+              </a:lnSpc>
+              <a:spcBef>
+                <a:spcPts val="0"/>
+              </a:spcBef>
+              <a:spcAft>
+                <a:spcPts val="0"/>
+              </a:spcAft>
+              <a:buClr>
+                <a:schemeClr val="lt1"/>
+              </a:buClr>
+              <a:buSzPts val="4100"/>
+              <a:buFont typeface="Helvetica Neue"/>
+              <a:buChar char="○"/>
+            </a:pPr>
+            <a:r>
+              <a:rPr lang="en-US" sz="4100">
+                <a:solidFill>
+                  <a:schemeClr val="lt1"/>
+                </a:solidFill>
+                <a:latin typeface="Helvetica Neue"/>
+                <a:ea typeface="Helvetica Neue"/>
+                <a:cs typeface="Helvetica Neue"/>
+                <a:sym typeface="Helvetica Neue"/>
+              </a:rPr>
+              <a:t>SIFT gives students the tools to get their homeworks graded instantly on their own computers</a:t>
+            </a:r>
+            <a:endParaRPr sz="4100">
+              <a:solidFill>
+                <a:schemeClr val="lt1"/>
+              </a:solidFill>
+              <a:latin typeface="Helvetica Neue"/>
+              <a:ea typeface="Helvetica Neue"/>
+              <a:cs typeface="Helvetica Neue"/>
+              <a:sym typeface="Helvetica Neue"/>
+            </a:endParaRPr>
+          </a:p>
+          <a:p>
+            <a:pPr indent="-488950" lvl="0" marL="457200" rtl="0" algn="l">
+              <a:lnSpc>
+                <a:spcPct val="115000"/>
+              </a:lnSpc>
+              <a:spcBef>
+                <a:spcPts val="0"/>
+              </a:spcBef>
+              <a:spcAft>
+                <a:spcPts val="0"/>
+              </a:spcAft>
+              <a:buClr>
+                <a:schemeClr val="lt1"/>
+              </a:buClr>
+              <a:buSzPts val="4100"/>
+              <a:buFont typeface="Helvetica Neue"/>
+              <a:buChar char="●"/>
+            </a:pPr>
+            <a:r>
+              <a:rPr lang="en-US" sz="4100">
+                <a:solidFill>
+                  <a:schemeClr val="lt1"/>
+                </a:solidFill>
+                <a:latin typeface="Helvetica Neue"/>
+                <a:ea typeface="Helvetica Neue"/>
+                <a:cs typeface="Helvetica Neue"/>
+                <a:sym typeface="Helvetica Neue"/>
+              </a:rPr>
+              <a:t>SIFT runs the user’s source code and shows a comparison between the actual and expected output</a:t>
+            </a:r>
+            <a:endParaRPr sz="4100">
+              <a:solidFill>
+                <a:schemeClr val="lt1"/>
+              </a:solidFill>
+              <a:latin typeface="Helvetica Neue"/>
+              <a:ea typeface="Helvetica Neue"/>
+              <a:cs typeface="Helvetica Neue"/>
+              <a:sym typeface="Helvetica Neue"/>
+            </a:endParaRPr>
+          </a:p>
+          <a:p>
+            <a:pPr indent="-488950" lvl="0" marL="457200" rtl="0" algn="l">
+              <a:lnSpc>
+                <a:spcPct val="115000"/>
+              </a:lnSpc>
+              <a:spcBef>
+                <a:spcPts val="0"/>
+              </a:spcBef>
+              <a:spcAft>
+                <a:spcPts val="0"/>
+              </a:spcAft>
+              <a:buClr>
+                <a:schemeClr val="lt1"/>
+              </a:buClr>
+              <a:buSzPts val="4100"/>
+              <a:buFont typeface="Helvetica Neue"/>
+              <a:buChar char="●"/>
+            </a:pPr>
+            <a:r>
+              <a:rPr lang="en-US" sz="4100">
+                <a:solidFill>
+                  <a:schemeClr val="lt1"/>
+                </a:solidFill>
+                <a:latin typeface="Helvetica Neue"/>
+                <a:ea typeface="Helvetica Neue"/>
+                <a:cs typeface="Helvetica Neue"/>
+                <a:sym typeface="Helvetica Neue"/>
+              </a:rPr>
+              <a:t>Streamlines the process of creating and testing code</a:t>
+            </a:r>
+            <a:endParaRPr sz="4100">
+              <a:solidFill>
+                <a:schemeClr val="lt1"/>
+              </a:solidFill>
+              <a:latin typeface="Helvetica Neue"/>
+              <a:ea typeface="Helvetica Neue"/>
+              <a:cs typeface="Helvetica Neue"/>
+              <a:sym typeface="Helvetica Neue"/>
+            </a:endParaRPr>
+          </a:p>
+          <a:p>
+            <a:pPr indent="-488950" lvl="1" marL="914400" rtl="0" algn="l">
+              <a:lnSpc>
+                <a:spcPct val="115000"/>
+              </a:lnSpc>
+              <a:spcBef>
+                <a:spcPts val="0"/>
+              </a:spcBef>
+              <a:spcAft>
+                <a:spcPts val="0"/>
+              </a:spcAft>
+              <a:buClr>
+                <a:schemeClr val="lt1"/>
+              </a:buClr>
+              <a:buSzPts val="4100"/>
+              <a:buFont typeface="Helvetica Neue"/>
+              <a:buChar char="○"/>
+            </a:pPr>
+            <a:r>
+              <a:rPr lang="en-US" sz="4100">
+                <a:solidFill>
+                  <a:schemeClr val="lt1"/>
+                </a:solidFill>
+                <a:latin typeface="Helvetica Neue"/>
+                <a:ea typeface="Helvetica Neue"/>
+                <a:cs typeface="Helvetica Neue"/>
+                <a:sym typeface="Helvetica Neue"/>
+              </a:rPr>
+              <a:t>Students can spend less time waiting for Submitty, wasting submissions, and instead get quick results and keep working</a:t>
+            </a:r>
+            <a:endParaRPr sz="4100">
               <a:solidFill>
                 <a:schemeClr val="lt1"/>
               </a:solidFill>
@@ -10375,13 +10533,161 @@
           <p:cNvPr id="42" name="Google Shape;42;p1"/>
           <p:cNvSpPr txBox="1"/>
           <p:nvPr>
+            <p:ph idx="9" type="body"/>
+          </p:nvPr>
+        </p:nvSpPr>
+        <p:spPr>
+          <a:xfrm>
+            <a:off x="33405900" y="6352650"/>
+            <a:ext cx="10047000" cy="3668100"/>
+          </a:xfrm>
+          <a:prstGeom prst="rect">
+            <a:avLst/>
+          </a:prstGeom>
+          <a:noFill/>
+          <a:ln>
+            <a:noFill/>
+          </a:ln>
+        </p:spPr>
+        <p:txBody>
+          <a:bodyPr anchorCtr="0" anchor="t" bIns="228575" lIns="228575" spcFirstLastPara="1" rIns="228575" wrap="square" tIns="228575">
+            <a:noAutofit/>
+          </a:bodyPr>
+          <a:lstStyle/>
+          <a:p>
+            <a:pPr indent="-476250" lvl="0" marL="457200" rtl="0" algn="l">
+              <a:lnSpc>
+                <a:spcPct val="115000"/>
+              </a:lnSpc>
+              <a:spcBef>
+                <a:spcPts val="0"/>
+              </a:spcBef>
+              <a:spcAft>
+                <a:spcPts val="0"/>
+              </a:spcAft>
+              <a:buClr>
+                <a:schemeClr val="lt1"/>
+              </a:buClr>
+              <a:buSzPts val="3900"/>
+              <a:buFont typeface="Helvetica Neue"/>
+              <a:buChar char="●"/>
+            </a:pPr>
+            <a:r>
+              <a:rPr lang="en-US" sz="3900">
+                <a:solidFill>
+                  <a:schemeClr val="lt1"/>
+                </a:solidFill>
+                <a:latin typeface="Helvetica Neue"/>
+                <a:ea typeface="Helvetica Neue"/>
+                <a:cs typeface="Helvetica Neue"/>
+                <a:sym typeface="Helvetica Neue"/>
+              </a:rPr>
+              <a:t>We made our mock ups in figma</a:t>
+            </a:r>
+            <a:endParaRPr sz="3900">
+              <a:solidFill>
+                <a:schemeClr val="lt1"/>
+              </a:solidFill>
+              <a:latin typeface="Helvetica Neue"/>
+              <a:ea typeface="Helvetica Neue"/>
+              <a:cs typeface="Helvetica Neue"/>
+              <a:sym typeface="Helvetica Neue"/>
+            </a:endParaRPr>
+          </a:p>
+          <a:p>
+            <a:pPr indent="-476250" lvl="1" marL="914400" rtl="0" algn="l">
+              <a:lnSpc>
+                <a:spcPct val="115000"/>
+              </a:lnSpc>
+              <a:spcBef>
+                <a:spcPts val="0"/>
+              </a:spcBef>
+              <a:spcAft>
+                <a:spcPts val="0"/>
+              </a:spcAft>
+              <a:buClr>
+                <a:schemeClr val="lt1"/>
+              </a:buClr>
+              <a:buSzPts val="3900"/>
+              <a:buFont typeface="Helvetica Neue"/>
+              <a:buChar char="○"/>
+            </a:pPr>
+            <a:r>
+              <a:rPr lang="en-US" sz="3900">
+                <a:solidFill>
+                  <a:schemeClr val="lt1"/>
+                </a:solidFill>
+                <a:latin typeface="Helvetica Neue"/>
+                <a:ea typeface="Helvetica Neue"/>
+                <a:cs typeface="Helvetica Neue"/>
+                <a:sym typeface="Helvetica Neue"/>
+              </a:rPr>
+              <a:t>it was easy to use and it allowed us to easily collaborate with each other. </a:t>
+            </a:r>
+            <a:endParaRPr sz="3900">
+              <a:solidFill>
+                <a:schemeClr val="lt1"/>
+              </a:solidFill>
+              <a:latin typeface="Helvetica Neue"/>
+              <a:ea typeface="Helvetica Neue"/>
+              <a:cs typeface="Helvetica Neue"/>
+              <a:sym typeface="Helvetica Neue"/>
+            </a:endParaRPr>
+          </a:p>
+          <a:p>
+            <a:pPr indent="-476250" lvl="0" marL="457200" rtl="0" algn="l">
+              <a:lnSpc>
+                <a:spcPct val="115000"/>
+              </a:lnSpc>
+              <a:spcBef>
+                <a:spcPts val="0"/>
+              </a:spcBef>
+              <a:spcAft>
+                <a:spcPts val="0"/>
+              </a:spcAft>
+              <a:buClr>
+                <a:schemeClr val="lt1"/>
+              </a:buClr>
+              <a:buSzPts val="3900"/>
+              <a:buFont typeface="Helvetica Neue"/>
+              <a:buChar char="●"/>
+            </a:pPr>
+            <a:r>
+              <a:rPr lang="en-US" sz="3900">
+                <a:solidFill>
+                  <a:schemeClr val="lt1"/>
+                </a:solidFill>
+                <a:latin typeface="Helvetica Neue"/>
+                <a:ea typeface="Helvetica Neue"/>
+                <a:cs typeface="Helvetica Neue"/>
+                <a:sym typeface="Helvetica Neue"/>
+              </a:rPr>
+              <a:t>Our design philosophy when making our frontend was that we wanted to emphasize the discoverability of our application. </a:t>
+            </a:r>
+            <a:endParaRPr sz="3900">
+              <a:solidFill>
+                <a:schemeClr val="lt1"/>
+              </a:solidFill>
+              <a:latin typeface="Helvetica Neue"/>
+              <a:ea typeface="Helvetica Neue"/>
+              <a:cs typeface="Helvetica Neue"/>
+              <a:sym typeface="Helvetica Neue"/>
+            </a:endParaRPr>
+          </a:p>
+        </p:txBody>
+      </p:sp>
+      <p:sp>
+        <p:nvSpPr>
+          <p:cNvPr id="43" name="Google Shape;43;p1"/>
+          <p:cNvSpPr txBox="1"/>
+          <p:nvPr>
             <p:ph idx="2" type="body"/>
           </p:nvPr>
         </p:nvSpPr>
         <p:spPr>
           <a:xfrm>
             <a:off x="477827" y="5548749"/>
-            <a:ext cx="10048800" cy="877200"/>
+            <a:ext cx="10048800" cy="908100"/>
           </a:xfrm>
           <a:prstGeom prst="rect">
             <a:avLst/>
@@ -10411,7 +10717,7 @@
               <a:buNone/>
             </a:pPr>
             <a:r>
-              <a:rPr lang="en-US" sz="4500">
+              <a:rPr lang="en-US" sz="4700">
                 <a:solidFill>
                   <a:schemeClr val="lt1"/>
                 </a:solidFill>
@@ -10422,7 +10728,7 @@
               </a:rPr>
               <a:t>Introduction</a:t>
             </a:r>
-            <a:endParaRPr sz="4500">
+            <a:endParaRPr sz="4700">
               <a:solidFill>
                 <a:schemeClr val="lt1"/>
               </a:solidFill>
@@ -10436,13 +10742,13 @@
       </p:sp>
       <p:sp>
         <p:nvSpPr>
-          <p:cNvPr id="43" name="Google Shape;43;p1"/>
+          <p:cNvPr id="44" name="Google Shape;44;p1"/>
           <p:cNvSpPr/>
           <p:nvPr/>
         </p:nvSpPr>
         <p:spPr>
           <a:xfrm>
-            <a:off x="11711350" y="16952575"/>
+            <a:off x="11746475" y="17008525"/>
             <a:ext cx="20582400" cy="14338500"/>
           </a:xfrm>
           <a:prstGeom prst="rect">
@@ -10481,7 +10787,7 @@
       </p:sp>
       <p:sp>
         <p:nvSpPr>
-          <p:cNvPr id="44" name="Google Shape;44;p1"/>
+          <p:cNvPr id="45" name="Google Shape;45;p1"/>
           <p:cNvSpPr txBox="1"/>
           <p:nvPr>
             <p:ph idx="3" type="body"/>
@@ -10489,8 +10795,8 @@
         </p:nvSpPr>
         <p:spPr>
           <a:xfrm>
-            <a:off x="17410138" y="17008513"/>
-            <a:ext cx="10050600" cy="877200"/>
+            <a:off x="16824188" y="17140563"/>
+            <a:ext cx="10050600" cy="908100"/>
           </a:xfrm>
           <a:prstGeom prst="rect">
             <a:avLst/>
@@ -10520,7 +10826,7 @@
               <a:buNone/>
             </a:pPr>
             <a:r>
-              <a:rPr lang="en-US" sz="4500">
+              <a:rPr lang="en-US" sz="4700">
                 <a:solidFill>
                   <a:schemeClr val="lt1"/>
                 </a:solidFill>
@@ -10531,7 +10837,7 @@
               </a:rPr>
               <a:t>Visuals</a:t>
             </a:r>
-            <a:endParaRPr sz="4500">
+            <a:endParaRPr sz="4700">
               <a:solidFill>
                 <a:schemeClr val="lt1"/>
               </a:solidFill>
@@ -10545,7 +10851,7 @@
       </p:sp>
       <p:sp>
         <p:nvSpPr>
-          <p:cNvPr id="45" name="Google Shape;45;p1"/>
+          <p:cNvPr id="46" name="Google Shape;46;p1"/>
           <p:cNvSpPr txBox="1"/>
           <p:nvPr>
             <p:ph idx="5" type="body"/>
@@ -10554,7 +10860,7 @@
         <p:spPr>
           <a:xfrm>
             <a:off x="11655687" y="5548749"/>
-            <a:ext cx="10048800" cy="877200"/>
+            <a:ext cx="10048800" cy="908100"/>
           </a:xfrm>
           <a:prstGeom prst="rect">
             <a:avLst/>
@@ -10584,7 +10890,7 @@
               <a:buNone/>
             </a:pPr>
             <a:r>
-              <a:rPr lang="en-US" sz="4500">
+              <a:rPr lang="en-US" sz="4700">
                 <a:solidFill>
                   <a:schemeClr val="lt1"/>
                 </a:solidFill>
@@ -10595,7 +10901,7 @@
               </a:rPr>
               <a:t>Objectives</a:t>
             </a:r>
-            <a:endParaRPr sz="4500">
+            <a:endParaRPr sz="4700">
               <a:solidFill>
                 <a:schemeClr val="lt1"/>
               </a:solidFill>
@@ -10609,7 +10915,7 @@
       </p:sp>
       <p:pic>
         <p:nvPicPr>
-          <p:cNvPr id="46" name="Google Shape;46;p1"/>
+          <p:cNvPr id="47" name="Google Shape;47;p1"/>
           <p:cNvPicPr preferRelativeResize="0"/>
           <p:nvPr/>
         </p:nvPicPr>
@@ -10637,7 +10943,7 @@
       </p:pic>
       <p:sp>
         <p:nvSpPr>
-          <p:cNvPr id="47" name="Google Shape;47;p1"/>
+          <p:cNvPr id="48" name="Google Shape;48;p1"/>
           <p:cNvSpPr/>
           <p:nvPr/>
         </p:nvSpPr>
@@ -10682,766 +10988,7 @@
       </p:sp>
       <p:sp>
         <p:nvSpPr>
-          <p:cNvPr id="48" name="Google Shape;48;p1"/>
-          <p:cNvSpPr txBox="1"/>
-          <p:nvPr>
-            <p:ph idx="7" type="body"/>
-          </p:nvPr>
-        </p:nvSpPr>
-        <p:spPr>
-          <a:xfrm>
-            <a:off x="23563850" y="5548750"/>
-            <a:ext cx="7410900" cy="877200"/>
-          </a:xfrm>
-          <a:prstGeom prst="rect">
-            <a:avLst/>
-          </a:prstGeom>
-          <a:noFill/>
-          <a:ln>
-            <a:noFill/>
-          </a:ln>
-        </p:spPr>
-        <p:txBody>
-          <a:bodyPr anchorCtr="0" anchor="ctr" bIns="91425" lIns="91425" spcFirstLastPara="1" rIns="91425" wrap="square" tIns="91425">
-            <a:spAutoFit/>
-          </a:bodyPr>
-          <a:lstStyle/>
-          <a:p>
-            <a:pPr indent="0" lvl="0" marL="0" rtl="0" algn="ctr">
-              <a:spcBef>
-                <a:spcPts val="0"/>
-              </a:spcBef>
-              <a:spcAft>
-                <a:spcPts val="0"/>
-              </a:spcAft>
-              <a:buClr>
-                <a:srgbClr val="1F3864"/>
-              </a:buClr>
-              <a:buSzPts val="3700"/>
-              <a:buNone/>
-            </a:pPr>
-            <a:r>
-              <a:rPr lang="en-US" sz="4500">
-                <a:solidFill>
-                  <a:schemeClr val="lt1"/>
-                </a:solidFill>
-                <a:latin typeface="Helvetica Neue"/>
-                <a:ea typeface="Helvetica Neue"/>
-                <a:cs typeface="Helvetica Neue"/>
-                <a:sym typeface="Helvetica Neue"/>
-              </a:rPr>
-              <a:t>Materials and Methods</a:t>
-            </a:r>
-            <a:endParaRPr sz="4500">
-              <a:solidFill>
-                <a:schemeClr val="lt1"/>
-              </a:solidFill>
-              <a:latin typeface="Helvetica Neue"/>
-              <a:ea typeface="Helvetica Neue"/>
-              <a:cs typeface="Helvetica Neue"/>
-              <a:sym typeface="Helvetica Neue"/>
-            </a:endParaRPr>
-          </a:p>
-        </p:txBody>
-      </p:sp>
-      <p:sp>
-        <p:nvSpPr>
           <p:cNvPr id="49" name="Google Shape;49;p1"/>
-          <p:cNvSpPr txBox="1"/>
-          <p:nvPr>
-            <p:ph idx="8" type="body"/>
-          </p:nvPr>
-        </p:nvSpPr>
-        <p:spPr>
-          <a:xfrm>
-            <a:off x="33492342" y="5548749"/>
-            <a:ext cx="10047000" cy="877200"/>
-          </a:xfrm>
-          <a:prstGeom prst="rect">
-            <a:avLst/>
-          </a:prstGeom>
-          <a:noFill/>
-          <a:ln>
-            <a:noFill/>
-          </a:ln>
-        </p:spPr>
-        <p:txBody>
-          <a:bodyPr anchorCtr="0" anchor="ctr" bIns="91425" lIns="91425" spcFirstLastPara="1" rIns="91425" wrap="square" tIns="91425">
-            <a:spAutoFit/>
-          </a:bodyPr>
-          <a:lstStyle/>
-          <a:p>
-            <a:pPr indent="0" lvl="0" marL="0" rtl="0" algn="ctr">
-              <a:spcBef>
-                <a:spcPts val="0"/>
-              </a:spcBef>
-              <a:spcAft>
-                <a:spcPts val="0"/>
-              </a:spcAft>
-              <a:buClr>
-                <a:srgbClr val="1F3864"/>
-              </a:buClr>
-              <a:buSzPts val="3700"/>
-              <a:buNone/>
-            </a:pPr>
-            <a:r>
-              <a:rPr lang="en-US" sz="4500">
-                <a:solidFill>
-                  <a:schemeClr val="lt1"/>
-                </a:solidFill>
-                <a:latin typeface="Helvetica Neue"/>
-                <a:ea typeface="Helvetica Neue"/>
-                <a:cs typeface="Helvetica Neue"/>
-                <a:sym typeface="Helvetica Neue"/>
-              </a:rPr>
-              <a:t>Frontend/UI</a:t>
-            </a:r>
-            <a:endParaRPr sz="4500">
-              <a:solidFill>
-                <a:schemeClr val="lt1"/>
-              </a:solidFill>
-              <a:latin typeface="Helvetica Neue"/>
-              <a:ea typeface="Helvetica Neue"/>
-              <a:cs typeface="Helvetica Neue"/>
-              <a:sym typeface="Helvetica Neue"/>
-            </a:endParaRPr>
-          </a:p>
-        </p:txBody>
-      </p:sp>
-      <p:sp>
-        <p:nvSpPr>
-          <p:cNvPr id="50" name="Google Shape;50;p1"/>
-          <p:cNvSpPr txBox="1"/>
-          <p:nvPr>
-            <p:ph idx="13" type="body"/>
-          </p:nvPr>
-        </p:nvSpPr>
-        <p:spPr>
-          <a:xfrm>
-            <a:off x="33387742" y="19165513"/>
-            <a:ext cx="10047000" cy="877200"/>
-          </a:xfrm>
-          <a:prstGeom prst="rect">
-            <a:avLst/>
-          </a:prstGeom>
-          <a:noFill/>
-          <a:ln>
-            <a:noFill/>
-          </a:ln>
-        </p:spPr>
-        <p:txBody>
-          <a:bodyPr anchorCtr="0" anchor="ctr" bIns="91425" lIns="91425" spcFirstLastPara="1" rIns="91425" wrap="square" tIns="91425">
-            <a:spAutoFit/>
-          </a:bodyPr>
-          <a:lstStyle/>
-          <a:p>
-            <a:pPr indent="0" lvl="0" marL="0" rtl="0" algn="ctr">
-              <a:spcBef>
-                <a:spcPts val="0"/>
-              </a:spcBef>
-              <a:spcAft>
-                <a:spcPts val="0"/>
-              </a:spcAft>
-              <a:buClr>
-                <a:srgbClr val="1F3864"/>
-              </a:buClr>
-              <a:buSzPts val="3700"/>
-              <a:buNone/>
-            </a:pPr>
-            <a:r>
-              <a:rPr lang="en-US" sz="4500">
-                <a:solidFill>
-                  <a:schemeClr val="lt1"/>
-                </a:solidFill>
-                <a:latin typeface="Helvetica Neue"/>
-                <a:ea typeface="Helvetica Neue"/>
-                <a:cs typeface="Helvetica Neue"/>
-                <a:sym typeface="Helvetica Neue"/>
-              </a:rPr>
-              <a:t>Future Goals</a:t>
-            </a:r>
-            <a:endParaRPr sz="4500">
-              <a:solidFill>
-                <a:schemeClr val="lt1"/>
-              </a:solidFill>
-              <a:latin typeface="Helvetica Neue"/>
-              <a:ea typeface="Helvetica Neue"/>
-              <a:cs typeface="Helvetica Neue"/>
-              <a:sym typeface="Helvetica Neue"/>
-            </a:endParaRPr>
-          </a:p>
-        </p:txBody>
-      </p:sp>
-      <p:sp>
-        <p:nvSpPr>
-          <p:cNvPr id="51" name="Google Shape;51;p1"/>
-          <p:cNvSpPr txBox="1"/>
-          <p:nvPr>
-            <p:ph idx="14" type="body"/>
-          </p:nvPr>
-        </p:nvSpPr>
-        <p:spPr>
-          <a:xfrm>
-            <a:off x="33387750" y="19827975"/>
-            <a:ext cx="10052100" cy="6926400"/>
-          </a:xfrm>
-          <a:prstGeom prst="rect">
-            <a:avLst/>
-          </a:prstGeom>
-          <a:noFill/>
-          <a:ln>
-            <a:noFill/>
-          </a:ln>
-        </p:spPr>
-        <p:txBody>
-          <a:bodyPr anchorCtr="0" anchor="t" bIns="228575" lIns="228575" spcFirstLastPara="1" rIns="228575" wrap="square" tIns="228575">
-            <a:spAutoFit/>
-          </a:bodyPr>
-          <a:lstStyle/>
-          <a:p>
-            <a:pPr indent="0" lvl="0" marL="0" rtl="0" algn="l">
-              <a:spcBef>
-                <a:spcPts val="0"/>
-              </a:spcBef>
-              <a:spcAft>
-                <a:spcPts val="0"/>
-              </a:spcAft>
-              <a:buClr>
-                <a:schemeClr val="dk1"/>
-              </a:buClr>
-              <a:buSzPts val="1100"/>
-              <a:buFont typeface="Arial"/>
-              <a:buNone/>
-            </a:pPr>
-            <a:r>
-              <a:rPr lang="en-US" sz="3000">
-                <a:solidFill>
-                  <a:schemeClr val="lt1"/>
-                </a:solidFill>
-                <a:latin typeface="Helvetica Neue"/>
-                <a:ea typeface="Helvetica Neue"/>
-                <a:cs typeface="Helvetica Neue"/>
-                <a:sym typeface="Helvetica Neue"/>
-              </a:rPr>
-              <a:t>Some of the ideas and goals we have for the future include:</a:t>
-            </a:r>
-            <a:endParaRPr sz="3000">
-              <a:solidFill>
-                <a:schemeClr val="lt1"/>
-              </a:solidFill>
-              <a:latin typeface="Helvetica Neue"/>
-              <a:ea typeface="Helvetica Neue"/>
-              <a:cs typeface="Helvetica Neue"/>
-              <a:sym typeface="Helvetica Neue"/>
-            </a:endParaRPr>
-          </a:p>
-          <a:p>
-            <a:pPr indent="-419100" lvl="0" marL="457200" rtl="0" algn="l">
-              <a:spcBef>
-                <a:spcPts val="0"/>
-              </a:spcBef>
-              <a:spcAft>
-                <a:spcPts val="0"/>
-              </a:spcAft>
-              <a:buClr>
-                <a:schemeClr val="lt1"/>
-              </a:buClr>
-              <a:buSzPts val="3000"/>
-              <a:buFont typeface="Helvetica Neue"/>
-              <a:buChar char="●"/>
-            </a:pPr>
-            <a:r>
-              <a:rPr lang="en-US" sz="3000">
-                <a:solidFill>
-                  <a:schemeClr val="lt1"/>
-                </a:solidFill>
-                <a:latin typeface="Helvetica Neue"/>
-                <a:ea typeface="Helvetica Neue"/>
-                <a:cs typeface="Helvetica Neue"/>
-                <a:sym typeface="Helvetica Neue"/>
-              </a:rPr>
-              <a:t>Allowing users to select individual courses and have all the necessary resources already available for them without extra downloads</a:t>
-            </a:r>
-            <a:endParaRPr sz="3000">
-              <a:solidFill>
-                <a:schemeClr val="lt1"/>
-              </a:solidFill>
-              <a:latin typeface="Helvetica Neue"/>
-              <a:ea typeface="Helvetica Neue"/>
-              <a:cs typeface="Helvetica Neue"/>
-              <a:sym typeface="Helvetica Neue"/>
-            </a:endParaRPr>
-          </a:p>
-          <a:p>
-            <a:pPr indent="-419100" lvl="0" marL="457200" rtl="0" algn="l">
-              <a:spcBef>
-                <a:spcPts val="0"/>
-              </a:spcBef>
-              <a:spcAft>
-                <a:spcPts val="0"/>
-              </a:spcAft>
-              <a:buClr>
-                <a:schemeClr val="lt1"/>
-              </a:buClr>
-              <a:buSzPts val="3000"/>
-              <a:buFont typeface="Helvetica Neue"/>
-              <a:buChar char="●"/>
-            </a:pPr>
-            <a:r>
-              <a:rPr lang="en-US" sz="3000">
-                <a:solidFill>
-                  <a:schemeClr val="lt1"/>
-                </a:solidFill>
-                <a:latin typeface="Helvetica Neue"/>
-                <a:ea typeface="Helvetica Neue"/>
-                <a:cs typeface="Helvetica Neue"/>
-                <a:sym typeface="Helvetica Neue"/>
-              </a:rPr>
-              <a:t>Allowing professors to upload materials and manage their courses on the app to allow the features mentioned above</a:t>
-            </a:r>
-            <a:endParaRPr sz="3000">
-              <a:solidFill>
-                <a:schemeClr val="lt1"/>
-              </a:solidFill>
-              <a:latin typeface="Helvetica Neue"/>
-              <a:ea typeface="Helvetica Neue"/>
-              <a:cs typeface="Helvetica Neue"/>
-              <a:sym typeface="Helvetica Neue"/>
-            </a:endParaRPr>
-          </a:p>
-          <a:p>
-            <a:pPr indent="-419100" lvl="0" marL="457200" rtl="0" algn="l">
-              <a:spcBef>
-                <a:spcPts val="0"/>
-              </a:spcBef>
-              <a:spcAft>
-                <a:spcPts val="0"/>
-              </a:spcAft>
-              <a:buClr>
-                <a:schemeClr val="lt1"/>
-              </a:buClr>
-              <a:buSzPts val="3000"/>
-              <a:buFont typeface="Helvetica Neue"/>
-              <a:buChar char="●"/>
-            </a:pPr>
-            <a:r>
-              <a:rPr lang="en-US" sz="3000">
-                <a:solidFill>
-                  <a:schemeClr val="lt1"/>
-                </a:solidFill>
-                <a:latin typeface="Helvetica Neue"/>
-                <a:ea typeface="Helvetica Neue"/>
-                <a:cs typeface="Helvetica Neue"/>
-                <a:sym typeface="Helvetica Neue"/>
-              </a:rPr>
-              <a:t>Incorporate AI for giving users feedback and tips on how to improve their code/coding habits</a:t>
-            </a:r>
-            <a:endParaRPr sz="3000">
-              <a:solidFill>
-                <a:schemeClr val="lt1"/>
-              </a:solidFill>
-              <a:latin typeface="Helvetica Neue"/>
-              <a:ea typeface="Helvetica Neue"/>
-              <a:cs typeface="Helvetica Neue"/>
-              <a:sym typeface="Helvetica Neue"/>
-            </a:endParaRPr>
-          </a:p>
-          <a:p>
-            <a:pPr indent="-419100" lvl="0" marL="457200" rtl="0" algn="l">
-              <a:spcBef>
-                <a:spcPts val="0"/>
-              </a:spcBef>
-              <a:spcAft>
-                <a:spcPts val="0"/>
-              </a:spcAft>
-              <a:buClr>
-                <a:schemeClr val="lt1"/>
-              </a:buClr>
-              <a:buSzPts val="3000"/>
-              <a:buFont typeface="Helvetica Neue"/>
-              <a:buChar char="●"/>
-            </a:pPr>
-            <a:r>
-              <a:rPr lang="en-US" sz="3000">
-                <a:solidFill>
-                  <a:schemeClr val="lt1"/>
-                </a:solidFill>
-                <a:latin typeface="Helvetica Neue"/>
-                <a:ea typeface="Helvetica Neue"/>
-                <a:cs typeface="Helvetica Neue"/>
-                <a:sym typeface="Helvetica Neue"/>
-              </a:rPr>
-              <a:t>Possibly creating a better UI from scratch for more control and more flexible aesthetics</a:t>
-            </a:r>
-            <a:endParaRPr sz="3000">
-              <a:solidFill>
-                <a:schemeClr val="lt1"/>
-              </a:solidFill>
-              <a:latin typeface="Helvetica Neue"/>
-              <a:ea typeface="Helvetica Neue"/>
-              <a:cs typeface="Helvetica Neue"/>
-              <a:sym typeface="Helvetica Neue"/>
-            </a:endParaRPr>
-          </a:p>
-          <a:p>
-            <a:pPr indent="-419100" lvl="0" marL="457200" rtl="0" algn="l">
-              <a:spcBef>
-                <a:spcPts val="0"/>
-              </a:spcBef>
-              <a:spcAft>
-                <a:spcPts val="0"/>
-              </a:spcAft>
-              <a:buClr>
-                <a:schemeClr val="lt1"/>
-              </a:buClr>
-              <a:buSzPts val="3000"/>
-              <a:buFont typeface="Helvetica Neue"/>
-              <a:buChar char="●"/>
-            </a:pPr>
-            <a:r>
-              <a:rPr lang="en-US" sz="3000">
-                <a:solidFill>
-                  <a:schemeClr val="lt1"/>
-                </a:solidFill>
-                <a:latin typeface="Helvetica Neue"/>
-                <a:ea typeface="Helvetica Neue"/>
-                <a:cs typeface="Helvetica Neue"/>
-                <a:sym typeface="Helvetica Neue"/>
-              </a:rPr>
-              <a:t>Make </a:t>
-            </a:r>
-            <a:r>
-              <a:rPr lang="en-US" sz="3000">
-                <a:solidFill>
-                  <a:schemeClr val="lt1"/>
-                </a:solidFill>
-                <a:latin typeface="Helvetica Neue"/>
-                <a:ea typeface="Helvetica Neue"/>
-                <a:cs typeface="Helvetica Neue"/>
-                <a:sym typeface="Helvetica Neue"/>
-              </a:rPr>
-              <a:t>the</a:t>
-            </a:r>
-            <a:r>
-              <a:rPr lang="en-US" sz="3000">
-                <a:solidFill>
-                  <a:schemeClr val="lt1"/>
-                </a:solidFill>
-                <a:latin typeface="Helvetica Neue"/>
-                <a:ea typeface="Helvetica Neue"/>
-                <a:cs typeface="Helvetica Neue"/>
-                <a:sym typeface="Helvetica Neue"/>
-              </a:rPr>
-              <a:t> app distributable (through platforms such as Docker)</a:t>
-            </a:r>
-            <a:endParaRPr sz="3000">
-              <a:solidFill>
-                <a:schemeClr val="lt1"/>
-              </a:solidFill>
-              <a:latin typeface="Helvetica Neue"/>
-              <a:ea typeface="Helvetica Neue"/>
-              <a:cs typeface="Helvetica Neue"/>
-              <a:sym typeface="Helvetica Neue"/>
-            </a:endParaRPr>
-          </a:p>
-        </p:txBody>
-      </p:sp>
-      <p:sp>
-        <p:nvSpPr>
-          <p:cNvPr id="52" name="Google Shape;52;p1"/>
-          <p:cNvSpPr txBox="1"/>
-          <p:nvPr>
-            <p:ph idx="15" type="body"/>
-          </p:nvPr>
-        </p:nvSpPr>
-        <p:spPr>
-          <a:xfrm>
-            <a:off x="33390292" y="27584401"/>
-            <a:ext cx="10047000" cy="877200"/>
-          </a:xfrm>
-          <a:prstGeom prst="rect">
-            <a:avLst/>
-          </a:prstGeom>
-          <a:noFill/>
-          <a:ln>
-            <a:noFill/>
-          </a:ln>
-        </p:spPr>
-        <p:txBody>
-          <a:bodyPr anchorCtr="0" anchor="ctr" bIns="91425" lIns="91425" spcFirstLastPara="1" rIns="91425" wrap="square" tIns="91425">
-            <a:spAutoFit/>
-          </a:bodyPr>
-          <a:lstStyle/>
-          <a:p>
-            <a:pPr indent="0" lvl="0" marL="0" rtl="0" algn="ctr">
-              <a:spcBef>
-                <a:spcPts val="0"/>
-              </a:spcBef>
-              <a:spcAft>
-                <a:spcPts val="0"/>
-              </a:spcAft>
-              <a:buClr>
-                <a:srgbClr val="1F3864"/>
-              </a:buClr>
-              <a:buSzPts val="3700"/>
-              <a:buNone/>
-            </a:pPr>
-            <a:r>
-              <a:rPr lang="en-US" sz="4500">
-                <a:solidFill>
-                  <a:schemeClr val="lt1"/>
-                </a:solidFill>
-                <a:latin typeface="Helvetica Neue"/>
-                <a:ea typeface="Helvetica Neue"/>
-                <a:cs typeface="Helvetica Neue"/>
-                <a:sym typeface="Helvetica Neue"/>
-              </a:rPr>
-              <a:t>Acknowledgements</a:t>
-            </a:r>
-            <a:endParaRPr sz="4500">
-              <a:solidFill>
-                <a:schemeClr val="lt1"/>
-              </a:solidFill>
-              <a:latin typeface="Helvetica Neue"/>
-              <a:ea typeface="Helvetica Neue"/>
-              <a:cs typeface="Helvetica Neue"/>
-              <a:sym typeface="Helvetica Neue"/>
-            </a:endParaRPr>
-          </a:p>
-        </p:txBody>
-      </p:sp>
-      <p:sp>
-        <p:nvSpPr>
-          <p:cNvPr id="53" name="Google Shape;53;p1"/>
-          <p:cNvSpPr txBox="1"/>
-          <p:nvPr>
-            <p:ph idx="16" type="body"/>
-          </p:nvPr>
-        </p:nvSpPr>
-        <p:spPr>
-          <a:xfrm>
-            <a:off x="33466500" y="28338451"/>
-            <a:ext cx="10052100" cy="1454400"/>
-          </a:xfrm>
-          <a:prstGeom prst="rect">
-            <a:avLst/>
-          </a:prstGeom>
-          <a:noFill/>
-          <a:ln>
-            <a:noFill/>
-          </a:ln>
-        </p:spPr>
-        <p:txBody>
-          <a:bodyPr anchorCtr="0" anchor="t" bIns="228575" lIns="228575" spcFirstLastPara="1" rIns="228575" wrap="square" tIns="228575">
-            <a:spAutoFit/>
-          </a:bodyPr>
-          <a:lstStyle/>
-          <a:p>
-            <a:pPr indent="-419100" lvl="0" marL="457200" rtl="0" algn="l">
-              <a:lnSpc>
-                <a:spcPct val="115000"/>
-              </a:lnSpc>
-              <a:spcBef>
-                <a:spcPts val="0"/>
-              </a:spcBef>
-              <a:spcAft>
-                <a:spcPts val="0"/>
-              </a:spcAft>
-              <a:buClr>
-                <a:schemeClr val="lt1"/>
-              </a:buClr>
-              <a:buSzPts val="3000"/>
-              <a:buFont typeface="Helvetica Neue"/>
-              <a:buChar char="●"/>
-            </a:pPr>
-            <a:r>
-              <a:t/>
-            </a:r>
-            <a:endParaRPr sz="3000">
-              <a:solidFill>
-                <a:schemeClr val="lt1"/>
-              </a:solidFill>
-              <a:latin typeface="Helvetica Neue"/>
-              <a:ea typeface="Helvetica Neue"/>
-              <a:cs typeface="Helvetica Neue"/>
-              <a:sym typeface="Helvetica Neue"/>
-            </a:endParaRPr>
-          </a:p>
-          <a:p>
-            <a:pPr indent="-419100" lvl="0" marL="457200" rtl="0" algn="l">
-              <a:lnSpc>
-                <a:spcPct val="115000"/>
-              </a:lnSpc>
-              <a:spcBef>
-                <a:spcPts val="0"/>
-              </a:spcBef>
-              <a:spcAft>
-                <a:spcPts val="0"/>
-              </a:spcAft>
-              <a:buClr>
-                <a:schemeClr val="lt1"/>
-              </a:buClr>
-              <a:buSzPts val="3000"/>
-              <a:buFont typeface="Helvetica Neue"/>
-              <a:buChar char="●"/>
-            </a:pPr>
-            <a:r>
-              <a:rPr lang="en-US" sz="3000">
-                <a:solidFill>
-                  <a:schemeClr val="lt1"/>
-                </a:solidFill>
-                <a:latin typeface="Helvetica Neue"/>
-                <a:ea typeface="Helvetica Neue"/>
-                <a:cs typeface="Helvetica Neue"/>
-                <a:sym typeface="Helvetica Neue"/>
-              </a:rPr>
-              <a:t>RCOS professors, coordinators, and mentors</a:t>
-            </a:r>
-            <a:endParaRPr sz="3000">
-              <a:solidFill>
-                <a:schemeClr val="lt1"/>
-              </a:solidFill>
-              <a:latin typeface="Helvetica Neue"/>
-              <a:ea typeface="Helvetica Neue"/>
-              <a:cs typeface="Helvetica Neue"/>
-              <a:sym typeface="Helvetica Neue"/>
-            </a:endParaRPr>
-          </a:p>
-        </p:txBody>
-      </p:sp>
-      <p:sp>
-        <p:nvSpPr>
-          <p:cNvPr id="54" name="Google Shape;54;p1"/>
-          <p:cNvSpPr txBox="1"/>
-          <p:nvPr>
-            <p:ph idx="19" type="body"/>
-          </p:nvPr>
-        </p:nvSpPr>
-        <p:spPr>
-          <a:xfrm>
-            <a:off x="5932593" y="2789587"/>
-            <a:ext cx="31998900" cy="1280100"/>
-          </a:xfrm>
-          <a:prstGeom prst="rect">
-            <a:avLst/>
-          </a:prstGeom>
-          <a:noFill/>
-          <a:ln>
-            <a:noFill/>
-          </a:ln>
-        </p:spPr>
-        <p:txBody>
-          <a:bodyPr anchorCtr="1" anchor="t" bIns="45700" lIns="91425" spcFirstLastPara="1" rIns="91425" wrap="square" tIns="45700">
-            <a:normAutofit fontScale="85000"/>
-          </a:bodyPr>
-          <a:lstStyle/>
-          <a:p>
-            <a:pPr indent="0" lvl="0" marL="0" rtl="0" algn="ctr">
-              <a:spcBef>
-                <a:spcPts val="0"/>
-              </a:spcBef>
-              <a:spcAft>
-                <a:spcPts val="0"/>
-              </a:spcAft>
-              <a:buClr>
-                <a:srgbClr val="1F3864"/>
-              </a:buClr>
-              <a:buSzPct val="100000"/>
-              <a:buFont typeface="Calibri"/>
-              <a:buNone/>
-            </a:pPr>
-            <a:r>
-              <a:rPr i="1" lang="en-US">
-                <a:solidFill>
-                  <a:schemeClr val="lt1"/>
-                </a:solidFill>
-                <a:latin typeface="Helvetica Neue"/>
-                <a:ea typeface="Helvetica Neue"/>
-                <a:cs typeface="Helvetica Neue"/>
-                <a:sym typeface="Helvetica Neue"/>
-              </a:rPr>
-              <a:t>Abedalah Safi, Abrar Zaki, Aleks Bekker, Ayaan Ahmad, Joshua Javillo</a:t>
-            </a:r>
-            <a:endParaRPr i="1">
-              <a:solidFill>
-                <a:schemeClr val="lt1"/>
-              </a:solidFill>
-              <a:latin typeface="Helvetica Neue"/>
-              <a:ea typeface="Helvetica Neue"/>
-              <a:cs typeface="Helvetica Neue"/>
-              <a:sym typeface="Helvetica Neue"/>
-            </a:endParaRPr>
-          </a:p>
-        </p:txBody>
-      </p:sp>
-      <p:sp>
-        <p:nvSpPr>
-          <p:cNvPr id="55" name="Google Shape;55;p1"/>
-          <p:cNvSpPr txBox="1"/>
-          <p:nvPr>
-            <p:ph idx="20" type="body"/>
-          </p:nvPr>
-        </p:nvSpPr>
-        <p:spPr>
-          <a:xfrm>
-            <a:off x="5932593" y="1151613"/>
-            <a:ext cx="31998900" cy="1638000"/>
-          </a:xfrm>
-          <a:prstGeom prst="rect">
-            <a:avLst/>
-          </a:prstGeom>
-          <a:noFill/>
-          <a:ln>
-            <a:noFill/>
-          </a:ln>
-        </p:spPr>
-        <p:txBody>
-          <a:bodyPr anchorCtr="1" anchor="t" bIns="45700" lIns="91425" spcFirstLastPara="1" rIns="91425" wrap="square" tIns="45700">
-            <a:normAutofit lnSpcReduction="20000"/>
-          </a:bodyPr>
-          <a:lstStyle/>
-          <a:p>
-            <a:pPr indent="0" lvl="0" marL="0" rtl="0" algn="ctr">
-              <a:spcBef>
-                <a:spcPts val="0"/>
-              </a:spcBef>
-              <a:spcAft>
-                <a:spcPts val="0"/>
-              </a:spcAft>
-              <a:buClr>
-                <a:srgbClr val="1F3864"/>
-              </a:buClr>
-              <a:buSzPts val="11500"/>
-              <a:buFont typeface="Calibri"/>
-              <a:buNone/>
-            </a:pPr>
-            <a:r>
-              <a:rPr lang="en-US">
-                <a:solidFill>
-                  <a:schemeClr val="lt1"/>
-                </a:solidFill>
-                <a:latin typeface="Helvetica Neue"/>
-                <a:ea typeface="Helvetica Neue"/>
-                <a:cs typeface="Helvetica Neue"/>
-                <a:sym typeface="Helvetica Neue"/>
-              </a:rPr>
-              <a:t>SIFT: Submitty Instant Feedback and Testing</a:t>
-            </a:r>
-            <a:endParaRPr>
-              <a:solidFill>
-                <a:schemeClr val="lt1"/>
-              </a:solidFill>
-              <a:latin typeface="Helvetica Neue"/>
-              <a:ea typeface="Helvetica Neue"/>
-              <a:cs typeface="Helvetica Neue"/>
-              <a:sym typeface="Helvetica Neue"/>
-            </a:endParaRPr>
-          </a:p>
-        </p:txBody>
-      </p:sp>
-      <p:sp>
-        <p:nvSpPr>
-          <p:cNvPr id="56" name="Google Shape;56;p1"/>
           <p:cNvSpPr txBox="1"/>
           <p:nvPr>
             <p:ph idx="6" type="body"/>
@@ -11699,19 +11246,7 @@
                 <a:cs typeface="Helvetica Neue"/>
                 <a:sym typeface="Helvetica Neue"/>
               </a:rPr>
-              <a:t>Joshua Javillo,</a:t>
-            </a:r>
-            <a:r>
-              <a:rPr i="1" lang="en-US" sz="3800">
-                <a:solidFill>
-                  <a:schemeClr val="lt1"/>
-                </a:solidFill>
-                <a:latin typeface="Helvetica Neue"/>
-                <a:ea typeface="Helvetica Neue"/>
-                <a:cs typeface="Helvetica Neue"/>
-                <a:sym typeface="Helvetica Neue"/>
-              </a:rPr>
-              <a:t> </a:t>
+              <a:t>Joshua Javillo, </a:t>
             </a:r>
             <a:r>
               <a:rPr lang="en-US" sz="3800">
@@ -11837,50 +11372,26 @@
               </a:rPr>
               <a:t> worked on documentation, writing code, and developing the API</a:t>
             </a:r>
-            <a:endParaRPr/>
+            <a:endParaRPr>
+              <a:solidFill>
+                <a:schemeClr val="lt1"/>
+              </a:solidFill>
+            </a:endParaRPr>
           </a:p>
         </p:txBody>
       </p:sp>
-      <p:pic>
-        <p:nvPicPr>
-          <p:cNvPr id="57" name="Google Shape;57;p1"/>
-          <p:cNvPicPr preferRelativeResize="0"/>
-          <p:nvPr/>
-        </p:nvPicPr>
-        <p:blipFill>
-          <a:blip r:embed="rId5">
-            <a:alphaModFix/>
-          </a:blip>
-          <a:stretch>
-            <a:fillRect/>
-          </a:stretch>
-        </p:blipFill>
-        <p:spPr>
-          <a:xfrm>
-            <a:off x="12366276" y="26984800"/>
-            <a:ext cx="6487550" cy="3668193"/>
-          </a:xfrm>
-          <a:prstGeom prst="rect">
-            <a:avLst/>
-          </a:prstGeom>
-          <a:noFill/>
-          <a:ln>
-            <a:noFill/>
-          </a:ln>
-        </p:spPr>
-      </p:pic>
       <p:sp>
         <p:nvSpPr>
-          <p:cNvPr id="58" name="Google Shape;58;p1"/>
+          <p:cNvPr id="50" name="Google Shape;50;p1"/>
           <p:cNvSpPr txBox="1"/>
           <p:nvPr>
-            <p:ph idx="3" type="body"/>
+            <p:ph idx="7" type="body"/>
           </p:nvPr>
         </p:nvSpPr>
         <p:spPr>
           <a:xfrm>
-            <a:off x="472638" y="19410538"/>
-            <a:ext cx="10050600" cy="877200"/>
+            <a:off x="23563850" y="5548750"/>
+            <a:ext cx="7410900" cy="908100"/>
           </a:xfrm>
           <a:prstGeom prst="rect">
             <a:avLst/>
@@ -11910,7 +11421,7 @@
               <a:buNone/>
             </a:pPr>
             <a:r>
-              <a:rPr lang="en-US" sz="4500">
+              <a:rPr lang="en-US" sz="4700">
                 <a:solidFill>
                   <a:schemeClr val="lt1"/>
                 </a:solidFill>
@@ -11919,9 +11430,9 @@
                 <a:cs typeface="Helvetica Neue"/>
                 <a:sym typeface="Helvetica Neue"/>
               </a:rPr>
-              <a:t>Changes from last semester</a:t>
+              <a:t>Materials and Methods</a:t>
             </a:r>
-            <a:endParaRPr sz="4500">
+            <a:endParaRPr sz="4700">
               <a:solidFill>
                 <a:schemeClr val="lt1"/>
               </a:solidFill>
@@ -11935,14 +11446,16 @@
       </p:sp>
       <p:sp>
         <p:nvSpPr>
-          <p:cNvPr id="59" name="Google Shape;59;p1"/>
+          <p:cNvPr id="51" name="Google Shape;51;p1"/>
           <p:cNvSpPr txBox="1"/>
-          <p:nvPr/>
+          <p:nvPr>
+            <p:ph idx="8" type="body"/>
+          </p:nvPr>
         </p:nvSpPr>
         <p:spPr>
           <a:xfrm>
-            <a:off x="428325" y="20490175"/>
-            <a:ext cx="10464600" cy="12525000"/>
+            <a:off x="33492342" y="5548749"/>
+            <a:ext cx="10047000" cy="908100"/>
           </a:xfrm>
           <a:prstGeom prst="rect">
             <a:avLst/>
@@ -11953,30 +11466,26 @@
           </a:ln>
         </p:spPr>
         <p:txBody>
-          <a:bodyPr anchorCtr="0" anchor="t" bIns="91425" lIns="91425" spcFirstLastPara="1" rIns="91425" wrap="square" tIns="91425">
-            <a:noAutofit/>
+          <a:bodyPr anchorCtr="0" anchor="ctr" bIns="91425" lIns="91425" spcFirstLastPara="1" rIns="91425" wrap="square" tIns="91425">
+            <a:spAutoFit/>
           </a:bodyPr>
           <a:lstStyle/>
           <a:p>
-            <a:pPr indent="-469900" lvl="0" marL="914400" rtl="0" algn="l">
-              <a:lnSpc>
-                <a:spcPct val="115000"/>
-              </a:lnSpc>
-              <a:spcBef>
-                <a:spcPts val="0"/>
-              </a:spcBef>
-              <a:spcAft>
-                <a:spcPts val="0"/>
-              </a:spcAft>
-              <a:buClr>
-                <a:schemeClr val="lt1"/>
-              </a:buClr>
-              <a:buSzPts val="3800"/>
-              <a:buFont typeface="Helvetica Neue"/>
-              <a:buChar char="●"/>
+            <a:pPr indent="0" lvl="0" marL="0" rtl="0" algn="ctr">
+              <a:spcBef>
+                <a:spcPts val="0"/>
+              </a:spcBef>
+              <a:spcAft>
+                <a:spcPts val="0"/>
+              </a:spcAft>
+              <a:buClr>
+                <a:srgbClr val="1F3864"/>
+              </a:buClr>
+              <a:buSzPts val="3700"/>
+              <a:buNone/>
             </a:pPr>
             <a:r>
-              <a:rPr lang="en-US" sz="3800">
+              <a:rPr lang="en-US" sz="4700">
                 <a:solidFill>
                   <a:schemeClr val="lt1"/>
                 </a:solidFill>
@@ -11985,249 +11494,9 @@
                 <a:cs typeface="Helvetica Neue"/>
                 <a:sym typeface="Helvetica Neue"/>
               </a:rPr>
-              <a:t>Moving away from Python</a:t>
+              <a:t>Frontend/UI</a:t>
             </a:r>
-            <a:endParaRPr sz="3800">
-              <a:solidFill>
-                <a:schemeClr val="lt1"/>
-              </a:solidFill>
-              <a:latin typeface="Helvetica Neue"/>
-              <a:ea typeface="Helvetica Neue"/>
-              <a:cs typeface="Helvetica Neue"/>
-              <a:sym typeface="Helvetica Neue"/>
-            </a:endParaRPr>
-          </a:p>
-          <a:p>
-            <a:pPr indent="-469900" lvl="1" marL="1371600" rtl="0" algn="l">
-              <a:lnSpc>
-                <a:spcPct val="115000"/>
-              </a:lnSpc>
-              <a:spcBef>
-                <a:spcPts val="0"/>
-              </a:spcBef>
-              <a:spcAft>
-                <a:spcPts val="0"/>
-              </a:spcAft>
-              <a:buClr>
-                <a:schemeClr val="lt1"/>
-              </a:buClr>
-              <a:buSzPts val="3800"/>
-              <a:buFont typeface="Helvetica Neue"/>
-              <a:buChar char="○"/>
-            </a:pPr>
-            <a:r>
-              <a:rPr lang="en-US" sz="3800">
-                <a:solidFill>
-                  <a:schemeClr val="lt1"/>
-                </a:solidFill>
-                <a:latin typeface="Helvetica Neue"/>
-                <a:ea typeface="Helvetica Neue"/>
-                <a:cs typeface="Helvetica Neue"/>
-                <a:sym typeface="Helvetica Neue"/>
-              </a:rPr>
-              <a:t>Javascript was more customizable and robust for front-end</a:t>
-            </a:r>
-            <a:endParaRPr sz="3800">
-              <a:solidFill>
-                <a:schemeClr val="lt1"/>
-              </a:solidFill>
-              <a:latin typeface="Helvetica Neue"/>
-              <a:ea typeface="Helvetica Neue"/>
-              <a:cs typeface="Helvetica Neue"/>
-              <a:sym typeface="Helvetica Neue"/>
-            </a:endParaRPr>
-          </a:p>
-          <a:p>
-            <a:pPr indent="-469900" lvl="1" marL="1371600" rtl="0" algn="l">
-              <a:lnSpc>
-                <a:spcPct val="115000"/>
-              </a:lnSpc>
-              <a:spcBef>
-                <a:spcPts val="0"/>
-              </a:spcBef>
-              <a:spcAft>
-                <a:spcPts val="0"/>
-              </a:spcAft>
-              <a:buClr>
-                <a:schemeClr val="lt1"/>
-              </a:buClr>
-              <a:buSzPts val="3800"/>
-              <a:buFont typeface="Helvetica Neue"/>
-              <a:buChar char="○"/>
-            </a:pPr>
-            <a:r>
-              <a:rPr lang="en-US" sz="3800">
-                <a:solidFill>
-                  <a:schemeClr val="lt1"/>
-                </a:solidFill>
-                <a:latin typeface="Helvetica Neue"/>
-                <a:ea typeface="Helvetica Neue"/>
-                <a:cs typeface="Helvetica Neue"/>
-                <a:sym typeface="Helvetica Neue"/>
-              </a:rPr>
-              <a:t>Golang is more performant for back-end tasks</a:t>
-            </a:r>
-            <a:endParaRPr sz="3800">
-              <a:solidFill>
-                <a:schemeClr val="lt1"/>
-              </a:solidFill>
-              <a:latin typeface="Helvetica Neue"/>
-              <a:ea typeface="Helvetica Neue"/>
-              <a:cs typeface="Helvetica Neue"/>
-              <a:sym typeface="Helvetica Neue"/>
-            </a:endParaRPr>
-          </a:p>
-          <a:p>
-            <a:pPr indent="-469900" lvl="0" marL="914400" rtl="0" algn="l">
-              <a:lnSpc>
-                <a:spcPct val="115000"/>
-              </a:lnSpc>
-              <a:spcBef>
-                <a:spcPts val="0"/>
-              </a:spcBef>
-              <a:spcAft>
-                <a:spcPts val="0"/>
-              </a:spcAft>
-              <a:buClr>
-                <a:schemeClr val="lt1"/>
-              </a:buClr>
-              <a:buSzPts val="3800"/>
-              <a:buFont typeface="Helvetica Neue"/>
-              <a:buChar char="●"/>
-            </a:pPr>
-            <a:r>
-              <a:rPr lang="en-US" sz="3800">
-                <a:solidFill>
-                  <a:schemeClr val="lt1"/>
-                </a:solidFill>
-                <a:latin typeface="Helvetica Neue"/>
-                <a:ea typeface="Helvetica Neue"/>
-                <a:cs typeface="Helvetica Neue"/>
-                <a:sym typeface="Helvetica Neue"/>
-              </a:rPr>
-              <a:t>Decided to </a:t>
-            </a:r>
-            <a:endParaRPr sz="3800">
-              <a:solidFill>
-                <a:schemeClr val="lt1"/>
-              </a:solidFill>
-              <a:latin typeface="Helvetica Neue"/>
-              <a:ea typeface="Helvetica Neue"/>
-              <a:cs typeface="Helvetica Neue"/>
-              <a:sym typeface="Helvetica Neue"/>
-            </a:endParaRPr>
-          </a:p>
-          <a:p>
-            <a:pPr indent="-469900" lvl="0" marL="914400" rtl="0" algn="l">
-              <a:lnSpc>
-                <a:spcPct val="115000"/>
-              </a:lnSpc>
-              <a:spcBef>
-                <a:spcPts val="0"/>
-              </a:spcBef>
-              <a:spcAft>
-                <a:spcPts val="0"/>
-              </a:spcAft>
-              <a:buClr>
-                <a:schemeClr val="lt1"/>
-              </a:buClr>
-              <a:buSzPts val="3800"/>
-              <a:buFont typeface="Helvetica Neue"/>
-              <a:buChar char="●"/>
-            </a:pPr>
-            <a:r>
-              <a:rPr lang="en-US" sz="3800">
-                <a:solidFill>
-                  <a:schemeClr val="lt1"/>
-                </a:solidFill>
-                <a:latin typeface="Helvetica Neue"/>
-                <a:ea typeface="Helvetica Neue"/>
-                <a:cs typeface="Helvetica Neue"/>
-                <a:sym typeface="Helvetica Neue"/>
-              </a:rPr>
-              <a:t>New logo</a:t>
-            </a:r>
-            <a:endParaRPr sz="3800">
-              <a:solidFill>
-                <a:schemeClr val="lt1"/>
-              </a:solidFill>
-              <a:latin typeface="Helvetica Neue"/>
-              <a:ea typeface="Helvetica Neue"/>
-              <a:cs typeface="Helvetica Neue"/>
-              <a:sym typeface="Helvetica Neue"/>
-            </a:endParaRPr>
-          </a:p>
-          <a:p>
-            <a:pPr indent="-469900" lvl="1" marL="1371600" rtl="0" algn="l">
-              <a:lnSpc>
-                <a:spcPct val="115000"/>
-              </a:lnSpc>
-              <a:spcBef>
-                <a:spcPts val="0"/>
-              </a:spcBef>
-              <a:spcAft>
-                <a:spcPts val="0"/>
-              </a:spcAft>
-              <a:buClr>
-                <a:schemeClr val="lt1"/>
-              </a:buClr>
-              <a:buSzPts val="3800"/>
-              <a:buFont typeface="Helvetica Neue"/>
-              <a:buChar char="○"/>
-            </a:pPr>
-            <a:r>
-              <a:rPr lang="en-US" sz="3800">
-                <a:solidFill>
-                  <a:schemeClr val="lt1"/>
-                </a:solidFill>
-                <a:latin typeface="Helvetica Neue"/>
-                <a:ea typeface="Helvetica Neue"/>
-                <a:cs typeface="Helvetica Neue"/>
-                <a:sym typeface="Helvetica Neue"/>
-              </a:rPr>
-              <a:t>A modified version of the Submitty logo with the duck made up of green binary</a:t>
-            </a:r>
-            <a:endParaRPr sz="3800">
-              <a:solidFill>
-                <a:schemeClr val="lt1"/>
-              </a:solidFill>
-              <a:latin typeface="Helvetica Neue"/>
-              <a:ea typeface="Helvetica Neue"/>
-              <a:cs typeface="Helvetica Neue"/>
-              <a:sym typeface="Helvetica Neue"/>
-            </a:endParaRPr>
-          </a:p>
-          <a:p>
-            <a:pPr indent="0" lvl="0" marL="914400" rtl="0" algn="l">
-              <a:lnSpc>
-                <a:spcPct val="115000"/>
-              </a:lnSpc>
-              <a:spcBef>
-                <a:spcPts val="0"/>
-              </a:spcBef>
-              <a:spcAft>
-                <a:spcPts val="0"/>
-              </a:spcAft>
-              <a:buClr>
-                <a:schemeClr val="dk1"/>
-              </a:buClr>
-              <a:buSzPts val="1100"/>
-              <a:buFont typeface="Arial"/>
-              <a:buNone/>
-            </a:pPr>
-            <a:r>
-              <a:rPr lang="en-US" sz="3800">
-                <a:solidFill>
-                  <a:schemeClr val="lt1"/>
-                </a:solidFill>
-                <a:latin typeface="Helvetica Neue"/>
-                <a:ea typeface="Helvetica Neue"/>
-                <a:cs typeface="Helvetica Neue"/>
-                <a:sym typeface="Helvetica Neue"/>
-              </a:rPr>
-              <a:t> </a:t>
-            </a:r>
-            <a:endParaRPr sz="3800">
+            <a:endParaRPr sz="4700">
               <a:solidFill>
                 <a:schemeClr val="lt1"/>
               </a:solidFill>
@@ -12239,6 +11508,600 @@
           </a:p>
         </p:txBody>
       </p:sp>
+      <p:sp>
+        <p:nvSpPr>
+          <p:cNvPr id="52" name="Google Shape;52;p1"/>
+          <p:cNvSpPr txBox="1"/>
+          <p:nvPr>
+            <p:ph idx="13" type="body"/>
+          </p:nvPr>
+        </p:nvSpPr>
+        <p:spPr>
+          <a:xfrm>
+            <a:off x="33387742" y="20003713"/>
+            <a:ext cx="10047000" cy="908100"/>
+          </a:xfrm>
+          <a:prstGeom prst="rect">
+            <a:avLst/>
+          </a:prstGeom>
+          <a:noFill/>
+          <a:ln>
+            <a:noFill/>
+          </a:ln>
+        </p:spPr>
+        <p:txBody>
+          <a:bodyPr anchorCtr="0" anchor="ctr" bIns="91425" lIns="91425" spcFirstLastPara="1" rIns="91425" wrap="square" tIns="91425">
+            <a:spAutoFit/>
+          </a:bodyPr>
+          <a:lstStyle/>
+          <a:p>
+            <a:pPr indent="0" lvl="0" marL="0" rtl="0" algn="ctr">
+              <a:spcBef>
+                <a:spcPts val="0"/>
+              </a:spcBef>
+              <a:spcAft>
+                <a:spcPts val="0"/>
+              </a:spcAft>
+              <a:buClr>
+                <a:srgbClr val="1F3864"/>
+              </a:buClr>
+              <a:buSzPts val="3700"/>
+              <a:buNone/>
+            </a:pPr>
+            <a:r>
+              <a:rPr lang="en-US" sz="4700">
+                <a:solidFill>
+                  <a:schemeClr val="lt1"/>
+                </a:solidFill>
+                <a:latin typeface="Helvetica Neue"/>
+                <a:ea typeface="Helvetica Neue"/>
+                <a:cs typeface="Helvetica Neue"/>
+                <a:sym typeface="Helvetica Neue"/>
+              </a:rPr>
+              <a:t>Future Goals</a:t>
+            </a:r>
+            <a:endParaRPr sz="4700">
+              <a:solidFill>
+                <a:schemeClr val="lt1"/>
+              </a:solidFill>
+              <a:latin typeface="Helvetica Neue"/>
+              <a:ea typeface="Helvetica Neue"/>
+              <a:cs typeface="Helvetica Neue"/>
+              <a:sym typeface="Helvetica Neue"/>
+            </a:endParaRPr>
+          </a:p>
+        </p:txBody>
+      </p:sp>
+      <p:sp>
+        <p:nvSpPr>
+          <p:cNvPr id="53" name="Google Shape;53;p1"/>
+          <p:cNvSpPr txBox="1"/>
+          <p:nvPr>
+            <p:ph idx="14" type="body"/>
+          </p:nvPr>
+        </p:nvSpPr>
+        <p:spPr>
+          <a:xfrm>
+            <a:off x="33387750" y="20818575"/>
+            <a:ext cx="10052100" cy="7065000"/>
+          </a:xfrm>
+          <a:prstGeom prst="rect">
+            <a:avLst/>
+          </a:prstGeom>
+          <a:noFill/>
+          <a:ln>
+            <a:noFill/>
+          </a:ln>
+        </p:spPr>
+        <p:txBody>
+          <a:bodyPr anchorCtr="0" anchor="t" bIns="228575" lIns="228575" spcFirstLastPara="1" rIns="228575" wrap="square" tIns="228575">
+            <a:spAutoFit/>
+          </a:bodyPr>
+          <a:lstStyle/>
+          <a:p>
+            <a:pPr indent="0" lvl="0" marL="0" rtl="0" algn="l">
+              <a:spcBef>
+                <a:spcPts val="0"/>
+              </a:spcBef>
+              <a:spcAft>
+                <a:spcPts val="0"/>
+              </a:spcAft>
+              <a:buClr>
+                <a:schemeClr val="dk1"/>
+              </a:buClr>
+              <a:buSzPts val="1100"/>
+              <a:buFont typeface="Arial"/>
+              <a:buNone/>
+            </a:pPr>
+            <a:r>
+              <a:rPr lang="en-US" sz="3900">
+                <a:solidFill>
+                  <a:schemeClr val="lt1"/>
+                </a:solidFill>
+                <a:latin typeface="Helvetica Neue"/>
+                <a:ea typeface="Helvetica Neue"/>
+                <a:cs typeface="Helvetica Neue"/>
+                <a:sym typeface="Helvetica Neue"/>
+              </a:rPr>
+              <a:t>Some of the ideas and goals we have for the future include:</a:t>
+            </a:r>
+            <a:endParaRPr sz="3900">
+              <a:solidFill>
+                <a:schemeClr val="lt1"/>
+              </a:solidFill>
+              <a:latin typeface="Helvetica Neue"/>
+              <a:ea typeface="Helvetica Neue"/>
+              <a:cs typeface="Helvetica Neue"/>
+              <a:sym typeface="Helvetica Neue"/>
+            </a:endParaRPr>
+          </a:p>
+          <a:p>
+            <a:pPr indent="-476250" lvl="0" marL="457200" rtl="0" algn="l">
+              <a:spcBef>
+                <a:spcPts val="0"/>
+              </a:spcBef>
+              <a:spcAft>
+                <a:spcPts val="0"/>
+              </a:spcAft>
+              <a:buClr>
+                <a:schemeClr val="lt1"/>
+              </a:buClr>
+              <a:buSzPts val="3900"/>
+              <a:buFont typeface="Helvetica Neue"/>
+              <a:buChar char="●"/>
+            </a:pPr>
+            <a:r>
+              <a:rPr lang="en-US" sz="3900">
+                <a:solidFill>
+                  <a:schemeClr val="lt1"/>
+                </a:solidFill>
+                <a:latin typeface="Helvetica Neue"/>
+                <a:ea typeface="Helvetica Neue"/>
+                <a:cs typeface="Helvetica Neue"/>
+                <a:sym typeface="Helvetica Neue"/>
+              </a:rPr>
+              <a:t>Allowing users to select individual courses and have all the necessary resources already available for them without extra downloads</a:t>
+            </a:r>
+            <a:endParaRPr sz="3900">
+              <a:solidFill>
+                <a:schemeClr val="lt1"/>
+              </a:solidFill>
+              <a:latin typeface="Helvetica Neue"/>
+              <a:ea typeface="Helvetica Neue"/>
+              <a:cs typeface="Helvetica Neue"/>
+              <a:sym typeface="Helvetica Neue"/>
+            </a:endParaRPr>
+          </a:p>
+          <a:p>
+            <a:pPr indent="-476250" lvl="0" marL="457200" rtl="0" algn="l">
+              <a:spcBef>
+                <a:spcPts val="0"/>
+              </a:spcBef>
+              <a:spcAft>
+                <a:spcPts val="0"/>
+              </a:spcAft>
+              <a:buClr>
+                <a:schemeClr val="lt1"/>
+              </a:buClr>
+              <a:buSzPts val="3900"/>
+              <a:buFont typeface="Helvetica Neue"/>
+              <a:buChar char="●"/>
+            </a:pPr>
+            <a:r>
+              <a:rPr lang="en-US" sz="3900">
+                <a:solidFill>
+                  <a:schemeClr val="lt1"/>
+                </a:solidFill>
+                <a:latin typeface="Helvetica Neue"/>
+                <a:ea typeface="Helvetica Neue"/>
+                <a:cs typeface="Helvetica Neue"/>
+                <a:sym typeface="Helvetica Neue"/>
+              </a:rPr>
+              <a:t>Allowing professors to upload materials and manage their courses on the app to allow the features mentioned above</a:t>
+            </a:r>
+            <a:endParaRPr sz="3900">
+              <a:solidFill>
+                <a:schemeClr val="lt1"/>
+              </a:solidFill>
+              <a:latin typeface="Helvetica Neue"/>
+              <a:ea typeface="Helvetica Neue"/>
+              <a:cs typeface="Helvetica Neue"/>
+              <a:sym typeface="Helvetica Neue"/>
+            </a:endParaRPr>
+          </a:p>
+          <a:p>
+            <a:pPr indent="-476250" lvl="0" marL="457200" rtl="0" algn="l">
+              <a:spcBef>
+                <a:spcPts val="0"/>
+              </a:spcBef>
+              <a:spcAft>
+                <a:spcPts val="0"/>
+              </a:spcAft>
+              <a:buClr>
+                <a:schemeClr val="lt1"/>
+              </a:buClr>
+              <a:buSzPts val="3900"/>
+              <a:buFont typeface="Helvetica Neue"/>
+              <a:buChar char="●"/>
+            </a:pPr>
+            <a:r>
+              <a:rPr lang="en-US" sz="3900">
+                <a:solidFill>
+                  <a:schemeClr val="lt1"/>
+                </a:solidFill>
+                <a:latin typeface="Helvetica Neue"/>
+                <a:ea typeface="Helvetica Neue"/>
+                <a:cs typeface="Helvetica Neue"/>
+                <a:sym typeface="Helvetica Neue"/>
+              </a:rPr>
+              <a:t>Make the app distributable (through platforms such as Docker)</a:t>
+            </a:r>
+            <a:endParaRPr sz="3900">
+              <a:solidFill>
+                <a:schemeClr val="lt1"/>
+              </a:solidFill>
+              <a:latin typeface="Helvetica Neue"/>
+              <a:ea typeface="Helvetica Neue"/>
+              <a:cs typeface="Helvetica Neue"/>
+              <a:sym typeface="Helvetica Neue"/>
+            </a:endParaRPr>
+          </a:p>
+        </p:txBody>
+      </p:sp>
+      <p:sp>
+        <p:nvSpPr>
+          <p:cNvPr id="54" name="Google Shape;54;p1"/>
+          <p:cNvSpPr txBox="1"/>
+          <p:nvPr>
+            <p:ph idx="15" type="body"/>
+          </p:nvPr>
+        </p:nvSpPr>
+        <p:spPr>
+          <a:xfrm>
+            <a:off x="33390292" y="29260801"/>
+            <a:ext cx="10047000" cy="908100"/>
+          </a:xfrm>
+          <a:prstGeom prst="rect">
+            <a:avLst/>
+          </a:prstGeom>
+          <a:noFill/>
+          <a:ln>
+            <a:noFill/>
+          </a:ln>
+        </p:spPr>
+        <p:txBody>
+          <a:bodyPr anchorCtr="0" anchor="ctr" bIns="91425" lIns="91425" spcFirstLastPara="1" rIns="91425" wrap="square" tIns="91425">
+            <a:spAutoFit/>
+          </a:bodyPr>
+          <a:lstStyle/>
+          <a:p>
+            <a:pPr indent="0" lvl="0" marL="0" rtl="0" algn="ctr">
+              <a:spcBef>
+                <a:spcPts val="0"/>
+              </a:spcBef>
+              <a:spcAft>
+                <a:spcPts val="0"/>
+              </a:spcAft>
+              <a:buClr>
+                <a:srgbClr val="1F3864"/>
+              </a:buClr>
+              <a:buSzPts val="3700"/>
+              <a:buNone/>
+            </a:pPr>
+            <a:r>
+              <a:rPr lang="en-US" sz="4700">
+                <a:solidFill>
+                  <a:schemeClr val="lt1"/>
+                </a:solidFill>
+                <a:latin typeface="Helvetica Neue"/>
+                <a:ea typeface="Helvetica Neue"/>
+                <a:cs typeface="Helvetica Neue"/>
+                <a:sym typeface="Helvetica Neue"/>
+              </a:rPr>
+              <a:t>Acknowledgements</a:t>
+            </a:r>
+            <a:endParaRPr sz="4700">
+              <a:solidFill>
+                <a:schemeClr val="lt1"/>
+              </a:solidFill>
+              <a:latin typeface="Helvetica Neue"/>
+              <a:ea typeface="Helvetica Neue"/>
+              <a:cs typeface="Helvetica Neue"/>
+              <a:sym typeface="Helvetica Neue"/>
+            </a:endParaRPr>
+          </a:p>
+        </p:txBody>
+      </p:sp>
+      <p:sp>
+        <p:nvSpPr>
+          <p:cNvPr id="55" name="Google Shape;55;p1"/>
+          <p:cNvSpPr txBox="1"/>
+          <p:nvPr>
+            <p:ph idx="16" type="body"/>
+          </p:nvPr>
+        </p:nvSpPr>
+        <p:spPr>
+          <a:xfrm>
+            <a:off x="33466500" y="30014851"/>
+            <a:ext cx="10052100" cy="923400"/>
+          </a:xfrm>
+          <a:prstGeom prst="rect">
+            <a:avLst/>
+          </a:prstGeom>
+          <a:noFill/>
+          <a:ln>
+            <a:noFill/>
+          </a:ln>
+        </p:spPr>
+        <p:txBody>
+          <a:bodyPr anchorCtr="0" anchor="t" bIns="228575" lIns="228575" spcFirstLastPara="1" rIns="228575" wrap="square" tIns="228575">
+            <a:spAutoFit/>
+          </a:bodyPr>
+          <a:lstStyle/>
+          <a:p>
+            <a:pPr indent="-419100" lvl="0" marL="457200" rtl="0" algn="l">
+              <a:lnSpc>
+                <a:spcPct val="115000"/>
+              </a:lnSpc>
+              <a:spcBef>
+                <a:spcPts val="0"/>
+              </a:spcBef>
+              <a:spcAft>
+                <a:spcPts val="0"/>
+              </a:spcAft>
+              <a:buClr>
+                <a:schemeClr val="lt1"/>
+              </a:buClr>
+              <a:buSzPts val="3000"/>
+              <a:buFont typeface="Helvetica Neue"/>
+              <a:buChar char="●"/>
+            </a:pPr>
+            <a:r>
+              <a:rPr lang="en-US" sz="3000">
+                <a:solidFill>
+                  <a:schemeClr val="lt1"/>
+                </a:solidFill>
+                <a:latin typeface="Helvetica Neue"/>
+                <a:ea typeface="Helvetica Neue"/>
+                <a:cs typeface="Helvetica Neue"/>
+                <a:sym typeface="Helvetica Neue"/>
+              </a:rPr>
+              <a:t>RCOS professors, coordinators, and mentors</a:t>
+            </a:r>
+            <a:endParaRPr sz="3000">
+              <a:solidFill>
+                <a:schemeClr val="lt1"/>
+              </a:solidFill>
+              <a:latin typeface="Helvetica Neue"/>
+              <a:ea typeface="Helvetica Neue"/>
+              <a:cs typeface="Helvetica Neue"/>
+              <a:sym typeface="Helvetica Neue"/>
+            </a:endParaRPr>
+          </a:p>
+        </p:txBody>
+      </p:sp>
+      <p:sp>
+        <p:nvSpPr>
+          <p:cNvPr id="56" name="Google Shape;56;p1"/>
+          <p:cNvSpPr txBox="1"/>
+          <p:nvPr>
+            <p:ph idx="19" type="body"/>
+          </p:nvPr>
+        </p:nvSpPr>
+        <p:spPr>
+          <a:xfrm>
+            <a:off x="5932593" y="2789587"/>
+            <a:ext cx="31998900" cy="1280100"/>
+          </a:xfrm>
+          <a:prstGeom prst="rect">
+            <a:avLst/>
+          </a:prstGeom>
+          <a:noFill/>
+          <a:ln>
+            <a:noFill/>
+          </a:ln>
+        </p:spPr>
+        <p:txBody>
+          <a:bodyPr anchorCtr="1" anchor="t" bIns="45700" lIns="91425" spcFirstLastPara="1" rIns="91425" wrap="square" tIns="45700">
+            <a:normAutofit fontScale="70000"/>
+          </a:bodyPr>
+          <a:lstStyle/>
+          <a:p>
+            <a:pPr indent="0" lvl="0" marL="0" rtl="0" algn="ctr">
+              <a:spcBef>
+                <a:spcPts val="0"/>
+              </a:spcBef>
+              <a:spcAft>
+                <a:spcPts val="0"/>
+              </a:spcAft>
+              <a:buClr>
+                <a:srgbClr val="1F3864"/>
+              </a:buClr>
+              <a:buSzPct val="100000"/>
+              <a:buFont typeface="Calibri"/>
+              <a:buNone/>
+            </a:pPr>
+            <a:r>
+              <a:rPr i="1" lang="en-US">
+                <a:solidFill>
+                  <a:schemeClr val="lt1"/>
+                </a:solidFill>
+                <a:latin typeface="Helvetica Neue"/>
+                <a:ea typeface="Helvetica Neue"/>
+                <a:cs typeface="Helvetica Neue"/>
+                <a:sym typeface="Helvetica Neue"/>
+              </a:rPr>
+              <a:t>Abedalah Safi, Abrar Zaki, Aleks Bekker, Ayaan Ahmad, Joshua Javillo, Steven Huynh</a:t>
+            </a:r>
+            <a:endParaRPr i="1">
+              <a:solidFill>
+                <a:schemeClr val="lt1"/>
+              </a:solidFill>
+              <a:latin typeface="Helvetica Neue"/>
+              <a:ea typeface="Helvetica Neue"/>
+              <a:cs typeface="Helvetica Neue"/>
+              <a:sym typeface="Helvetica Neue"/>
+            </a:endParaRPr>
+          </a:p>
+        </p:txBody>
+      </p:sp>
+      <p:sp>
+        <p:nvSpPr>
+          <p:cNvPr id="57" name="Google Shape;57;p1"/>
+          <p:cNvSpPr txBox="1"/>
+          <p:nvPr>
+            <p:ph idx="20" type="body"/>
+          </p:nvPr>
+        </p:nvSpPr>
+        <p:spPr>
+          <a:xfrm>
+            <a:off x="5932593" y="1151613"/>
+            <a:ext cx="31998900" cy="1638000"/>
+          </a:xfrm>
+          <a:prstGeom prst="rect">
+            <a:avLst/>
+          </a:prstGeom>
+          <a:noFill/>
+          <a:ln>
+            <a:noFill/>
+          </a:ln>
+        </p:spPr>
+        <p:txBody>
+          <a:bodyPr anchorCtr="1" anchor="t" bIns="45700" lIns="91425" spcFirstLastPara="1" rIns="91425" wrap="square" tIns="45700">
+            <a:normAutofit lnSpcReduction="20000"/>
+          </a:bodyPr>
+          <a:lstStyle/>
+          <a:p>
+            <a:pPr indent="0" lvl="0" marL="0" rtl="0" algn="ctr">
+              <a:spcBef>
+                <a:spcPts val="0"/>
+              </a:spcBef>
+              <a:spcAft>
+                <a:spcPts val="0"/>
+              </a:spcAft>
+              <a:buClr>
+                <a:srgbClr val="1F3864"/>
+              </a:buClr>
+              <a:buSzPts val="11500"/>
+              <a:buFont typeface="Calibri"/>
+              <a:buNone/>
+            </a:pPr>
+            <a:r>
+              <a:rPr lang="en-US">
+                <a:solidFill>
+                  <a:schemeClr val="lt1"/>
+                </a:solidFill>
+                <a:latin typeface="Helvetica Neue"/>
+                <a:ea typeface="Helvetica Neue"/>
+                <a:cs typeface="Helvetica Neue"/>
+                <a:sym typeface="Helvetica Neue"/>
+              </a:rPr>
+              <a:t>SIFT: Submitty Instant Feedback and Testing</a:t>
+            </a:r>
+            <a:endParaRPr>
+              <a:solidFill>
+                <a:schemeClr val="lt1"/>
+              </a:solidFill>
+              <a:latin typeface="Helvetica Neue"/>
+              <a:ea typeface="Helvetica Neue"/>
+              <a:cs typeface="Helvetica Neue"/>
+              <a:sym typeface="Helvetica Neue"/>
+            </a:endParaRPr>
+          </a:p>
+        </p:txBody>
+      </p:sp>
+      <p:sp>
+        <p:nvSpPr>
+          <p:cNvPr id="58" name="Google Shape;58;p1"/>
+          <p:cNvSpPr txBox="1"/>
+          <p:nvPr>
+            <p:ph idx="3" type="body"/>
+          </p:nvPr>
+        </p:nvSpPr>
+        <p:spPr>
+          <a:xfrm>
+            <a:off x="472638" y="21742663"/>
+            <a:ext cx="10050600" cy="908100"/>
+          </a:xfrm>
+          <a:prstGeom prst="rect">
+            <a:avLst/>
+          </a:prstGeom>
+          <a:noFill/>
+          <a:ln>
+            <a:noFill/>
+          </a:ln>
+        </p:spPr>
+        <p:txBody>
+          <a:bodyPr anchorCtr="0" anchor="ctr" bIns="91425" lIns="91425" spcFirstLastPara="1" rIns="91425" wrap="square" tIns="91425">
+            <a:spAutoFit/>
+          </a:bodyPr>
+          <a:lstStyle/>
+          <a:p>
+            <a:pPr indent="0" lvl="0" marL="0" rtl="0" algn="ctr">
+              <a:spcBef>
+                <a:spcPts val="0"/>
+              </a:spcBef>
+              <a:spcAft>
+                <a:spcPts val="0"/>
+              </a:spcAft>
+              <a:buClr>
+                <a:srgbClr val="1F3864"/>
+              </a:buClr>
+              <a:buSzPts val="3700"/>
+              <a:buNone/>
+            </a:pPr>
+            <a:r>
+              <a:rPr lang="en-US" sz="4700">
+                <a:solidFill>
+                  <a:schemeClr val="lt1"/>
+                </a:solidFill>
+                <a:latin typeface="Helvetica Neue"/>
+                <a:ea typeface="Helvetica Neue"/>
+                <a:cs typeface="Helvetica Neue"/>
+                <a:sym typeface="Helvetica Neue"/>
+              </a:rPr>
+              <a:t>Changes from last semester</a:t>
+            </a:r>
+            <a:endParaRPr sz="4700">
+              <a:solidFill>
+                <a:schemeClr val="lt1"/>
+              </a:solidFill>
+              <a:latin typeface="Helvetica Neue"/>
+              <a:ea typeface="Helvetica Neue"/>
+              <a:cs typeface="Helvetica Neue"/>
+              <a:sym typeface="Helvetica Neue"/>
+            </a:endParaRPr>
+          </a:p>
+        </p:txBody>
+      </p:sp>
+      <p:pic>
+        <p:nvPicPr>
+          <p:cNvPr id="59" name="Google Shape;59;p1"/>
+          <p:cNvPicPr preferRelativeResize="0"/>
+          <p:nvPr/>
+        </p:nvPicPr>
+        <p:blipFill>
+          <a:blip r:embed="rId5">
+            <a:alphaModFix/>
+          </a:blip>
+          <a:stretch>
+            <a:fillRect/>
+          </a:stretch>
+        </p:blipFill>
+        <p:spPr>
+          <a:xfrm>
+            <a:off x="38112199" y="1322074"/>
+            <a:ext cx="2543175" cy="2543175"/>
+          </a:xfrm>
+          <a:prstGeom prst="rect">
+            <a:avLst/>
+          </a:prstGeom>
+          <a:noFill/>
+          <a:ln>
+            <a:noFill/>
+          </a:ln>
+        </p:spPr>
+      </p:pic>
       <p:pic>
         <p:nvPicPr>
           <p:cNvPr id="60" name="Google Shape;60;p1"/>
@@ -12255,7 +12118,7 @@
         </p:blipFill>
         <p:spPr>
           <a:xfrm>
-            <a:off x="38112199" y="1322074"/>
+            <a:off x="40975425" y="1322073"/>
             <a:ext cx="2543175" cy="2543175"/>
           </a:xfrm>
           <a:prstGeom prst="rect">
@@ -12283,8 +12146,8 @@
         </p:blipFill>
         <p:spPr>
           <a:xfrm>
-            <a:off x="40975425" y="1322073"/>
-            <a:ext cx="2543175" cy="2543175"/>
+            <a:off x="22798838" y="6544675"/>
+            <a:ext cx="1438600" cy="1438600"/>
           </a:xfrm>
           <a:prstGeom prst="rect">
             <a:avLst/>
@@ -12311,8 +12174,8 @@
         </p:blipFill>
         <p:spPr>
           <a:xfrm>
-            <a:off x="22798838" y="6544675"/>
-            <a:ext cx="1438600" cy="1438600"/>
+            <a:off x="24527550" y="6482925"/>
+            <a:ext cx="2543175" cy="1562100"/>
           </a:xfrm>
           <a:prstGeom prst="rect">
             <a:avLst/>
@@ -12329,36 +12192,8 @@
           <p:cNvPicPr preferRelativeResize="0"/>
           <p:nvPr/>
         </p:nvPicPr>
-        <p:blipFill>
+        <p:blipFill rotWithShape="1">
           <a:blip r:embed="rId9">
-            <a:alphaModFix/>
-          </a:blip>
-          <a:stretch>
-            <a:fillRect/>
-          </a:stretch>
-        </p:blipFill>
-        <p:spPr>
-          <a:xfrm>
-            <a:off x="24527550" y="6482925"/>
-            <a:ext cx="2543175" cy="1562100"/>
-          </a:xfrm>
-          <a:prstGeom prst="rect">
-            <a:avLst/>
-          </a:prstGeom>
-          <a:noFill/>
-          <a:ln>
-            <a:noFill/>
-          </a:ln>
-        </p:spPr>
-      </p:pic>
-      <p:pic>
-        <p:nvPicPr>
-          <p:cNvPr id="64" name="Google Shape;64;p1"/>
-          <p:cNvPicPr preferRelativeResize="0"/>
-          <p:nvPr/>
-        </p:nvPicPr>
-        <p:blipFill rotWithShape="1">
-          <a:blip r:embed="rId10">
             <a:alphaModFix/>
           </a:blip>
           <a:srcRect b="0" l="0" r="87635" t="0"/>
@@ -12380,12 +12215,12 @@
       </p:pic>
       <p:pic>
         <p:nvPicPr>
-          <p:cNvPr id="65" name="Google Shape;65;p1"/>
+          <p:cNvPr id="64" name="Google Shape;64;p1"/>
           <p:cNvPicPr preferRelativeResize="0"/>
           <p:nvPr/>
         </p:nvPicPr>
         <p:blipFill rotWithShape="1">
-          <a:blip r:embed="rId11">
+          <a:blip r:embed="rId10">
             <a:alphaModFix/>
           </a:blip>
           <a:srcRect b="16548" l="0" r="48773" t="0"/>
@@ -12395,6 +12230,34 @@
           <a:xfrm>
             <a:off x="28297887" y="6543212"/>
             <a:ext cx="1438600" cy="1441530"/>
+          </a:xfrm>
+          <a:prstGeom prst="rect">
+            <a:avLst/>
+          </a:prstGeom>
+          <a:noFill/>
+          <a:ln>
+            <a:noFill/>
+          </a:ln>
+        </p:spPr>
+      </p:pic>
+      <p:pic>
+        <p:nvPicPr>
+          <p:cNvPr id="65" name="Google Shape;65;p1"/>
+          <p:cNvPicPr preferRelativeResize="0"/>
+          <p:nvPr/>
+        </p:nvPicPr>
+        <p:blipFill>
+          <a:blip r:embed="rId11">
+            <a:alphaModFix/>
+          </a:blip>
+          <a:stretch>
+            <a:fillRect/>
+          </a:stretch>
+        </p:blipFill>
+        <p:spPr>
+          <a:xfrm>
+            <a:off x="29736492" y="6378463"/>
+            <a:ext cx="2003266" cy="1771026"/>
           </a:xfrm>
           <a:prstGeom prst="rect">
             <a:avLst/>
@@ -12421,13 +12284,473 @@
         </p:blipFill>
         <p:spPr>
           <a:xfrm>
-            <a:off x="29736492" y="6378463"/>
-            <a:ext cx="2003266" cy="1771026"/>
+            <a:off x="1358017" y="32003988"/>
+            <a:ext cx="2543175" cy="810462"/>
           </a:xfrm>
           <a:prstGeom prst="rect">
             <a:avLst/>
           </a:prstGeom>
           <a:noFill/>
+          <a:ln>
+            <a:noFill/>
+          </a:ln>
+        </p:spPr>
+      </p:pic>
+      <p:sp>
+        <p:nvSpPr>
+          <p:cNvPr id="67" name="Google Shape;67;p1"/>
+          <p:cNvSpPr txBox="1"/>
+          <p:nvPr>
+            <p:ph idx="8" type="body"/>
+          </p:nvPr>
+        </p:nvSpPr>
+        <p:spPr>
+          <a:xfrm>
+            <a:off x="33405892" y="11745199"/>
+            <a:ext cx="10047000" cy="908100"/>
+          </a:xfrm>
+          <a:prstGeom prst="rect">
+            <a:avLst/>
+          </a:prstGeom>
+          <a:noFill/>
+          <a:ln>
+            <a:noFill/>
+          </a:ln>
+        </p:spPr>
+        <p:txBody>
+          <a:bodyPr anchorCtr="0" anchor="ctr" bIns="91425" lIns="91425" spcFirstLastPara="1" rIns="91425" wrap="square" tIns="91425">
+            <a:spAutoFit/>
+          </a:bodyPr>
+          <a:lstStyle/>
+          <a:p>
+            <a:pPr indent="0" lvl="0" marL="0" rtl="0" algn="ctr">
+              <a:spcBef>
+                <a:spcPts val="0"/>
+              </a:spcBef>
+              <a:spcAft>
+                <a:spcPts val="0"/>
+              </a:spcAft>
+              <a:buClr>
+                <a:srgbClr val="1F3864"/>
+              </a:buClr>
+              <a:buSzPts val="3700"/>
+              <a:buNone/>
+            </a:pPr>
+            <a:r>
+              <a:rPr lang="en-US" sz="4700">
+                <a:solidFill>
+                  <a:schemeClr val="lt1"/>
+                </a:solidFill>
+                <a:latin typeface="Helvetica Neue"/>
+                <a:ea typeface="Helvetica Neue"/>
+                <a:cs typeface="Helvetica Neue"/>
+                <a:sym typeface="Helvetica Neue"/>
+              </a:rPr>
+              <a:t>Backend &amp; API</a:t>
+            </a:r>
+            <a:endParaRPr sz="4700">
+              <a:solidFill>
+                <a:schemeClr val="lt1"/>
+              </a:solidFill>
+              <a:latin typeface="Helvetica Neue"/>
+              <a:ea typeface="Helvetica Neue"/>
+              <a:cs typeface="Helvetica Neue"/>
+              <a:sym typeface="Helvetica Neue"/>
+            </a:endParaRPr>
+          </a:p>
+        </p:txBody>
+      </p:sp>
+      <p:sp>
+        <p:nvSpPr>
+          <p:cNvPr id="68" name="Google Shape;68;p1"/>
+          <p:cNvSpPr txBox="1"/>
+          <p:nvPr>
+            <p:ph idx="9" type="body"/>
+          </p:nvPr>
+        </p:nvSpPr>
+        <p:spPr>
+          <a:xfrm>
+            <a:off x="33387750" y="12622400"/>
+            <a:ext cx="10047000" cy="6926400"/>
+          </a:xfrm>
+          <a:prstGeom prst="rect">
+            <a:avLst/>
+          </a:prstGeom>
+          <a:noFill/>
+          <a:ln>
+            <a:noFill/>
+          </a:ln>
+        </p:spPr>
+        <p:txBody>
+          <a:bodyPr anchorCtr="0" anchor="t" bIns="228575" lIns="228575" spcFirstLastPara="1" rIns="228575" wrap="square" tIns="228575">
+            <a:noAutofit/>
+          </a:bodyPr>
+          <a:lstStyle/>
+          <a:p>
+            <a:pPr indent="-476250" lvl="0" marL="457200" rtl="0" algn="l">
+              <a:lnSpc>
+                <a:spcPct val="115000"/>
+              </a:lnSpc>
+              <a:spcBef>
+                <a:spcPts val="0"/>
+              </a:spcBef>
+              <a:spcAft>
+                <a:spcPts val="0"/>
+              </a:spcAft>
+              <a:buClr>
+                <a:schemeClr val="lt1"/>
+              </a:buClr>
+              <a:buSzPts val="3900"/>
+              <a:buFont typeface="Helvetica Neue"/>
+              <a:buChar char="●"/>
+            </a:pPr>
+            <a:r>
+              <a:rPr lang="en-US" sz="3900">
+                <a:solidFill>
+                  <a:schemeClr val="lt1"/>
+                </a:solidFill>
+                <a:latin typeface="Helvetica Neue"/>
+                <a:ea typeface="Helvetica Neue"/>
+                <a:cs typeface="Helvetica Neue"/>
+                <a:sym typeface="Helvetica Neue"/>
+              </a:rPr>
+              <a:t>Request for assignment goes to API</a:t>
+            </a:r>
+            <a:endParaRPr sz="3900">
+              <a:solidFill>
+                <a:schemeClr val="lt1"/>
+              </a:solidFill>
+              <a:latin typeface="Helvetica Neue"/>
+              <a:ea typeface="Helvetica Neue"/>
+              <a:cs typeface="Helvetica Neue"/>
+              <a:sym typeface="Helvetica Neue"/>
+            </a:endParaRPr>
+          </a:p>
+          <a:p>
+            <a:pPr indent="-476250" lvl="0" marL="457200" rtl="0" algn="l">
+              <a:lnSpc>
+                <a:spcPct val="115000"/>
+              </a:lnSpc>
+              <a:spcBef>
+                <a:spcPts val="0"/>
+              </a:spcBef>
+              <a:spcAft>
+                <a:spcPts val="0"/>
+              </a:spcAft>
+              <a:buClr>
+                <a:schemeClr val="lt1"/>
+              </a:buClr>
+              <a:buSzPts val="3900"/>
+              <a:buFont typeface="Helvetica Neue"/>
+              <a:buChar char="●"/>
+            </a:pPr>
+            <a:r>
+              <a:rPr lang="en-US" sz="3900">
+                <a:solidFill>
+                  <a:schemeClr val="lt1"/>
+                </a:solidFill>
+                <a:latin typeface="Helvetica Neue"/>
+                <a:ea typeface="Helvetica Neue"/>
+                <a:cs typeface="Helvetica Neue"/>
+                <a:sym typeface="Helvetica Neue"/>
+              </a:rPr>
+              <a:t>ExpressJS API used to store files for assignments</a:t>
+            </a:r>
+            <a:endParaRPr sz="3900">
+              <a:solidFill>
+                <a:schemeClr val="lt1"/>
+              </a:solidFill>
+              <a:latin typeface="Helvetica Neue"/>
+              <a:ea typeface="Helvetica Neue"/>
+              <a:cs typeface="Helvetica Neue"/>
+              <a:sym typeface="Helvetica Neue"/>
+            </a:endParaRPr>
+          </a:p>
+          <a:p>
+            <a:pPr indent="-476250" lvl="0" marL="457200" rtl="0" algn="l">
+              <a:lnSpc>
+                <a:spcPct val="115000"/>
+              </a:lnSpc>
+              <a:spcBef>
+                <a:spcPts val="0"/>
+              </a:spcBef>
+              <a:spcAft>
+                <a:spcPts val="0"/>
+              </a:spcAft>
+              <a:buClr>
+                <a:schemeClr val="lt1"/>
+              </a:buClr>
+              <a:buSzPts val="3900"/>
+              <a:buFont typeface="Helvetica Neue"/>
+              <a:buChar char="●"/>
+            </a:pPr>
+            <a:r>
+              <a:rPr lang="en-US" sz="3900">
+                <a:solidFill>
+                  <a:schemeClr val="lt1"/>
+                </a:solidFill>
+                <a:latin typeface="Helvetica Neue"/>
+                <a:ea typeface="Helvetica Neue"/>
+                <a:cs typeface="Helvetica Neue"/>
+                <a:sym typeface="Helvetica Neue"/>
+              </a:rPr>
+              <a:t>Professors can call the API to GET and POST files for their assignments</a:t>
+            </a:r>
+            <a:endParaRPr sz="3900">
+              <a:solidFill>
+                <a:schemeClr val="lt1"/>
+              </a:solidFill>
+              <a:latin typeface="Helvetica Neue"/>
+              <a:ea typeface="Helvetica Neue"/>
+              <a:cs typeface="Helvetica Neue"/>
+              <a:sym typeface="Helvetica Neue"/>
+            </a:endParaRPr>
+          </a:p>
+          <a:p>
+            <a:pPr indent="-476250" lvl="0" marL="457200" rtl="0" algn="l">
+              <a:lnSpc>
+                <a:spcPct val="115000"/>
+              </a:lnSpc>
+              <a:spcBef>
+                <a:spcPts val="0"/>
+              </a:spcBef>
+              <a:spcAft>
+                <a:spcPts val="0"/>
+              </a:spcAft>
+              <a:buClr>
+                <a:schemeClr val="lt1"/>
+              </a:buClr>
+              <a:buSzPts val="3900"/>
+              <a:buFont typeface="Helvetica Neue"/>
+              <a:buChar char="●"/>
+            </a:pPr>
+            <a:r>
+              <a:rPr lang="en-US" sz="3900">
+                <a:solidFill>
+                  <a:schemeClr val="lt1"/>
+                </a:solidFill>
+                <a:latin typeface="Helvetica Neue"/>
+                <a:ea typeface="Helvetica Neue"/>
+                <a:cs typeface="Helvetica Neue"/>
+                <a:sym typeface="Helvetica Neue"/>
+              </a:rPr>
+              <a:t>Assignment is retrieved from API</a:t>
+            </a:r>
+            <a:endParaRPr sz="3900">
+              <a:solidFill>
+                <a:schemeClr val="lt1"/>
+              </a:solidFill>
+              <a:latin typeface="Helvetica Neue"/>
+              <a:ea typeface="Helvetica Neue"/>
+              <a:cs typeface="Helvetica Neue"/>
+              <a:sym typeface="Helvetica Neue"/>
+            </a:endParaRPr>
+          </a:p>
+          <a:p>
+            <a:pPr indent="-476250" lvl="0" marL="457200" rtl="0" algn="l">
+              <a:lnSpc>
+                <a:spcPct val="115000"/>
+              </a:lnSpc>
+              <a:spcBef>
+                <a:spcPts val="0"/>
+              </a:spcBef>
+              <a:spcAft>
+                <a:spcPts val="0"/>
+              </a:spcAft>
+              <a:buClr>
+                <a:schemeClr val="lt1"/>
+              </a:buClr>
+              <a:buSzPts val="3900"/>
+              <a:buFont typeface="Helvetica Neue"/>
+              <a:buChar char="●"/>
+            </a:pPr>
+            <a:r>
+              <a:rPr lang="en-US" sz="3900">
+                <a:solidFill>
+                  <a:schemeClr val="lt1"/>
+                </a:solidFill>
+                <a:latin typeface="Helvetica Neue"/>
+                <a:ea typeface="Helvetica Neue"/>
+                <a:cs typeface="Helvetica Neue"/>
+                <a:sym typeface="Helvetica Neue"/>
+              </a:rPr>
+              <a:t>Student code is run through a json config interpreter made in Go  </a:t>
+            </a:r>
+            <a:endParaRPr sz="3900">
+              <a:solidFill>
+                <a:schemeClr val="lt1"/>
+              </a:solidFill>
+              <a:latin typeface="Helvetica Neue"/>
+              <a:ea typeface="Helvetica Neue"/>
+              <a:cs typeface="Helvetica Neue"/>
+              <a:sym typeface="Helvetica Neue"/>
+            </a:endParaRPr>
+          </a:p>
+          <a:p>
+            <a:pPr indent="-476250" lvl="0" marL="457200" rtl="0" algn="l">
+              <a:lnSpc>
+                <a:spcPct val="115000"/>
+              </a:lnSpc>
+              <a:spcBef>
+                <a:spcPts val="0"/>
+              </a:spcBef>
+              <a:spcAft>
+                <a:spcPts val="0"/>
+              </a:spcAft>
+              <a:buClr>
+                <a:schemeClr val="lt1"/>
+              </a:buClr>
+              <a:buSzPts val="3900"/>
+              <a:buFont typeface="Helvetica Neue"/>
+              <a:buChar char="●"/>
+            </a:pPr>
+            <a:r>
+              <a:rPr lang="en-US" sz="3900">
+                <a:solidFill>
+                  <a:schemeClr val="lt1"/>
+                </a:solidFill>
+                <a:latin typeface="Helvetica Neue"/>
+                <a:ea typeface="Helvetica Neue"/>
+                <a:cs typeface="Helvetica Neue"/>
+                <a:sym typeface="Helvetica Neue"/>
+              </a:rPr>
+              <a:t>Checked for compliance with the rules in the json retrieved from the API.</a:t>
+            </a:r>
+            <a:endParaRPr sz="3900">
+              <a:solidFill>
+                <a:schemeClr val="lt1"/>
+              </a:solidFill>
+              <a:latin typeface="Helvetica Neue"/>
+              <a:ea typeface="Helvetica Neue"/>
+              <a:cs typeface="Helvetica Neue"/>
+              <a:sym typeface="Helvetica Neue"/>
+            </a:endParaRPr>
+          </a:p>
+        </p:txBody>
+      </p:sp>
+      <p:pic>
+        <p:nvPicPr>
+          <p:cNvPr id="69" name="Google Shape;69;p1"/>
+          <p:cNvPicPr preferRelativeResize="0"/>
+          <p:nvPr/>
+        </p:nvPicPr>
+        <p:blipFill>
+          <a:blip r:embed="rId13">
+            <a:alphaModFix/>
+          </a:blip>
+          <a:stretch>
+            <a:fillRect/>
+          </a:stretch>
+        </p:blipFill>
+        <p:spPr>
+          <a:xfrm>
+            <a:off x="11916127" y="18467513"/>
+            <a:ext cx="10047000" cy="5651451"/>
+          </a:xfrm>
+          <a:prstGeom prst="rect">
+            <a:avLst/>
+          </a:prstGeom>
+          <a:solidFill>
+            <a:srgbClr val="8C8C8C">
+              <a:alpha val="70890"/>
+            </a:srgbClr>
+          </a:solidFill>
+          <a:ln>
+            <a:noFill/>
+          </a:ln>
+        </p:spPr>
+      </p:pic>
+      <p:pic>
+        <p:nvPicPr>
+          <p:cNvPr id="70" name="Google Shape;70;p1"/>
+          <p:cNvPicPr preferRelativeResize="0"/>
+          <p:nvPr/>
+        </p:nvPicPr>
+        <p:blipFill>
+          <a:blip r:embed="rId14">
+            <a:alphaModFix/>
+          </a:blip>
+          <a:stretch>
+            <a:fillRect/>
+          </a:stretch>
+        </p:blipFill>
+        <p:spPr>
+          <a:xfrm>
+            <a:off x="22169588" y="18480100"/>
+            <a:ext cx="10047014" cy="5651451"/>
+          </a:xfrm>
+          <a:prstGeom prst="rect">
+            <a:avLst/>
+          </a:prstGeom>
+          <a:solidFill>
+            <a:srgbClr val="8C8C8C">
+              <a:alpha val="70890"/>
+            </a:srgbClr>
+          </a:solidFill>
+          <a:ln>
+            <a:noFill/>
+          </a:ln>
+        </p:spPr>
+      </p:pic>
+      <p:pic>
+        <p:nvPicPr>
+          <p:cNvPr id="71" name="Google Shape;71;p1"/>
+          <p:cNvPicPr preferRelativeResize="0"/>
+          <p:nvPr/>
+        </p:nvPicPr>
+        <p:blipFill>
+          <a:blip r:embed="rId15">
+            <a:alphaModFix/>
+          </a:blip>
+          <a:stretch>
+            <a:fillRect/>
+          </a:stretch>
+        </p:blipFill>
+        <p:spPr>
+          <a:xfrm>
+            <a:off x="11910425" y="24286425"/>
+            <a:ext cx="10058400" cy="5657839"/>
+          </a:xfrm>
+          <a:prstGeom prst="rect">
+            <a:avLst/>
+          </a:prstGeom>
+          <a:solidFill>
+            <a:srgbClr val="8C8C8C">
+              <a:alpha val="70890"/>
+            </a:srgbClr>
+          </a:solidFill>
+          <a:ln>
+            <a:noFill/>
+          </a:ln>
+        </p:spPr>
+      </p:pic>
+      <p:pic>
+        <p:nvPicPr>
+          <p:cNvPr id="72" name="Google Shape;72;p1"/>
+          <p:cNvPicPr preferRelativeResize="0"/>
+          <p:nvPr/>
+        </p:nvPicPr>
+        <p:blipFill>
+          <a:blip r:embed="rId16">
+            <a:alphaModFix/>
+          </a:blip>
+          <a:stretch>
+            <a:fillRect/>
+          </a:stretch>
+        </p:blipFill>
+        <p:spPr>
+          <a:xfrm>
+            <a:off x="22171919" y="24289632"/>
+            <a:ext cx="10047000" cy="5651438"/>
+          </a:xfrm>
+          <a:prstGeom prst="rect">
+            <a:avLst/>
+          </a:prstGeom>
+          <a:solidFill>
+            <a:srgbClr val="8C8C8C">
+              <a:alpha val="70890"/>
+            </a:srgbClr>
+          </a:solidFill>
           <a:ln>
             <a:noFill/>
           </a:ln>
@@ -12442,6 +12765,285 @@
 </file>
 
 <file path=ppt/theme/theme1.xml><?xml version="1.0" encoding="utf-8"?>
+<a:theme xmlns:a="http://schemas.openxmlformats.org/drawingml/2006/main" xmlns:r="http://schemas.openxmlformats.org/officeDocument/2006/relationships" name="36x48-Template">
+  <a:themeElements>
+    <a:clrScheme name="Office">
+      <a:dk1>
+        <a:srgbClr val="000000"/>
+      </a:dk1>
+      <a:lt1>
+        <a:srgbClr val="FFFFFF"/>
+      </a:lt1>
+      <a:dk2>
+        <a:srgbClr val="44546A"/>
+      </a:dk2>
+      <a:lt2>
+        <a:srgbClr val="E7E6E6"/>
+      </a:lt2>
+      <a:accent1>
+        <a:srgbClr val="5B9BD5"/>
+      </a:accent1>
+      <a:accent2>
+        <a:srgbClr val="ED7D31"/>
+      </a:accent2>
+      <a:accent3>
+        <a:srgbClr val="A5A5A5"/>
+      </a:accent3>
+      <a:accent4>
+        <a:srgbClr val="FFC000"/>
+      </a:accent4>
+      <a:accent5>
+        <a:srgbClr val="4472C4"/>
+      </a:accent5>
+      <a:accent6>
+        <a:srgbClr val="70AD47"/>
+      </a:accent6>
+      <a:hlink>
+        <a:srgbClr val="0563C1"/>
+      </a:hlink>
+      <a:folHlink>
+        <a:srgbClr val="954F72"/>
+      </a:folHlink>
+    </a:clrScheme>
+    <a:fontScheme name="Office">
+      <a:majorFont>
+        <a:latin typeface="Arial"/>
+        <a:ea typeface=""/>
+        <a:cs typeface=""/>
+        <a:font script="Jpan" typeface="ＭＳ Ｐゴシック"/>
+        <a:font script="Hang" typeface="맑은 고딕"/>
+        <a:font script="Hans" typeface="宋体"/>
+        <a:font script="Hant" typeface="新細明體"/>
+        <a:font script="Arab" typeface="Times New Roman"/>
+        <a:font script="Hebr" typeface="Times New Roman"/>
+        <a:font script="Thai" typeface="Angsana New"/>
+        <a:font script="Ethi" typeface="Nyala"/>
+        <a:font script="Beng" typeface="Vrinda"/>
+        <a:font script="Gujr" typeface="Shruti"/>
+        <a:font script="Khmr" typeface="MoolBoran"/>
+        <a:font script="Knda" typeface="Tunga"/>
+        <a:font script="Guru" typeface="Raavi"/>
+        <a:font script="Cans" typeface="Euphemia"/>
+        <a:font script="Cher" typeface="Plantagenet Cherokee"/>
+        <a:font script="Yiii" typeface="Microsoft Yi Baiti"/>
+        <a:font script="Tibt" typeface="Microsoft Himalaya"/>
+        <a:font script="Thaa" typeface="MV Boli"/>
+        <a:font script="Deva" typeface="Mangal"/>
+        <a:font script="Telu" typeface="Gautami"/>
+        <a:font script="Taml" typeface="Latha"/>
+        <a:font script="Syrc" typeface="Estrangelo Edessa"/>
+        <a:font script="Orya" typeface="Kalinga"/>
+        <a:font script="Mlym" typeface="Kartika"/>
+        <a:font script="Laoo" typeface="DokChampa"/>
+        <a:font script="Sinh" typeface="Iskoola Pota"/>
+        <a:font script="Mong" typeface="Mongolian Baiti"/>
+        <a:font script="Viet" typeface="Times New Roman"/>
+        <a:font script="Uigh" typeface="Microsoft Uighur"/>
+        <a:font script="Geor" typeface="Sylfaen"/>
+      </a:majorFont>
+      <a:minorFont>
+        <a:latin typeface="Arial"/>
+        <a:ea typeface=""/>
+        <a:cs typeface=""/>
+        <a:font script="Jpan" typeface="ＭＳ Ｐゴシック"/>
+        <a:font script="Hang" typeface="맑은 고딕"/>
+        <a:font script="Hans" typeface="宋体"/>
+        <a:font script="Hant" typeface="新細明體"/>
+        <a:font script="Arab" typeface="Arial"/>
+        <a:font script="Hebr" typeface="Arial"/>
+        <a:font script="Thai" typeface="Cordia New"/>
+        <a:font script="Ethi" typeface="Nyala"/>
+        <a:font script="Beng" typeface="Vrinda"/>
+        <a:font script="Gujr" typeface="Shruti"/>
+        <a:font script="Khmr" typeface="DaunPenh"/>
+        <a:font script="Knda" typeface="Tunga"/>
+        <a:font script="Guru" typeface="Raavi"/>
+        <a:font script="Cans" typeface="Euphemia"/>
+        <a:font script="Cher" typeface="Plantagenet Cherokee"/>
+        <a:font script="Yiii" typeface="Microsoft Yi Baiti"/>
+        <a:font script="Tibt" typeface="Microsoft Himalaya"/>
+        <a:font script="Thaa" typeface="MV Boli"/>
+        <a:font script="Deva" typeface="Mangal"/>
+        <a:font script="Telu" typeface="Gautami"/>
+        <a:font script="Taml" typeface="Latha"/>
+        <a:font script="Syrc" typeface="Estrangelo Edessa"/>
+        <a:font script="Orya" typeface="Kalinga"/>
+        <a:font script="Mlym" typeface="Kartika"/>
+        <a:font script="Laoo" typeface="DokChampa"/>
+        <a:font script="Sinh" typeface="Iskoola Pota"/>
+        <a:font script="Mong" typeface="Mongolian Baiti"/>
+        <a:font script="Viet" typeface="Arial"/>
+        <a:font script="Uigh" typeface="Microsoft Uighur"/>
+        <a:font script="Geor" typeface="Sylfaen"/>
+      </a:minorFont>
+    </a:fontScheme>
+    <a:fmtScheme name="Office">
+      <a:fillStyleLst>
+        <a:solidFill>
+          <a:schemeClr val="phClr"/>
+        </a:solidFill>
+        <a:gradFill rotWithShape="1">
+          <a:gsLst>
+            <a:gs pos="0">
+              <a:schemeClr val="phClr">
+                <a:tint val="50000"/>
+                <a:satMod val="300000"/>
+              </a:schemeClr>
+            </a:gs>
+            <a:gs pos="35000">
+              <a:schemeClr val="phClr">
+                <a:tint val="37000"/>
+                <a:satMod val="300000"/>
+              </a:schemeClr>
+            </a:gs>
+            <a:gs pos="100000">
+              <a:schemeClr val="phClr">
+                <a:tint val="15000"/>
+                <a:satMod val="350000"/>
+              </a:schemeClr>
+            </a:gs>
+          </a:gsLst>
+          <a:lin ang="16200000" scaled="1"/>
+        </a:gradFill>
+        <a:gradFill rotWithShape="1">
+          <a:gsLst>
+            <a:gs pos="0">
+              <a:schemeClr val="phClr">
+                <a:tint val="100000"/>
+                <a:shade val="100000"/>
+                <a:satMod val="130000"/>
+              </a:schemeClr>
+            </a:gs>
+            <a:gs pos="100000">
+              <a:schemeClr val="phClr">
+                <a:tint val="50000"/>
+                <a:shade val="100000"/>
+                <a:satMod val="350000"/>
+              </a:schemeClr>
+            </a:gs>
+          </a:gsLst>
+          <a:lin ang="16200000" scaled="0"/>
+        </a:gradFill>
+      </a:fillStyleLst>
+      <a:lnStyleLst>
+        <a:ln w="9525" cap="flat" cmpd="sng" algn="ctr">
+          <a:solidFill>
+            <a:schemeClr val="phClr">
+              <a:shade val="95000"/>
+              <a:satMod val="105000"/>
+            </a:schemeClr>
+          </a:solidFill>
+          <a:prstDash val="solid"/>
+        </a:ln>
+        <a:ln w="25400" cap="flat" cmpd="sng" algn="ctr">
+          <a:solidFill>
+            <a:schemeClr val="phClr"/>
+          </a:solidFill>
+          <a:prstDash val="solid"/>
+        </a:ln>
+        <a:ln w="38100" cap="flat" cmpd="sng" algn="ctr">
+          <a:solidFill>
+            <a:schemeClr val="phClr"/>
+          </a:solidFill>
+          <a:prstDash val="solid"/>
+        </a:ln>
+      </a:lnStyleLst>
+      <a:effectStyleLst>
+        <a:effectStyle>
+          <a:effectLst>
+            <a:outerShdw blurRad="40000" dist="20000" dir="5400000" rotWithShape="0">
+              <a:srgbClr val="000000">
+                <a:alpha val="38000"/>
+              </a:srgbClr>
+            </a:outerShdw>
+          </a:effectLst>
+        </a:effectStyle>
+        <a:effectStyle>
+          <a:effectLst>
+            <a:outerShdw blurRad="40000" dist="23000" dir="5400000" rotWithShape="0">
+              <a:srgbClr val="000000">
+                <a:alpha val="35000"/>
+              </a:srgbClr>
+            </a:outerShdw>
+          </a:effectLst>
+        </a:effectStyle>
+        <a:effectStyle>
+          <a:effectLst>
+            <a:outerShdw blurRad="40000" dist="23000" dir="5400000" rotWithShape="0">
+              <a:srgbClr val="000000">
+                <a:alpha val="35000"/>
+              </a:srgbClr>
+            </a:outerShdw>
+          </a:effectLst>
+          <a:scene3d>
+            <a:camera prst="orthographicFront">
+              <a:rot lat="0" lon="0" rev="0"/>
+            </a:camera>
+            <a:lightRig rig="threePt" dir="t">
+              <a:rot lat="0" lon="0" rev="1200000"/>
+            </a:lightRig>
+          </a:scene3d>
+          <a:sp3d>
+            <a:bevelT w="63500" h="25400"/>
+          </a:sp3d>
+        </a:effectStyle>
+      </a:effectStyleLst>
+      <a:bgFillStyleLst>
+        <a:solidFill>
+          <a:schemeClr val="phClr"/>
+        </a:solidFill>
+        <a:gradFill rotWithShape="1">
+          <a:gsLst>
+            <a:gs pos="0">
+              <a:schemeClr val="phClr">
+                <a:tint val="40000"/>
+                <a:satMod val="350000"/>
+              </a:schemeClr>
+            </a:gs>
+            <a:gs pos="40000">
+              <a:schemeClr val="phClr">
+                <a:tint val="45000"/>
+                <a:shade val="99000"/>
+                <a:satMod val="350000"/>
+              </a:schemeClr>
+            </a:gs>
+            <a:gs pos="100000">
+              <a:schemeClr val="phClr">
+                <a:shade val="20000"/>
+                <a:satMod val="255000"/>
+              </a:schemeClr>
+            </a:gs>
+          </a:gsLst>
+          <a:path path="circle">
+            <a:fillToRect l="50000" t="-80000" r="50000" b="180000"/>
+          </a:path>
+        </a:gradFill>
+        <a:gradFill rotWithShape="1">
+          <a:gsLst>
+            <a:gs pos="0">
+              <a:schemeClr val="phClr">
+                <a:tint val="80000"/>
+                <a:satMod val="300000"/>
+              </a:schemeClr>
+            </a:gs>
+            <a:gs pos="100000">
+              <a:schemeClr val="phClr">
+                <a:shade val="30000"/>
+                <a:satMod val="200000"/>
+              </a:schemeClr>
+            </a:gs>
+          </a:gsLst>
+          <a:path path="circle">
+            <a:fillToRect l="50000" t="50000" r="50000" b="50000"/>
+          </a:path>
+        </a:gradFill>
+      </a:bgFillStyleLst>
+    </a:fmtScheme>
+  </a:themeElements>
+</a:theme>
+</file>
+
+<file path=ppt/theme/theme2.xml><?xml version="1.0" encoding="utf-8"?>
 <a:theme xmlns:a="http://schemas.openxmlformats.org/drawingml/2006/main" xmlns:r="http://schemas.openxmlformats.org/officeDocument/2006/relationships" name="Office Theme">
   <a:themeElements>
     <a:clrScheme name="Office">
@@ -12718,283 +13320,4 @@
     </a:fmtScheme>
   </a:themeElements>
 </a:theme>
-</file>
-
-<file path=ppt/theme/theme2.xml><?xml version="1.0" encoding="utf-8"?>
-<a:theme xmlns:a="http://schemas.openxmlformats.org/drawingml/2006/main" xmlns:r="http://schemas.openxmlformats.org/officeDocument/2006/relationships" name="36x48-Template">
-  <a:themeElements>
-    <a:clrScheme name="Office">
-      <a:dk1>
-        <a:srgbClr val="000000"/>
-      </a:dk1>
-      <a:lt1>
-        <a:srgbClr val="FFFFFF"/>
-      </a:lt1>
-      <a:dk2>
-        <a:srgbClr val="44546A"/>
-      </a:dk2>
-      <a:lt2>
-        <a:srgbClr val="E7E6E6"/>
-      </a:lt2>
-      <a:accent1>
-        <a:srgbClr val="5B9BD5"/>
-      </a:accent1>
-      <a:accent2>
-        <a:srgbClr val="ED7D31"/>
-      </a:accent2>
-      <a:accent3>
-        <a:srgbClr val="A5A5A5"/>
-      </a:accent3>
-      <a:accent4>
-        <a:srgbClr val="FFC000"/>
-      </a:accent4>
-      <a:accent5>
-        <a:srgbClr val="4472C4"/>
-      </a:accent5>
-      <a:accent6>
-        <a:srgbClr val="70AD47"/>
-      </a:accent6>
-      <a:hlink>
-        <a:srgbClr val="0563C1"/>
-      </a:hlink>
-      <a:folHlink>
-        <a:srgbClr val="954F72"/>
-      </a:folHlink>
-    </a:clrScheme>
-    <a:fontScheme name="Office">
-      <a:majorFont>
-        <a:latin typeface="Arial"/>
-        <a:ea typeface=""/>
-        <a:cs typeface=""/>
-        <a:font script="Jpan" typeface="ＭＳ Ｐゴシック"/>
-        <a:font script="Hang" typeface="맑은 고딕"/>
-        <a:font script="Hans" typeface="宋体"/>
-        <a:font script="Hant" typeface="新細明體"/>
-        <a:font script="Arab" typeface="Times New Roman"/>
-        <a:font script="Hebr" typeface="Times New Roman"/>
-        <a:font script="Thai" typeface="Angsana New"/>
-        <a:font script="Ethi" typeface="Nyala"/>
-        <a:font script="Beng" typeface="Vrinda"/>
-        <a:font script="Gujr" typeface="Shruti"/>
-        <a:font script="Khmr" typeface="MoolBoran"/>
-        <a:font script="Knda" typeface="Tunga"/>
-        <a:font script="Guru" typeface="Raavi"/>
-        <a:font script="Cans" typeface="Euphemia"/>
-        <a:font script="Cher" typeface="Plantagenet Cherokee"/>
-        <a:font script="Yiii" typeface="Microsoft Yi Baiti"/>
-        <a:font script="Tibt" typeface="Microsoft Himalaya"/>
-        <a:font script="Thaa" typeface="MV Boli"/>
-        <a:font script="Deva" typeface="Mangal"/>
-        <a:font script="Telu" typeface="Gautami"/>
-        <a:font script="Taml" typeface="Latha"/>
-        <a:font script="Syrc" typeface="Estrangelo Edessa"/>
-        <a:font script="Orya" typeface="Kalinga"/>
-        <a:font script="Mlym" typeface="Kartika"/>
-        <a:font script="Laoo" typeface="DokChampa"/>
-        <a:font script="Sinh" typeface="Iskoola Pota"/>
-        <a:font script="Mong" typeface="Mongolian Baiti"/>
-        <a:font script="Viet" typeface="Times New Roman"/>
-        <a:font script="Uigh" typeface="Microsoft Uighur"/>
-        <a:font script="Geor" typeface="Sylfaen"/>
-      </a:majorFont>
-      <a:minorFont>
-        <a:latin typeface="Arial"/>
-        <a:ea typeface=""/>
-        <a:cs typeface=""/>
-        <a:font script="Jpan" typeface="ＭＳ Ｐゴシック"/>
-        <a:font script="Hang" typeface="맑은 고딕"/>
-        <a:font script="Hans" typeface="宋体"/>
-        <a:font script="Hant" typeface="新細明體"/>
-        <a:font script="Arab" typeface="Arial"/>
-        <a:font script="Hebr" typeface="Arial"/>
-        <a:font script="Thai" typeface="Cordia New"/>
-        <a:font script="Ethi" typeface="Nyala"/>
-        <a:font script="Beng" typeface="Vrinda"/>
-        <a:font script="Gujr" typeface="Shruti"/>
-        <a:font script="Khmr" typeface="DaunPenh"/>
-        <a:font script="Knda" typeface="Tunga"/>
-        <a:font script="Guru" typeface="Raavi"/>
-        <a:font script="Cans" typeface="Euphemia"/>
-        <a:font script="Cher" typeface="Plantagenet Cherokee"/>
-        <a:font script="Yiii" typeface="Microsoft Yi Baiti"/>
-        <a:font script="Tibt" typeface="Microsoft Himalaya"/>
-        <a:font script="Thaa" typeface="MV Boli"/>
-        <a:font script="Deva" typeface="Mangal"/>
-        <a:font script="Telu" typeface="Gautami"/>
-        <a:font script="Taml" typeface="Latha"/>
-        <a:font script="Syrc" typeface="Estrangelo Edessa"/>
-        <a:font script="Orya" typeface="Kalinga"/>
-        <a:font script="Mlym" typeface="Kartika"/>
-        <a:font script="Laoo" typeface="DokChampa"/>
-        <a:font script="Sinh" typeface="Iskoola Pota"/>
-        <a:font script="Mong" typeface="Mongolian Baiti"/>
-        <a:font script="Viet" typeface="Arial"/>
-        <a:font script="Uigh" typeface="Microsoft Uighur"/>
-        <a:font script="Geor" typeface="Sylfaen"/>
-      </a:minorFont>
-    </a:fontScheme>
-    <a:fmtScheme name="Office">
-      <a:fillStyleLst>
-        <a:solidFill>
-          <a:schemeClr val="phClr"/>
-        </a:solidFill>
-        <a:gradFill rotWithShape="1">
-          <a:gsLst>
-            <a:gs pos="0">
-              <a:schemeClr val="phClr">
-                <a:tint val="50000"/>
-                <a:satMod val="300000"/>
-              </a:schemeClr>
-            </a:gs>
-            <a:gs pos="35000">
-              <a:schemeClr val="phClr">
-                <a:tint val="37000"/>
-                <a:satMod val="300000"/>
-              </a:schemeClr>
-            </a:gs>
-            <a:gs pos="100000">
-              <a:schemeClr val="phClr">
-                <a:tint val="15000"/>
-                <a:satMod val="350000"/>
-              </a:schemeClr>
-            </a:gs>
-          </a:gsLst>
-          <a:lin ang="16200000" scaled="1"/>
-        </a:gradFill>
-        <a:gradFill rotWithShape="1">
-          <a:gsLst>
-            <a:gs pos="0">
-              <a:schemeClr val="phClr">
-                <a:tint val="100000"/>
-                <a:shade val="100000"/>
-                <a:satMod val="130000"/>
-              </a:schemeClr>
-            </a:gs>
-            <a:gs pos="100000">
-              <a:schemeClr val="phClr">
-                <a:tint val="50000"/>
-                <a:shade val="100000"/>
-                <a:satMod val="350000"/>
-              </a:schemeClr>
-            </a:gs>
-          </a:gsLst>
-          <a:lin ang="16200000" scaled="0"/>
-        </a:gradFill>
-      </a:fillStyleLst>
-      <a:lnStyleLst>
-        <a:ln w="9525" cap="flat" cmpd="sng" algn="ctr">
-          <a:solidFill>
-            <a:schemeClr val="phClr">
-              <a:shade val="95000"/>
-              <a:satMod val="105000"/>
-            </a:schemeClr>
-          </a:solidFill>
-          <a:prstDash val="solid"/>
-        </a:ln>
-        <a:ln w="25400" cap="flat" cmpd="sng" algn="ctr">
-          <a:solidFill>
-            <a:schemeClr val="phClr"/>
-          </a:solidFill>
-          <a:prstDash val="solid"/>
-        </a:ln>
-        <a:ln w="38100" cap="flat" cmpd="sng" algn="ctr">
-          <a:solidFill>
-            <a:schemeClr val="phClr"/>
-          </a:solidFill>
-          <a:prstDash val="solid"/>
-        </a:ln>
-      </a:lnStyleLst>
-      <a:effectStyleLst>
-        <a:effectStyle>
-          <a:effectLst>
-            <a:outerShdw blurRad="40000" dist="20000" dir="5400000" rotWithShape="0">
-              <a:srgbClr val="000000">
-                <a:alpha val="38000"/>
-              </a:srgbClr>
-            </a:outerShdw>
-          </a:effectLst>
-        </a:effectStyle>
-        <a:effectStyle>
-          <a:effectLst>
-            <a:outerShdw blurRad="40000" dist="23000" dir="5400000" rotWithShape="0">
-              <a:srgbClr val="000000">
-                <a:alpha val="35000"/>
-              </a:srgbClr>
-            </a:outerShdw>
-          </a:effectLst>
-        </a:effectStyle>
-        <a:effectStyle>
-          <a:effectLst>
-            <a:outerShdw blurRad="40000" dist="23000" dir="5400000" rotWithShape="0">
-              <a:srgbClr val="000000">
-                <a:alpha val="35000"/>
-              </a:srgbClr>
-            </a:outerShdw>
-          </a:effectLst>
-          <a:scene3d>
-            <a:camera prst="orthographicFront">
-              <a:rot lat="0" lon="0" rev="0"/>
-            </a:camera>
-            <a:lightRig rig="threePt" dir="t">
-              <a:rot lat="0" lon="0" rev="1200000"/>
-            </a:lightRig>
-          </a:scene3d>
-          <a:sp3d>
-            <a:bevelT w="63500" h="25400"/>
-          </a:sp3d>
-        </a:effectStyle>
-      </a:effectStyleLst>
-      <a:bgFillStyleLst>
-        <a:solidFill>
-          <a:schemeClr val="phClr"/>
-        </a:solidFill>
-        <a:gradFill rotWithShape="1">
-          <a:gsLst>
-            <a:gs pos="0">
-              <a:schemeClr val="phClr">
-                <a:tint val="40000"/>
-                <a:satMod val="350000"/>
-              </a:schemeClr>
-            </a:gs>
-            <a:gs pos="40000">
-              <a:schemeClr val="phClr">
-                <a:tint val="45000"/>
-                <a:shade val="99000"/>
-                <a:satMod val="350000"/>
-              </a:schemeClr>
-            </a:gs>
-            <a:gs pos="100000">
-              <a:schemeClr val="phClr">
-                <a:shade val="20000"/>
-                <a:satMod val="255000"/>
-              </a:schemeClr>
-            </a:gs>
-          </a:gsLst>
-          <a:path path="circle">
-            <a:fillToRect l="50000" t="-80000" r="50000" b="180000"/>
-          </a:path>
-        </a:gradFill>
-        <a:gradFill rotWithShape="1">
-          <a:gsLst>
-            <a:gs pos="0">
-              <a:schemeClr val="phClr">
-                <a:tint val="80000"/>
-                <a:satMod val="300000"/>
-              </a:schemeClr>
-            </a:gs>
-            <a:gs pos="100000">
-              <a:schemeClr val="phClr">
-                <a:shade val="30000"/>
-                <a:satMod val="200000"/>
-              </a:schemeClr>
-            </a:gs>
-          </a:gsLst>
-          <a:path path="circle">
-            <a:fillToRect l="50000" t="50000" r="50000" b="50000"/>
-          </a:path>
-        </a:gradFill>
-      </a:bgFillStyleLst>
-    </a:fmtScheme>
-  </a:themeElements>
-</a:theme>
 </file>
</xml_diff>